<commit_message>
docs(presentacion): se quita Docker de la presentacion (ADR-007)
Las diapositivas 8 y 11 y la nota de la 8 describen el entorno con LocalDB.

Co-Authored-By: Claude Haiku 5.5 <noreply@anthropic.com>
</commit_message>
<xml_diff>
--- a/docs/presentacion.pptx
+++ b/docs/presentacion.pptx
@@ -1675,7 +1675,7 @@
           <a:p>
             <a:r>
               <a:rPr lang="en-US" dirty="0"/>
-              <a:t>Pruebas y calidad (1 min). 119 pruebas: 84 de integración contra un SQL Server real, con una base propia que se crea y se borra; 25 de dominio y 10 de la web. Rendimiento medido con 26 000 OT: 47 milisegundos y 23 KB por página. Digo también lo que no verifiqué: Docker no lo pude ejecutar.</a:t>
+              <a:t>Pruebas y calidad (1 min). 119 pruebas: 84 de integración contra un SQL Server real, con una base propia que se crea y se borra; 25 de dominio y 10 de la web. Rendimiento medido con 26 000 OT: 47 milisegundos y 23 KB por página. Digo también lo que no usamos: Docker no se usa en el proyecto (ADR-007).</a:t>
             </a:r>
             <a:endParaRPr lang="en-US" dirty="0"/>
           </a:p>
@@ -3995,7 +3995,7 @@
                   <a:schemeClr val="tx1"/>
                 </a:solidFill>
               </a:rPr>
-              <a:t>Ejecutar el Docker Compose</a:t>
+              <a:t>Presentación en vivo con LocalDB (sin Docker, ADR-007)</a:t>
             </a:r>
             <a:endParaRPr lang="en-US" sz="1500" dirty="0"/>
           </a:p>
@@ -9724,7 +9724,7 @@
                   <a:schemeClr val="tx1"/>
                 </a:solidFill>
               </a:rPr>
-              <a:t>Docker Compose escrito, sin ejecutar (no hay Docker en el equipo)</a:t>
+              <a:t>Sin Docker: ejecución con SQL Server local o LocalDB (ADR-007)</a:t>
             </a:r>
             <a:endParaRPr lang="en-US" sz="1400" dirty="0"/>
           </a:p>

</xml_diff>

<commit_message>
docs(presentacion): version 1.2 de 13 diapositivas y guion de la demo alineado
- Presentacion: ADR-007, 121 pruebas, 16 evidencias, 35 reglas,
  diapositiva nueva de prompt y diff (RF-07), demo de 5 minutos con
  Swagger, edicion y exportacion; cifras de la diapositiva 2 alineadas
  con el analisis (672 filas; pantallas sin sesion); portada del
  responsable. Revisada con el checklist 42 v1.1.
- Guion: paso 0 Swagger, paso de edicion, especialista sin planning,
  plan B con capturas y preguntas sobre Docker, fallo intermitente y RN-37.

Co-Authored-By: Claude Opus 5.5 <noreply@anthropic.com>
</commit_message>
<xml_diff>
--- a/docs/presentacion.pptx
+++ b/docs/presentacion.pptx
@@ -4,6 +4,9 @@
   <p:sldMasterIdLst>
     <p:sldMasterId id="2147483648" r:id="rId1"/>
   </p:sldMasterIdLst>
+  <p:notesMasterIdLst>
+    <p:notesMasterId r:id="rId15"/>
+  </p:notesMasterIdLst>
   <p:sldIdLst>
     <p:sldId id="256" r:id="rId2"/>
     <p:sldId id="257" r:id="rId3"/>
@@ -14,13 +17,11 @@
     <p:sldId id="262" r:id="rId8"/>
     <p:sldId id="263" r:id="rId9"/>
     <p:sldId id="264" r:id="rId10"/>
-    <p:sldId id="265" r:id="rId11"/>
-    <p:sldId id="266" r:id="rId12"/>
-    <p:sldId id="267" r:id="rId13"/>
+    <p:sldId id="268" r:id="rId11"/>
+    <p:sldId id="265" r:id="rId12"/>
+    <p:sldId id="266" r:id="rId13"/>
+    <p:sldId id="267" r:id="rId14"/>
   </p:sldIdLst>
-  <p:notesMasterIdLst>
-    <p:notesMasterId r:id="rId14"/>
-  </p:notesMasterIdLst>
   <p:sldSz cx="12192000" cy="6858000"/>
   <p:notesSz cx="6858000" cy="12192000"/>
   <p:defaultTextStyle>
@@ -118,45 +119,46 @@
   <p:extLst>
     <p:ext uri="{521415D9-36F7-43E2-AB2F-B90AF26B5E84}">
       <p14:sectionLst xmlns:p14="http://schemas.microsoft.com/office/powerpoint/2010/main">
-        <p14:section name="Inicio" id="{54b47167-1380-303e-ee0b-42559e965d05}">
+        <p14:section name="Inicio" id="{54B47167-1380-303E-EE0B-42559E965D05}">
           <p14:sldIdLst>
             <p14:sldId id="256"/>
           </p14:sldIdLst>
         </p14:section>
-        <p14:section name="Problema" id="{67ae27da-768b-b3a0-b913-0ec96971f6ca}">
+        <p14:section name="Problema" id="{67AE27DA-768B-B3A0-B913-0EC96971F6CA}">
           <p14:sldIdLst>
             <p14:sldId id="257"/>
             <p14:sldId id="258"/>
           </p14:sldIdLst>
         </p14:section>
-        <p14:section name="Especificaciones" id="{871a627d-2f89-8710-bab5-23ae5f2f135f}">
+        <p14:section name="Especificaciones" id="{871A627D-2F89-8710-BAB5-23AE5F2F135F}">
           <p14:sldIdLst>
             <p14:sldId id="259"/>
             <p14:sldId id="260"/>
           </p14:sldIdLst>
         </p14:section>
-        <p14:section name="Arquitectura" id="{d317749d-4645-6601-e575-f02f1a80edf2}">
+        <p14:section name="Arquitectura" id="{D317749D-4645-6601-E575-F02F1A80EDF2}">
           <p14:sldIdLst>
             <p14:sldId id="261"/>
             <p14:sldId id="262"/>
           </p14:sldIdLst>
         </p14:section>
-        <p14:section name="Calidad" id="{398922cf-4b19-c445-ff13-4c5e96d7274a}">
+        <p14:section name="Calidad" id="{398922CF-4B19-C445-FF13-4C5E96D7274A}">
           <p14:sldIdLst>
             <p14:sldId id="263"/>
           </p14:sldIdLst>
         </p14:section>
-        <p14:section name="Uso de IA" id="{4125b0ad-d417-3c98-6b99-a8a5b371cc9b}">
+        <p14:section name="Uso de IA" id="{4125B0AD-D417-3C98-6B99-A8A5B371CC9B}">
           <p14:sldIdLst>
             <p14:sldId id="264"/>
+            <p14:sldId id="268"/>
           </p14:sldIdLst>
         </p14:section>
-        <p14:section name="Demo" id="{19770a89-5e04-6efd-f746-aec147bb289e}">
+        <p14:section name="Demo" id="{19770A89-5E04-6EFD-F746-AEC147BB289E}">
           <p14:sldIdLst>
             <p14:sldId id="265"/>
           </p14:sldIdLst>
         </p14:section>
-        <p14:section name="Cierre" id="{7f1e390f-33c0-724f-87d1-6d3e8b3bcc4d}">
+        <p14:section name="Cierre" id="{7F1E390F-33C0-724F-87D1-6D3E8B3BCC4D}">
           <p14:sldIdLst>
             <p14:sldId id="266"/>
             <p14:sldId id="267"/>
@@ -172,9 +174,11 @@
 </file>
 
 <file path=ppt/charts/chart1.xml><?xml version="1.0" encoding="utf-8"?>
-<c:chartSpace xmlns:c="http://schemas.openxmlformats.org/drawingml/2006/chart" xmlns:a="http://schemas.openxmlformats.org/drawingml/2006/main" xmlns:r="http://schemas.openxmlformats.org/officeDocument/2006/relationships">
+<c:chartSpace xmlns:c="http://schemas.openxmlformats.org/drawingml/2006/chart" xmlns:a="http://schemas.openxmlformats.org/drawingml/2006/main" xmlns:r="http://schemas.openxmlformats.org/officeDocument/2006/relationships" xmlns:c16r2="http://schemas.microsoft.com/office/drawing/2015/06/chart">
   <c:date1904 val="0"/>
+  <c:lang val="es-ES"/>
   <c:roundedCorners val="1"/>
+  <c:style val="2"/>
   <c:chart>
     <c:autoTitleDeleted val="1"/>
     <c:plotArea>
@@ -206,18 +210,26 @@
           <c:invertIfNegative val="0"/>
           <c:dLbls>
             <c:numFmt formatCode="#,##0" sourceLinked="0"/>
+            <c:spPr>
+              <a:noFill/>
+              <a:ln>
+                <a:noFill/>
+              </a:ln>
+              <a:effectLst/>
+            </c:spPr>
             <c:txPr>
               <a:bodyPr/>
               <a:lstStyle/>
               <a:p>
                 <a:pPr>
-                  <a:defRPr b="0" i="0" strike="noStrike" sz="1200" u="none">
+                  <a:defRPr sz="1200" b="0" i="0" u="none" strike="noStrike">
                     <a:solidFill>
                       <a:srgbClr val="1B2A30"/>
                     </a:solidFill>
                     <a:latin typeface="+mn-lt"/>
                   </a:defRPr>
                 </a:pPr>
+                <a:endParaRPr lang="es-MX"/>
               </a:p>
             </c:txPr>
             <c:showLegendKey val="0"/>
@@ -227,25 +239,28 @@
             <c:showPercent val="0"/>
             <c:showBubbleSize val="0"/>
             <c:showLeaderLines val="0"/>
+            <c:extLst>
+              <c:ext xmlns:c15="http://schemas.microsoft.com/office/drawing/2012/chart" uri="{CE6537A1-D6FC-4f65-9D91-7224C49458BB}">
+                <c15:showLeaderLines val="0"/>
+              </c:ext>
+            </c:extLst>
           </c:dLbls>
           <c:cat>
-            <c:multiLvlStrRef>
+            <c:strRef>
               <c:f>Sheet1!$A$2:$A$4</c:f>
-              <c:multiLvlStrCache>
+              <c:strCache>
                 <c:ptCount val="3"/>
-                <c:lvl>
-                  <c:pt idx="0">
-                    <c:v>Integración (API + SQL Server)</c:v>
-                  </c:pt>
-                  <c:pt idx="1">
-                    <c:v>Dominio</c:v>
-                  </c:pt>
-                  <c:pt idx="2">
-                    <c:v>Web</c:v>
-                  </c:pt>
-                </c:lvl>
-              </c:multiLvlStrCache>
-            </c:multiLvlStrRef>
+                <c:pt idx="0">
+                  <c:v>Integración (API + SQL Server)</c:v>
+                </c:pt>
+                <c:pt idx="1">
+                  <c:v>Dominio</c:v>
+                </c:pt>
+                <c:pt idx="2">
+                  <c:v>Web</c:v>
+                </c:pt>
+              </c:strCache>
+            </c:strRef>
           </c:cat>
           <c:val>
             <c:numRef>
@@ -254,47 +269,34 @@
                 <c:formatCode>General</c:formatCode>
                 <c:ptCount val="3"/>
                 <c:pt idx="0">
-                  <c:v>84</c:v>
+                  <c:v>85</c:v>
                 </c:pt>
                 <c:pt idx="1">
                   <c:v>25</c:v>
                 </c:pt>
                 <c:pt idx="2">
-                  <c:v>10</c:v>
+                  <c:v>11</c:v>
                 </c:pt>
               </c:numCache>
             </c:numRef>
           </c:val>
+          <c:extLst>
+            <c:ext xmlns:c16="http://schemas.microsoft.com/office/drawing/2014/chart" uri="{C3380CC4-5D6E-409C-BE32-E72D297353CC}">
+              <c16:uniqueId val="{00000000-B56B-4670-9E08-FEAF3F6B8BD5}"/>
+            </c:ext>
+          </c:extLst>
         </c:ser>
         <c:dLbls>
-          <c:numFmt formatCode="#,##0" sourceLinked="0"/>
-          <c:txPr>
-            <a:bodyPr/>
-            <a:lstStyle/>
-            <a:p>
-              <a:pPr>
-                <a:defRPr b="0" i="0" strike="noStrike" sz="1200" u="none">
-                  <a:solidFill>
-                    <a:srgbClr val="1B2A30"/>
-                  </a:solidFill>
-                  <a:latin typeface="+mn-lt"/>
-                </a:defRPr>
-              </a:pPr>
-            </a:p>
-          </c:txPr>
           <c:showLegendKey val="0"/>
           <c:showVal val="1"/>
           <c:showCatName val="0"/>
           <c:showSerName val="0"/>
           <c:showPercent val="0"/>
           <c:showBubbleSize val="0"/>
-          <c:showLeaderLines val="0"/>
         </c:dLbls>
         <c:gapWidth val="150"/>
-        <c:overlap val="0"/>
         <c:axId val="2094734554"/>
         <c:axId val="2094734552"/>
-        <c:axId val="2094734556"/>
       </c:barChart>
       <c:catAx>
         <c:axId val="2094734554"/>
@@ -328,13 +330,14 @@
                 <a:latin typeface="+mn-lt"/>
               </a:defRPr>
             </a:pPr>
-            <a:endParaRPr lang="en-US"/>
+            <a:endParaRPr lang="es-MX"/>
           </a:p>
         </c:txPr>
         <c:crossAx val="2094734552"/>
         <c:crosses val="autoZero"/>
         <c:auto val="1"/>
         <c:lblAlgn val="ctr"/>
+        <c:lblOffset val="100"/>
         <c:noMultiLvlLbl val="1"/>
       </c:catAx>
       <c:valAx>
@@ -348,30 +351,6 @@
         <c:majorTickMark val="out"/>
         <c:minorTickMark val="none"/>
         <c:tickLblPos val="low"/>
-        <c:spPr>
-          <a:ln w="12700" cap="flat">
-            <a:solidFill>
-              <a:srgbClr val="888888"/>
-            </a:solidFill>
-            <a:prstDash val="solid"/>
-            <a:round/>
-          </a:ln>
-        </c:spPr>
-        <c:txPr>
-          <a:bodyPr/>
-          <a:lstStyle/>
-          <a:p>
-            <a:pPr>
-              <a:defRPr sz="1200" b="0" i="0" u="none" strike="noStrike">
-                <a:solidFill>
-                  <a:srgbClr val="000000"/>
-                </a:solidFill>
-                <a:latin typeface="Arial"/>
-              </a:defRPr>
-            </a:pPr>
-            <a:endParaRPr lang="en-US"/>
-          </a:p>
-        </c:txPr>
         <c:crossAx val="2094734554"/>
         <c:crosses val="autoZero"/>
         <c:crossBetween val="between"/>
@@ -386,6 +365,7 @@
     </c:plotArea>
     <c:plotVisOnly val="1"/>
     <c:dispBlanksAs val="span"/>
+    <c:showDLblsOverMax val="1"/>
   </c:chart>
   <c:spPr>
     <a:noFill/>
@@ -422,234 +402,10 @@
           <a:chExt cx="0" cy="0"/>
         </a:xfrm>
       </p:grpSpPr>
-      <p:sp>
-        <p:nvSpPr>
-          <p:cNvPr id="2" name="Header Placeholder 1"/>
-          <p:cNvSpPr>
-            <a:spLocks noGrp="1"/>
-          </p:cNvSpPr>
-          <p:nvPr>
-            <p:ph type="hdr" sz="quarter"/>
-          </p:nvPr>
-        </p:nvSpPr>
-        <p:spPr>
-          <a:xfrm>
-            <a:off x="0" y="0"/>
-            <a:ext cx="2971800" cy="458788"/>
-          </a:xfrm>
-          <a:prstGeom prst="rect">
-            <a:avLst/>
-          </a:prstGeom>
-        </p:spPr>
-        <p:txBody>
-          <a:bodyPr vert="horz" lIns="91440" tIns="45720" rIns="91440" bIns="45720" rtlCol="0"/>
-          <a:lstStyle>
-            <a:lvl1pPr algn="l">
-              <a:defRPr sz="1200"/>
-            </a:lvl1pPr>
-          </a:lstStyle>
-          <a:p>
-            <a:endParaRPr lang="en-US"/>
-          </a:p>
-        </p:txBody>
-      </p:sp>
-      <p:sp>
-        <p:nvSpPr>
-          <p:cNvPr id="3" name="Date Placeholder 2"/>
-          <p:cNvSpPr>
-            <a:spLocks noGrp="1"/>
-          </p:cNvSpPr>
-          <p:nvPr>
-            <p:ph type="dt" idx="1"/>
-          </p:nvPr>
-        </p:nvSpPr>
-        <p:spPr>
-          <a:xfrm>
-            <a:off x="3884613" y="0"/>
-            <a:ext cx="2971800" cy="458788"/>
-          </a:xfrm>
-          <a:prstGeom prst="rect">
-            <a:avLst/>
-          </a:prstGeom>
-        </p:spPr>
-        <p:txBody>
-          <a:bodyPr vert="horz" lIns="91440" tIns="45720" rIns="91440" bIns="45720" rtlCol="0"/>
-          <a:lstStyle>
-            <a:lvl1pPr algn="r">
-              <a:defRPr sz="1200"/>
-            </a:lvl1pPr>
-          </a:lstStyle>
-          <a:p>
-            <a:fld id="{5282F153-3F37-0F45-9E97-73ACFA13230C}" type="datetimeFigureOut">
-              <a:rPr lang="en-US"/>
-              <a:t>7/23/19</a:t>
-            </a:fld>
-            <a:endParaRPr lang="en-US"/>
-          </a:p>
-        </p:txBody>
-      </p:sp>
-      <p:sp>
-        <p:nvSpPr>
-          <p:cNvPr id="4" name="Slide Image Placeholder 3"/>
-          <p:cNvSpPr>
-            <a:spLocks noGrp="1" noRot="1" noChangeAspect="1"/>
-          </p:cNvSpPr>
-          <p:nvPr>
-            <p:ph type="sldImg" idx="2"/>
-          </p:nvPr>
-        </p:nvSpPr>
-        <p:spPr>
-          <a:xfrm>
-            <a:off x="685800" y="1143000"/>
-            <a:ext cx="5486400" cy="3086100"/>
-          </a:xfrm>
-          <a:prstGeom prst="rect">
-            <a:avLst/>
-          </a:prstGeom>
-          <a:noFill/>
-          <a:ln w="12700">
-            <a:solidFill>
-              <a:prstClr val="black"/>
-            </a:solidFill>
-          </a:ln>
-        </p:spPr>
-        <p:txBody>
-          <a:bodyPr vert="horz" lIns="91440" tIns="45720" rIns="91440" bIns="45720" rtlCol="0" anchor="ctr"/>
-          <a:lstStyle/>
-          <a:p>
-            <a:endParaRPr lang="en-US"/>
-          </a:p>
-        </p:txBody>
-      </p:sp>
-      <p:sp>
-        <p:nvSpPr>
-          <p:cNvPr id="5" name="Notes Placeholder 4"/>
-          <p:cNvSpPr>
-            <a:spLocks noGrp="1"/>
-          </p:cNvSpPr>
-          <p:nvPr>
-            <p:ph type="body" sz="quarter" idx="3"/>
-          </p:nvPr>
-        </p:nvSpPr>
-        <p:spPr>
-          <a:xfrm>
-            <a:off x="685800" y="4400550"/>
-            <a:ext cx="5486400" cy="3600450"/>
-          </a:xfrm>
-          <a:prstGeom prst="rect">
-            <a:avLst/>
-          </a:prstGeom>
-        </p:spPr>
-        <p:txBody>
-          <a:bodyPr vert="horz" lIns="91440" tIns="45720" rIns="91440" bIns="45720" rtlCol="0"/>
-          <a:lstStyle/>
-          <a:p>
-            <a:pPr lvl="0"/>
-            <a:r>
-              <a:rPr lang="en-US"/>
-              <a:t>Click to edit Master text styles</a:t>
-            </a:r>
-          </a:p>
-          <a:p>
-            <a:pPr lvl="1"/>
-            <a:r>
-              <a:rPr lang="en-US"/>
-              <a:t>Second level</a:t>
-            </a:r>
-          </a:p>
-          <a:p>
-            <a:pPr lvl="2"/>
-            <a:r>
-              <a:rPr lang="en-US"/>
-              <a:t>Third level</a:t>
-            </a:r>
-          </a:p>
-          <a:p>
-            <a:pPr lvl="3"/>
-            <a:r>
-              <a:rPr lang="en-US"/>
-              <a:t>Fourth level</a:t>
-            </a:r>
-          </a:p>
-          <a:p>
-            <a:pPr lvl="4"/>
-            <a:r>
-              <a:rPr lang="en-US"/>
-              <a:t>Fifth level</a:t>
-            </a:r>
-          </a:p>
-        </p:txBody>
-      </p:sp>
-      <p:sp>
-        <p:nvSpPr>
-          <p:cNvPr id="6" name="Footer Placeholder 5"/>
-          <p:cNvSpPr>
-            <a:spLocks noGrp="1"/>
-          </p:cNvSpPr>
-          <p:nvPr>
-            <p:ph type="ftr" sz="quarter" idx="4"/>
-          </p:nvPr>
-        </p:nvSpPr>
-        <p:spPr>
-          <a:xfrm>
-            <a:off x="0" y="8685213"/>
-            <a:ext cx="2971800" cy="458787"/>
-          </a:xfrm>
-          <a:prstGeom prst="rect">
-            <a:avLst/>
-          </a:prstGeom>
-        </p:spPr>
-        <p:txBody>
-          <a:bodyPr vert="horz" lIns="91440" tIns="45720" rIns="91440" bIns="45720" rtlCol="0" anchor="b"/>
-          <a:lstStyle>
-            <a:lvl1pPr algn="l">
-              <a:defRPr sz="1200"/>
-            </a:lvl1pPr>
-          </a:lstStyle>
-          <a:p>
-            <a:endParaRPr lang="en-US"/>
-          </a:p>
-        </p:txBody>
-      </p:sp>
-      <p:sp>
-        <p:nvSpPr>
-          <p:cNvPr id="7" name="Slide Number Placeholder 6"/>
-          <p:cNvSpPr>
-            <a:spLocks noGrp="1"/>
-          </p:cNvSpPr>
-          <p:nvPr>
-            <p:ph type="sldNum" sz="quarter" idx="5"/>
-          </p:nvPr>
-        </p:nvSpPr>
-        <p:spPr>
-          <a:xfrm>
-            <a:off x="3884613" y="8685213"/>
-            <a:ext cx="2971800" cy="458787"/>
-          </a:xfrm>
-          <a:prstGeom prst="rect">
-            <a:avLst/>
-          </a:prstGeom>
-        </p:spPr>
-        <p:txBody>
-          <a:bodyPr vert="horz" lIns="91440" tIns="45720" rIns="91440" bIns="45720" rtlCol="0" anchor="b"/>
-          <a:lstStyle>
-            <a:lvl1pPr algn="r">
-              <a:defRPr sz="1200"/>
-            </a:lvl1pPr>
-          </a:lstStyle>
-          <a:p>
-            <a:fld id="{CE5E9CC1-C706-0F49-92D6-E571CC5EEA8F}" type="slidenum">
-              <a:rPr lang="en-US"/>
-              <a:t>‹#›</a:t>
-            </a:fld>
-            <a:endParaRPr lang="en-US"/>
-          </a:p>
-        </p:txBody>
-      </p:sp>
     </p:spTree>
     <p:extLst>
       <p:ext uri="{BB962C8B-B14F-4D97-AF65-F5344CB8AC3E}">
-        <p14:creationId xmlns:p14="http://schemas.microsoft.com/office/powerpoint/2010/main" val="1024086991"/>
+        <p14:creationId xmlns:p14="http://schemas.microsoft.com/office/powerpoint/2010/main" val="548640150"/>
       </p:ext>
     </p:extLst>
   </p:cSld>
@@ -797,7 +553,6 @@
               <a:rPr lang="en-US" dirty="0"/>
               <a:t>Presentación (30 s). Soy Angel Hermoza. El proyecto toma el flujo central de SISMAN, el sistema de mantenimiento de una editora: mantenimiento preventivo, fecha programada y orden de trabajo. Lo reconstruí especificando primero y probando todo, con Claude Code como asistente.</a:t>
             </a:r>
-            <a:endParaRPr lang="en-US" dirty="0"/>
           </a:p>
         </p:txBody>
       </p:sp>
@@ -861,7 +616,7 @@
             <a:spLocks noGrp="1" noRot="1" noChangeAspect="1"/>
           </p:cNvSpPr>
           <p:nvPr>
-            <p:ph type="sldImg"/>
+            <p:ph type="sldImg" idx="2"/>
           </p:nvPr>
         </p:nvSpPr>
         <p:spPr/>
@@ -873,7 +628,7 @@
             <a:spLocks noGrp="1"/>
           </p:cNvSpPr>
           <p:nvPr>
-            <p:ph type="body" idx="1"/>
+            <p:ph type="body" sz="quarter" idx="3"/>
           </p:nvPr>
         </p:nvSpPr>
         <p:spPr/>
@@ -882,10 +637,8 @@
           <a:lstStyle/>
           <a:p>
             <a:r>
-              <a:rPr lang="en-US" dirty="0"/>
-              <a:t>Demo (4 min). Antes de la presentación: levantar la API en 5300 y la web en 5400 con la base de ejemplo, e iniciar sesión recién (el token dura 30 minutos). Seguir los siete pasos. Si algo falla, pasar a Swagger con la misma secuencia.</a:t>
-            </a:r>
-            <a:endParaRPr lang="en-US" dirty="0"/>
+              <a:t>Prompt y diff (1 min). El prompt de RF-07 fue una sola palabra: «si». Funcionó porque el contexto ya estaba escrito: el modelo con el correlativo, el ADR-001 y las reglas RN-30 a RN-35. La IA propuso este UPDATE con bloqueo de fila y OUTPUT, dentro de la transacción. El commit tiene 10 archivos y 407 líneas. Revisé el diff y, para saber si la prueba sirve, se rompió a propósito: con el algoritmo del original, la prueba de 20 solicitudes falló en 19. Restaurado el código, quedó en verde.</a:t>
+            </a:r>
           </a:p>
         </p:txBody>
       </p:sp>
@@ -896,28 +649,12 @@
             <a:spLocks noGrp="1"/>
           </p:cNvSpPr>
           <p:nvPr>
-            <p:ph type="sldNum" sz="quarter" idx="10"/>
+            <p:ph type="sldNum" sz="quarter" idx="5"/>
           </p:nvPr>
         </p:nvSpPr>
         <p:spPr/>
-        <p:txBody>
-          <a:bodyPr/>
-          <a:lstStyle/>
-          <a:p>
-            <a:fld id="{F7021451-1387-4CA6-816F-3879F97B5CBC}" type="slidenum">
-              <a:rPr lang="en-US"/>
-              <a:t>10</a:t>
-            </a:fld>
-            <a:endParaRPr lang="en-US"/>
-          </a:p>
-        </p:txBody>
       </p:sp>
     </p:spTree>
-    <p:extLst>
-      <p:ext uri="{BB962C8B-B14F-4D97-AF65-F5344CB8AC3E}">
-        <p14:creationId xmlns:p14="http://schemas.microsoft.com/office/powerpoint/2010/main" val="1024086991"/>
-      </p:ext>
-    </p:extLst>
   </p:cSld>
   <p:clrMapOvr>
     <a:masterClrMapping/>
@@ -970,10 +707,8 @@
           <a:lstStyle/>
           <a:p>
             <a:r>
-              <a:rPr lang="en-US" dirty="0"/>
-              <a:t>Aprendizajes (1 min). Tres aprendizajes sobre pruebas y uno sobre la IA: con la especificación como contexto acelera; sin ella, inventa. Y las mejoras que quedan, empezando por validar cuatro reglas con un usuario real.</a:t>
-            </a:r>
-            <a:endParaRPr lang="en-US" dirty="0"/>
+              <a:t>Demo (5 min). Antes de la presentación: reiniciar la base de demostración, levantar la API en 5300 y la web en 5400, e iniciar sesión recién (el token dura 30 minutos). Empezar por Swagger para mostrar el contrato, luego la web con los siete pasos. Si algo falla, seguir en Swagger con la misma secuencia.</a:t>
+            </a:r>
           </a:p>
         </p:txBody>
       </p:sp>
@@ -1058,10 +793,8 @@
           <a:lstStyle/>
           <a:p>
             <a:r>
-              <a:rPr lang="en-US" dirty="0"/>
-              <a:t>Cierre (15 s). Preguntas esperadas: por qué esta arquitectura, cómo funciona el correlativo, qué hizo la IA y qué corregí yo, por qué no microservicios. Tener abiertos el ADR-003, OtServicio.GenerarAsync y la evidencia 011.</a:t>
-            </a:r>
-            <a:endParaRPr lang="en-US" dirty="0"/>
+              <a:t>Aprendizajes (1 min). Tres aprendizajes sobre pruebas, uno sobre la IA y uno sobre el proyecto: decidir el entorno el primer día. En mejoras: las cinco reglas las decidí yo como responsable el 26/10; falta validarlas con usuarios de planta. Y Docker queda como mejora, no como algo que se entregó sin probar.</a:t>
+            </a:r>
           </a:p>
         </p:txBody>
       </p:sp>
@@ -1083,6 +816,93 @@
             <a:fld id="{F7021451-1387-4CA6-816F-3879F97B5CBC}" type="slidenum">
               <a:rPr lang="en-US"/>
               <a:t>12</a:t>
+            </a:fld>
+            <a:endParaRPr lang="en-US"/>
+          </a:p>
+        </p:txBody>
+      </p:sp>
+    </p:spTree>
+    <p:extLst>
+      <p:ext uri="{BB962C8B-B14F-4D97-AF65-F5344CB8AC3E}">
+        <p14:creationId xmlns:p14="http://schemas.microsoft.com/office/powerpoint/2010/main" val="1024086991"/>
+      </p:ext>
+    </p:extLst>
+  </p:cSld>
+  <p:clrMapOvr>
+    <a:masterClrMapping/>
+  </p:clrMapOvr>
+</p:notes>
+</file>
+
+<file path=ppt/notesSlides/notesSlide13.xml><?xml version="1.0" encoding="utf-8"?>
+<p:notes xmlns:a="http://schemas.openxmlformats.org/drawingml/2006/main" xmlns:r="http://schemas.openxmlformats.org/officeDocument/2006/relationships" xmlns:p="http://schemas.openxmlformats.org/presentationml/2006/main">
+  <p:cSld>
+    <p:spTree>
+      <p:nvGrpSpPr>
+        <p:cNvPr id="1" name=""/>
+        <p:cNvGrpSpPr/>
+        <p:nvPr/>
+      </p:nvGrpSpPr>
+      <p:grpSpPr>
+        <a:xfrm>
+          <a:off x="0" y="0"/>
+          <a:ext cx="0" cy="0"/>
+          <a:chOff x="0" y="0"/>
+          <a:chExt cx="0" cy="0"/>
+        </a:xfrm>
+      </p:grpSpPr>
+      <p:sp>
+        <p:nvSpPr>
+          <p:cNvPr id="2" name="Slide Image Placeholder 1"/>
+          <p:cNvSpPr>
+            <a:spLocks noGrp="1" noRot="1" noChangeAspect="1"/>
+          </p:cNvSpPr>
+          <p:nvPr>
+            <p:ph type="sldImg"/>
+          </p:nvPr>
+        </p:nvSpPr>
+        <p:spPr/>
+      </p:sp>
+      <p:sp>
+        <p:nvSpPr>
+          <p:cNvPr id="3" name="Notes Placeholder 2"/>
+          <p:cNvSpPr>
+            <a:spLocks noGrp="1"/>
+          </p:cNvSpPr>
+          <p:nvPr>
+            <p:ph type="body" idx="1"/>
+          </p:nvPr>
+        </p:nvSpPr>
+        <p:spPr/>
+        <p:txBody>
+          <a:bodyPr/>
+          <a:lstStyle/>
+          <a:p>
+            <a:r>
+              <a:rPr lang="en-US" dirty="0"/>
+              <a:t>Cierre (15 s). Preguntas esperadas: por qué esta arquitectura, cómo funciona el correlativo, qué hizo la IA y qué corregí yo, por qué no microservicios. Tener abiertos el ADR-003, OtServicio.GenerarAsync y la evidencia 011.</a:t>
+            </a:r>
+          </a:p>
+        </p:txBody>
+      </p:sp>
+      <p:sp>
+        <p:nvSpPr>
+          <p:cNvPr id="4" name="Slide Number Placeholder 3"/>
+          <p:cNvSpPr>
+            <a:spLocks noGrp="1"/>
+          </p:cNvSpPr>
+          <p:nvPr>
+            <p:ph type="sldNum" sz="quarter" idx="10"/>
+          </p:nvPr>
+        </p:nvSpPr>
+        <p:spPr/>
+        <p:txBody>
+          <a:bodyPr/>
+          <a:lstStyle/>
+          <a:p>
+            <a:fld id="{F7021451-1387-4CA6-816F-3879F97B5CBC}" type="slidenum">
+              <a:rPr lang="en-US"/>
+              <a:t>13</a:t>
             </a:fld>
             <a:endParaRPr lang="en-US"/>
           </a:p>
@@ -1149,7 +969,6 @@
               <a:rPr lang="en-US" dirty="0"/>
               <a:t>Problema (1 min). Cuatro hallazgos del análisis. El más grave: el número de OT se tomaba en cuatro pasos sin transacción. Además, muchos botones decían éxito aunque el procedimiento almacenado no existiera. Esto define qué tenía que garantizar el sistema nuevo.</a:t>
             </a:r>
-            <a:endParaRPr lang="en-US" dirty="0"/>
           </a:p>
         </p:txBody>
       </p:sp>
@@ -1237,7 +1056,6 @@
               <a:rPr lang="en-US" dirty="0"/>
               <a:t>Solución (1 min). Elegí un solo flujo, el más usado, y lo cerré de punta a punta: API, web, pruebas y documentación. Dos actores: el planificador, que hace todo, y el especialista, que solo consulta.</a:t>
             </a:r>
-            <a:endParaRPr lang="en-US" dirty="0"/>
           </a:p>
         </p:txBody>
       </p:sp>
@@ -1325,7 +1143,6 @@
               <a:rPr lang="en-US" dirty="0"/>
               <a:t>Specs y trazabilidad (1 min). Antes de escribir código escribí 12 requisitos, 12 historias con criterios Dado/Cuando/Entonces, 9 casos de uso y 34 reglas. La matriz enlaza cada requisito con su endpoint, su clase y su prueba. Ninguna regla está inventada: cada una cita su origen.</a:t>
             </a:r>
-            <a:endParaRPr lang="en-US" dirty="0"/>
           </a:p>
         </p:txBody>
       </p:sp>
@@ -1413,7 +1230,6 @@
               <a:rPr lang="en-US" dirty="0"/>
               <a:t>Ejemplo de trazabilidad (1 min). Esta es la regla más importante. Nace de un hallazgo, se convierte en RN-34, se diseña con un bloqueo de fila dentro de la transacción y se prueba con 20 solicitudes simultáneas. Para comprobar que la prueba sirve, puse a propósito el algoritmo del sistema original: la prueba falló en 19 de 20 solicitudes.</a:t>
             </a:r>
-            <a:endParaRPr lang="en-US" dirty="0"/>
           </a:p>
         </p:txBody>
       </p:sp>
@@ -1501,7 +1317,6 @@
               <a:rPr lang="en-US" dirty="0"/>
               <a:t>Arquitectura (1 min). Cuatro capas más la web. El dominio no depende de nada: ahí viven aprobar, programar fecha, generar OT y cambiar estado. Los controladores solo traducen HTTP. La web no repite reglas: le pregunta a la API qué transiciones están permitidas.</a:t>
             </a:r>
-            <a:endParaRPr lang="en-US" dirty="0"/>
           </a:p>
         </p:txBody>
       </p:sp>
@@ -1586,10 +1401,8 @@
           <a:lstStyle/>
           <a:p>
             <a:r>
-              <a:rPr lang="en-US" dirty="0"/>
-              <a:t>Decisiones (1 min). Cada decisión tiene contexto, alternativas descartadas y consecuencias. Por ejemplo, EF Core con esquema propio, porque a la base original le faltan 33 procedimientos y no se puede compartir. Estoy listo para defender cualquiera.</a:t>
-            </a:r>
-            <a:endParaRPr lang="en-US" dirty="0"/>
+              <a:t>Decisiones (1 min). Son siete. Cada una tiene contexto, alternativas descartadas y consecuencias. Por ejemplo, EF Core con esquema propio, porque a la base original le faltan procedimientos y no se puede compartir. La séptima es la más reciente: no usar Docker. El instructor lo recomendó, pero el Compose nunca se pudo ejecutar en este equipo, y preferí no entregar algo que no probé. Estoy listo para defender cualquiera.</a:t>
+            </a:r>
           </a:p>
         </p:txBody>
       </p:sp>
@@ -1674,10 +1487,8 @@
           <a:lstStyle/>
           <a:p>
             <a:r>
-              <a:rPr lang="en-US" dirty="0"/>
-              <a:t>Pruebas y calidad (1 min). 119 pruebas: 84 de integración contra un SQL Server real, con una base propia que se crea y se borra; 25 de dominio y 10 de la web. Rendimiento medido con 26 000 OT: 47 milisegundos y 23 KB por página. Digo también lo que no usamos: Docker no se usa en el proyecto (ADR-007).</a:t>
-            </a:r>
-            <a:endParaRPr lang="en-US" dirty="0"/>
+              <a:t>Pruebas y calidad (1 min). 121 pruebas: 85 de integración contra un SQL Server real, con una base propia que se crea y se borra; 25 de dominio y 11 de la web. Rendimiento medido con 26 000 OT: 47 milisegundos y 23 KB por página. La cobertura se volvió a medir el 28/10 con las 121 pruebas. Digo también lo que no usamos: Docker (ADR-007).</a:t>
+            </a:r>
           </a:p>
         </p:txBody>
       </p:sp>
@@ -1762,10 +1573,8 @@
           <a:lstStyle/>
           <a:p>
             <a:r>
-              <a:rPr lang="en-US" dirty="0"/>
-              <a:t>Uso de IA (2 min). Toda la implementación se hizo con Claude Code, siempre con la especificación como contexto. Registré 14 evidencias. Lo importante no es que la IA escribiera código, sino cómo se revisó: hubo conclusiones corregidas, errores de prueba que no eran del sistema, una prueba de mutación para comprobar que las pruebas detectan el defecto, y errores de herramienta que cambiaron la forma de trabajar.</a:t>
-            </a:r>
-            <a:endParaRPr lang="en-US" dirty="0"/>
+              <a:t>Uso de IA (2 min). Toda la implementación se hizo con Claude Code, siempre con la especificación como contexto. Registré 16 evidencias con el prompt, la respuesta, el cambio y mi decisión. Cuatro ejemplos: una conclusión de la IA que se corrigió, un fallo que era de la prueba y no del sistema, una prueba de mutación para comprobar que las pruebas detectan el defecto, y una recomendación de la IA que rechacé: mantener la carpeta docker/ sin haberla ejecutado.</a:t>
+            </a:r>
           </a:p>
         </p:txBody>
       </p:sp>
@@ -1843,6 +1652,7 @@
         <a:solidFill>
           <a:schemeClr val="tx2"/>
         </a:solidFill>
+        <a:effectLst/>
       </p:bgPr>
     </p:bg>
     <p:spTree>
@@ -1862,9 +1672,11 @@
       <p:sp>
         <p:nvSpPr>
           <p:cNvPr id="2" name="Text 0"/>
-          <p:cNvSpPr/>
+          <p:cNvSpPr>
+            <a:spLocks noGrp="1"/>
+          </p:cNvSpPr>
           <p:nvPr>
-            <p:ph idx="100" type="title" hasCustomPrompt="1"/>
+            <p:ph type="title" idx="100" hasCustomPrompt="1"/>
           </p:nvPr>
         </p:nvSpPr>
         <p:spPr>
@@ -1881,7 +1693,7 @@
         <p:txBody>
           <a:bodyPr wrap="square" rtlCol="0"/>
           <a:lstStyle>
-            <a:lvl1pPr algn="l" indent="0" marL="0">
+            <a:lvl1pPr marL="0" indent="0" algn="l">
               <a:buNone/>
               <a:defRPr lang="en-US" sz="4800" b="1" dirty="0">
                 <a:solidFill>
@@ -1894,7 +1706,7 @@
             </a:lvl1pPr>
           </a:lstStyle>
           <a:p>
-            <a:pPr algn="l" indent="0" marL="0">
+            <a:pPr marL="0" indent="0" algn="l">
               <a:buNone/>
             </a:pPr>
             <a:endParaRPr lang="en-US" sz="4800" dirty="0"/>
@@ -1904,9 +1716,11 @@
       <p:sp>
         <p:nvSpPr>
           <p:cNvPr id="3" name="Text 0"/>
-          <p:cNvSpPr/>
+          <p:cNvSpPr>
+            <a:spLocks noGrp="1"/>
+          </p:cNvSpPr>
           <p:nvPr>
-            <p:ph idx="101" type="body" hasCustomPrompt="1"/>
+            <p:ph type="body" idx="101" hasCustomPrompt="1"/>
           </p:nvPr>
         </p:nvSpPr>
         <p:spPr>
@@ -1923,7 +1737,7 @@
         <p:txBody>
           <a:bodyPr wrap="square" rtlCol="0"/>
           <a:lstStyle>
-            <a:lvl1pPr indent="0" marL="0">
+            <a:lvl1pPr marL="0" indent="0">
               <a:buNone/>
               <a:defRPr lang="en-US" sz="2000" dirty="0">
                 <a:solidFill>
@@ -1933,7 +1747,7 @@
             </a:lvl1pPr>
           </a:lstStyle>
           <a:p>
-            <a:pPr indent="0" marL="0">
+            <a:pPr marL="0" indent="0">
               <a:buNone/>
             </a:pPr>
             <a:endParaRPr lang="en-US" sz="2000" dirty="0"/>
@@ -1956,6 +1770,7 @@
         <a:solidFill>
           <a:schemeClr val="bg1"/>
         </a:solidFill>
+        <a:effectLst/>
       </p:bgPr>
     </p:bg>
     <p:spTree>
@@ -1975,9 +1790,11 @@
       <p:sp>
         <p:nvSpPr>
           <p:cNvPr id="2" name="Text 0"/>
-          <p:cNvSpPr/>
+          <p:cNvSpPr>
+            <a:spLocks noGrp="1"/>
+          </p:cNvSpPr>
           <p:nvPr>
-            <p:ph idx="100" type="title" hasCustomPrompt="1"/>
+            <p:ph type="title" idx="100" hasCustomPrompt="1"/>
           </p:nvPr>
         </p:nvSpPr>
         <p:spPr>
@@ -1994,7 +1811,7 @@
         <p:txBody>
           <a:bodyPr wrap="square" rtlCol="0"/>
           <a:lstStyle>
-            <a:lvl1pPr indent="0" marL="0">
+            <a:lvl1pPr marL="0" indent="0">
               <a:buNone/>
               <a:defRPr lang="en-US" sz="3400" b="1" dirty="0">
                 <a:solidFill>
@@ -2007,7 +1824,7 @@
             </a:lvl1pPr>
           </a:lstStyle>
           <a:p>
-            <a:pPr indent="0" marL="0">
+            <a:pPr marL="0" indent="0">
               <a:buNone/>
             </a:pPr>
             <a:endParaRPr lang="en-US" sz="3400" dirty="0"/>
@@ -2035,7 +1852,7 @@
           <a:bodyPr wrap="square" lIns="0" tIns="0" rIns="0" bIns="0" rtlCol="0" anchor="ctr"/>
           <a:lstStyle/>
           <a:p>
-            <a:pPr indent="0" marL="0">
+            <a:pPr marL="0" indent="0">
               <a:buNone/>
             </a:pPr>
             <a:r>
@@ -2070,7 +1887,7 @@
           </a:prstGeom>
           <a:extLst>
             <a:ext uri="{C572A759-6A51-4108-AA02-DFA0A04FC94B}">
-              <ma14:wrappingTextBoxFlag xmlns:ma14="http://schemas.microsoft.com/office/mac/drawingml/2011/main" val="0"/>
+              <ma14:wrappingTextBoxFlag xmlns:ma14="http://schemas.microsoft.com/office/mac/drawingml/2011/main" xmlns="" val="0"/>
             </a:ext>
           </a:extLst>
         </p:spPr>
@@ -2088,8 +1905,8 @@
           <a:p>
             <a:pPr algn="r"/>
             <a:fld id="{F7021451-1387-4CA6-816F-3879F97B5CBC}" type="slidenum">
-              <a:rPr b="0" lang="en-US"/>
-              <a:t>1003</a:t>
+              <a:rPr lang="en-US" b="0"/>
+              <a:t>‹Nº›</a:t>
             </a:fld>
             <a:endParaRPr lang="en-US"/>
           </a:p>
@@ -2106,6 +1923,11 @@
 <file path=ppt/slideMasters/slideMaster1.xml><?xml version="1.0" encoding="utf-8"?>
 <p:sldMaster xmlns:a="http://schemas.openxmlformats.org/drawingml/2006/main" xmlns:r="http://schemas.openxmlformats.org/officeDocument/2006/relationships" xmlns:p="http://schemas.openxmlformats.org/presentationml/2006/main">
   <p:cSld>
+    <p:bg>
+      <p:bgRef idx="1001">
+        <a:schemeClr val="bg1"/>
+      </p:bgRef>
+    </p:bg>
     <p:spTree>
       <p:nvGrpSpPr>
         <p:cNvPr id="1" name=""/>
@@ -2140,7 +1962,7 @@
           </a:prstGeom>
           <a:extLst>
             <a:ext uri="{C572A759-6A51-4108-AA02-DFA0A04FC94B}">
-              <ma14:wrappingTextBoxFlag xmlns:ma14="http://schemas.microsoft.com/office/mac/drawingml/2011/main" val="0"/>
+              <ma14:wrappingTextBoxFlag xmlns:ma14="http://schemas.microsoft.com/office/mac/drawingml/2011/main" xmlns="" val="0"/>
             </a:ext>
           </a:extLst>
         </p:spPr>
@@ -2158,8 +1980,8 @@
           <a:p>
             <a:pPr algn="r"/>
             <a:fld id="{F7021451-1387-4CA6-816F-3879F97B5CBC}" type="slidenum">
-              <a:rPr b="0" lang="en-US"/>
-              <a:t>null</a:t>
+              <a:rPr lang="en-US" b="0"/>
+              <a:t>‹Nº›</a:t>
             </a:fld>
             <a:endParaRPr lang="en-US"/>
           </a:p>
@@ -2447,9 +2269,11 @@
       <p:sp>
         <p:nvSpPr>
           <p:cNvPr id="2" name="Text 0"/>
-          <p:cNvSpPr/>
+          <p:cNvSpPr>
+            <a:spLocks noGrp="1"/>
+          </p:cNvSpPr>
           <p:nvPr>
-            <p:ph idx="100" type="title" hasCustomPrompt="1"/>
+            <p:ph type="title" idx="100" hasCustomPrompt="1"/>
           </p:nvPr>
         </p:nvSpPr>
         <p:spPr>
@@ -2467,7 +2291,7 @@
           <a:bodyPr wrap="square" lIns="0" tIns="0" rIns="0" bIns="0" rtlCol="0" anchor="b"/>
           <a:lstStyle/>
           <a:p>
-            <a:pPr algn="l" indent="0" marL="0">
+            <a:pPr marL="0" indent="0" algn="ctr">
               <a:buNone/>
             </a:pPr>
             <a:r>
@@ -2479,7 +2303,59 @@
                 <a:ea typeface="Cambria" pitchFamily="34" charset="-122"/>
                 <a:cs typeface="Cambria" pitchFamily="34" charset="-120"/>
               </a:rPr>
-              <a:t>SISMAN Mantenimiento</a:t>
+              <a:t>SISMAN </a:t>
+            </a:r>
+            <a:r>
+              <a:rPr lang="en-US" sz="4800" b="1" dirty="0" err="1" smtClean="0">
+                <a:solidFill>
+                  <a:schemeClr val="bg1"/>
+                </a:solidFill>
+                <a:latin typeface="Cambria" pitchFamily="34" charset="0"/>
+                <a:ea typeface="Cambria" pitchFamily="34" charset="-122"/>
+                <a:cs typeface="Cambria" pitchFamily="34" charset="-120"/>
+              </a:rPr>
+              <a:t>Mantenimiento</a:t>
+            </a:r>
+            <a:r>
+              <a:rPr lang="en-US" sz="4800" b="1" dirty="0" smtClean="0">
+                <a:solidFill>
+                  <a:schemeClr val="bg1"/>
+                </a:solidFill>
+                <a:latin typeface="Cambria" pitchFamily="34" charset="0"/>
+                <a:ea typeface="Cambria" pitchFamily="34" charset="-122"/>
+                <a:cs typeface="Cambria" pitchFamily="34" charset="-120"/>
+              </a:rPr>
+              <a:t/>
+            </a:r>
+            <a:br>
+              <a:rPr lang="en-US" sz="4800" b="1" dirty="0" smtClean="0">
+                <a:solidFill>
+                  <a:schemeClr val="bg1"/>
+                </a:solidFill>
+                <a:latin typeface="Cambria" pitchFamily="34" charset="0"/>
+                <a:ea typeface="Cambria" pitchFamily="34" charset="-122"/>
+                <a:cs typeface="Cambria" pitchFamily="34" charset="-120"/>
+              </a:rPr>
+            </a:br>
+            <a:r>
+              <a:rPr lang="en-US" dirty="0" err="1" smtClean="0"/>
+              <a:t>Diario</a:t>
+            </a:r>
+            <a:r>
+              <a:rPr lang="en-US" dirty="0" smtClean="0"/>
+              <a:t> </a:t>
+            </a:r>
+            <a:r>
+              <a:rPr lang="en-US" dirty="0" err="1" smtClean="0"/>
+              <a:t>Oficial</a:t>
+            </a:r>
+            <a:r>
+              <a:rPr lang="en-US" dirty="0" smtClean="0"/>
+              <a:t> El </a:t>
+            </a:r>
+            <a:r>
+              <a:rPr lang="en-US" dirty="0" err="1" smtClean="0"/>
+              <a:t>Peruano</a:t>
             </a:r>
             <a:endParaRPr lang="en-US" sz="4800" dirty="0"/>
           </a:p>
@@ -2488,15 +2364,17 @@
       <p:sp>
         <p:nvSpPr>
           <p:cNvPr id="3" name="Text 0"/>
-          <p:cNvSpPr/>
+          <p:cNvSpPr>
+            <a:spLocks noGrp="1"/>
+          </p:cNvSpPr>
           <p:nvPr>
-            <p:ph idx="101" type="body" hasCustomPrompt="1"/>
+            <p:ph type="body" idx="101" hasCustomPrompt="1"/>
           </p:nvPr>
         </p:nvSpPr>
         <p:spPr>
           <a:xfrm>
-            <a:off x="548640" y="3657600"/>
-            <a:ext cx="10058400" cy="1280160"/>
+            <a:off x="548640" y="3685592"/>
+            <a:ext cx="10515600" cy="1280160"/>
           </a:xfrm>
           <a:prstGeom prst="rect">
             <a:avLst/>
@@ -2508,7 +2386,7 @@
           <a:bodyPr wrap="square" lIns="0" tIns="0" rIns="0" bIns="0" rtlCol="0" anchor="t"/>
           <a:lstStyle/>
           <a:p>
-            <a:pPr indent="0" marL="0">
+            <a:pPr marL="0" indent="0" algn="ctr">
               <a:buNone/>
             </a:pPr>
             <a:r>
@@ -2517,21 +2395,76 @@
                   <a:schemeClr val="accent6"/>
                 </a:solidFill>
               </a:rPr>
-              <a:t>Del sistema que decía «éxito» sin grabar, a un módulo especificado, probado y trazable</a:t>
-            </a:r>
+              <a:t>Del sistema que decía «éxito» sin grabar, a un módulo especificado, probado y </a:t>
+            </a:r>
+            <a:r>
+              <a:rPr lang="en-US" sz="2000" dirty="0" err="1" smtClean="0">
+                <a:solidFill>
+                  <a:schemeClr val="accent6"/>
+                </a:solidFill>
+              </a:rPr>
+              <a:t>trazable</a:t>
+            </a:r>
+            <a:endParaRPr lang="en-US" sz="2000" dirty="0" smtClean="0">
+              <a:solidFill>
+                <a:schemeClr val="accent6"/>
+              </a:solidFill>
+            </a:endParaRPr>
+          </a:p>
+          <a:p>
+            <a:pPr marL="0" indent="0" algn="ctr">
+              <a:buNone/>
+            </a:pPr>
+            <a:endParaRPr lang="en-US" dirty="0"/>
+          </a:p>
+          <a:p>
+            <a:pPr marL="0" indent="0" algn="ctr">
+              <a:buNone/>
+            </a:pPr>
             <a:endParaRPr lang="en-US" sz="2000" dirty="0"/>
           </a:p>
           <a:p>
-            <a:pPr indent="0" marL="0">
-              <a:buNone/>
-            </a:pPr>
-            <a:r>
-              <a:rPr lang="en-US" sz="1400" dirty="0">
+            <a:pPr marL="0" indent="0" algn="ctr">
+              <a:buNone/>
+            </a:pPr>
+            <a:r>
+              <a:rPr lang="en-US" sz="2400" dirty="0">
                 <a:solidFill>
                   <a:schemeClr val="accent1"/>
                 </a:solidFill>
               </a:rPr>
-              <a:t>Proyecto integrador · Agentic Software Development (.NET 10) · Angel Hermoza · 31/10/2026</a:t>
+              <a:t>Proyecto integrador: Agentic Software Development (.NET 10)</a:t>
+            </a:r>
+            <a:endParaRPr lang="en-US" sz="2400" dirty="0" smtClean="0">
+              <a:solidFill>
+                <a:schemeClr val="accent1"/>
+              </a:solidFill>
+            </a:endParaRPr>
+          </a:p>
+          <a:p>
+            <a:pPr marL="0" indent="0" algn="ctr">
+              <a:buNone/>
+            </a:pPr>
+            <a:r>
+              <a:rPr lang="en-US" sz="2400" dirty="0" err="1" smtClean="0">
+                <a:solidFill>
+                  <a:schemeClr val="accent1"/>
+                </a:solidFill>
+              </a:rPr>
+              <a:t>Presentado por: Mg. Ing. Angel Hermoza Salas</a:t>
+            </a:r>
+          </a:p>
+          <a:p>
+            <a:pPr marL="0" indent="0" algn="ctr">
+              <a:buNone/>
+            </a:pPr>
+            <a:r>
+              <a:rPr lang="en-US" sz="2400" dirty="0" smtClean="0">
+                <a:solidFill>
+                  <a:schemeClr val="accent1"/>
+                </a:solidFill>
+              </a:rPr>
+              <a:t>31/10/2026</a:t>
             </a:r>
             <a:endParaRPr lang="en-US" sz="2000" dirty="0"/>
           </a:p>
@@ -2583,7 +2516,7 @@
           <a:bodyPr wrap="square" lIns="0" tIns="0" rIns="0" bIns="0" rtlCol="0" anchor="ctr"/>
           <a:lstStyle/>
           <a:p>
-            <a:pPr algn="ctr" indent="0" marL="0">
+            <a:pPr marL="0" indent="0" algn="ctr">
               <a:buNone/>
             </a:pPr>
             <a:r>
@@ -2668,7 +2601,7 @@
           <a:bodyPr wrap="square" lIns="0" tIns="0" rIns="0" bIns="0" rtlCol="0" anchor="ctr"/>
           <a:lstStyle/>
           <a:p>
-            <a:pPr algn="ctr" indent="0" marL="0">
+            <a:pPr marL="0" indent="0" algn="ctr">
               <a:buNone/>
             </a:pPr>
             <a:r>
@@ -2753,7 +2686,7 @@
           <a:bodyPr wrap="square" lIns="0" tIns="0" rIns="0" bIns="0" rtlCol="0" anchor="ctr"/>
           <a:lstStyle/>
           <a:p>
-            <a:pPr algn="ctr" indent="0" marL="0">
+            <a:pPr marL="0" indent="0" algn="ctr">
               <a:buNone/>
             </a:pPr>
             <a:r>
@@ -2777,6 +2710,628 @@
 </file>
 
 <file path=ppt/slides/slide10.xml><?xml version="1.0" encoding="utf-8"?>
+<p:sld xmlns:a="http://schemas.openxmlformats.org/drawingml/2006/main" xmlns:r="http://schemas.openxmlformats.org/officeDocument/2006/relationships" xmlns:p="http://schemas.openxmlformats.org/presentationml/2006/main">
+  <p:cSld>
+    <p:spTree>
+      <p:nvGrpSpPr>
+        <p:cNvPr id="1" name=""/>
+        <p:cNvGrpSpPr/>
+        <p:nvPr/>
+      </p:nvGrpSpPr>
+      <p:grpSpPr>
+        <a:xfrm>
+          <a:off x="0" y="0"/>
+          <a:ext cx="0" cy="0"/>
+          <a:chOff x="0" y="0"/>
+          <a:chExt cx="0" cy="0"/>
+        </a:xfrm>
+      </p:grpSpPr>
+      <p:sp>
+        <p:nvSpPr>
+          <p:cNvPr id="2" name="Text 0"/>
+          <p:cNvSpPr>
+            <a:spLocks noGrp="1"/>
+          </p:cNvSpPr>
+          <p:nvPr>
+            <p:ph type="title" idx="100" hasCustomPrompt="1"/>
+          </p:nvPr>
+        </p:nvSpPr>
+        <p:spPr>
+          <a:xfrm>
+            <a:off x="548640" y="365760"/>
+            <a:ext cx="11094415" cy="822960"/>
+          </a:xfrm>
+          <a:prstGeom prst="rect">
+            <a:avLst/>
+          </a:prstGeom>
+          <a:noFill/>
+          <a:ln/>
+        </p:spPr>
+        <p:txBody>
+          <a:bodyPr wrap="square" lIns="0" tIns="0" rIns="0" bIns="0" rtlCol="0" anchor="ctr"/>
+          <a:lstStyle/>
+          <a:p>
+            <a:pPr marL="0" indent="0">
+              <a:buNone/>
+            </a:pPr>
+            <a:r>
+              <a:rPr lang="en-US" sz="3400" b="1" dirty="0">
+                <a:solidFill>
+                  <a:schemeClr val="tx2"/>
+                </a:solidFill>
+                <a:latin typeface="Cambria" pitchFamily="34" charset="0"/>
+                <a:ea typeface="Cambria" pitchFamily="34" charset="-122"/>
+                <a:cs typeface="Cambria" pitchFamily="34" charset="-120"/>
+              </a:rPr>
+              <a:t>Un prompt corto funciona cuando la spec es el contexto</a:t>
+            </a:r>
+            <a:endParaRPr lang="en-US" sz="3400" dirty="0"/>
+          </a:p>
+        </p:txBody>
+      </p:sp>
+      <p:sp>
+        <p:nvSpPr>
+          <p:cNvPr id="25" name="Slide Number Placeholder 0"/>
+          <p:cNvSpPr>
+            <a:spLocks noGrp="1"/>
+          </p:cNvSpPr>
+          <p:nvPr>
+            <p:ph type="sldNum" sz="quarter" idx="4294967295"/>
+          </p:nvPr>
+        </p:nvSpPr>
+        <p:spPr>
+          <a:xfrm>
+            <a:off x="11094415" y="6400800"/>
+            <a:ext cx="548640" cy="274320"/>
+          </a:xfrm>
+          <a:prstGeom prst="rect">
+            <a:avLst/>
+          </a:prstGeom>
+          <a:extLst>
+            <a:ext uri="{C572A759-6A51-4108-AA02-DFA0A04FC94B}">
+              <ma14:wrappingTextBoxFlag xmlns:ma14="http://schemas.microsoft.com/office/mac/drawingml/2011/main" xmlns="" val="0"/>
+            </a:ext>
+          </a:extLst>
+        </p:spPr>
+        <p:txBody>
+          <a:bodyPr/>
+          <a:lstStyle>
+            <a:lvl1pPr>
+              <a:defRPr sz="1000">
+                <a:solidFill>
+                  <a:schemeClr val="accent4"/>
+                </a:solidFill>
+              </a:defRPr>
+            </a:lvl1pPr>
+          </a:lstStyle>
+          <a:p>
+            <a:pPr algn="r"/>
+            <a:fld id="{F7021451-1387-4CA6-816F-3879F97B5CBC}" type="slidenum">
+              <a:rPr lang="en-US" b="0"/>
+              <a:t>10</a:t>
+            </a:fld>
+            <a:endParaRPr lang="en-US"/>
+          </a:p>
+        </p:txBody>
+      </p:sp>
+      <p:sp>
+        <p:nvSpPr>
+          <p:cNvPr id="5" name="tarjeta-310"/>
+          <p:cNvSpPr/>
+          <p:nvPr/>
+        </p:nvSpPr>
+        <p:spPr>
+          <a:xfrm>
+            <a:off x="548640" y="1463040"/>
+            <a:ext cx="4206240" cy="2148840"/>
+          </a:xfrm>
+          <a:prstGeom prst="roundRect">
+            <a:avLst>
+              <a:gd name="adj" fmla="val 5455"/>
+            </a:avLst>
+          </a:prstGeom>
+          <a:solidFill>
+            <a:schemeClr val="bg2"/>
+          </a:solidFill>
+          <a:ln w="12700">
+            <a:solidFill>
+              <a:schemeClr val="bg2"/>
+            </a:solidFill>
+            <a:prstDash val="solid"/>
+          </a:ln>
+        </p:spPr>
+      </p:sp>
+      <p:sp>
+        <p:nvSpPr>
+          <p:cNvPr id="8" name="texto-311"/>
+          <p:cNvSpPr txBox="1"/>
+          <p:nvPr/>
+        </p:nvSpPr>
+        <p:spPr>
+          <a:xfrm>
+            <a:off x="822960" y="1645920"/>
+            <a:ext cx="3657600" cy="457200"/>
+          </a:xfrm>
+          <a:prstGeom prst="rect">
+            <a:avLst/>
+          </a:prstGeom>
+          <a:noFill/>
+          <a:ln/>
+        </p:spPr>
+        <p:txBody>
+          <a:bodyPr wrap="square" lIns="0" tIns="0" rIns="0" bIns="0" rtlCol="0" anchor="ctr"/>
+          <a:lstStyle/>
+          <a:p>
+            <a:pPr marL="0" indent="0">
+              <a:buNone/>
+            </a:pPr>
+            <a:r>
+              <a:rPr lang="en-US" sz="1800" b="1" dirty="0">
+                <a:solidFill>
+                  <a:schemeClr val="tx2"/>
+                </a:solidFill>
+              </a:rPr>
+              <a:t>Prompt</a:t>
+            </a:r>
+            <a:endParaRPr lang="en-US" sz="1800" dirty="0"/>
+          </a:p>
+        </p:txBody>
+      </p:sp>
+      <p:sp>
+        <p:nvSpPr>
+          <p:cNvPr id="3" name="texto-312"/>
+          <p:cNvSpPr txBox="1"/>
+          <p:nvPr/>
+        </p:nvSpPr>
+        <p:spPr>
+          <a:xfrm>
+            <a:off x="822960" y="2057400"/>
+            <a:ext cx="3657600" cy="822960"/>
+          </a:xfrm>
+          <a:prstGeom prst="rect">
+            <a:avLst/>
+          </a:prstGeom>
+          <a:noFill/>
+          <a:ln/>
+        </p:spPr>
+        <p:txBody>
+          <a:bodyPr wrap="square" lIns="0" tIns="0" rIns="0" bIns="0" rtlCol="0" anchor="t"/>
+          <a:lstStyle/>
+          <a:p>
+            <a:pPr marL="0" indent="0">
+              <a:buNone/>
+            </a:pPr>
+            <a:r>
+              <a:rPr lang="en-US" sz="4000" b="1" dirty="0">
+                <a:solidFill>
+                  <a:schemeClr val="tx2"/>
+                </a:solidFill>
+                <a:latin typeface="Cambria" pitchFamily="34" charset="0"/>
+                <a:ea typeface="Cambria" pitchFamily="34" charset="-122"/>
+                <a:cs typeface="Cambria" pitchFamily="34" charset="-120"/>
+              </a:rPr>
+              <a:t>«si»</a:t>
+            </a:r>
+            <a:endParaRPr lang="en-US" sz="6600" dirty="0"/>
+          </a:p>
+        </p:txBody>
+      </p:sp>
+      <p:sp>
+        <p:nvSpPr>
+          <p:cNvPr id="9" name="texto-313"/>
+          <p:cNvSpPr txBox="1"/>
+          <p:nvPr/>
+        </p:nvSpPr>
+        <p:spPr>
+          <a:xfrm>
+            <a:off x="822960" y="2834640"/>
+            <a:ext cx="3749039" cy="731520"/>
+          </a:xfrm>
+          <a:prstGeom prst="rect">
+            <a:avLst/>
+          </a:prstGeom>
+          <a:noFill/>
+          <a:ln/>
+        </p:spPr>
+        <p:txBody>
+          <a:bodyPr wrap="square" lIns="0" tIns="0" rIns="0" bIns="0" rtlCol="0" anchor="t"/>
+          <a:lstStyle/>
+          <a:p>
+            <a:pPr marL="0" indent="0">
+              <a:buNone/>
+            </a:pPr>
+            <a:r>
+              <a:rPr lang="en-US" sz="1400" dirty="0">
+                <a:solidFill>
+                  <a:schemeClr val="tx1"/>
+                </a:solidFill>
+              </a:rPr>
+              <a:t>Seguir con RF-07. Nada más: el resto ya estaba escrito.</a:t>
+            </a:r>
+            <a:endParaRPr lang="en-US" sz="1400" dirty="0"/>
+          </a:p>
+        </p:txBody>
+      </p:sp>
+      <p:sp>
+        <p:nvSpPr>
+          <p:cNvPr id="4" name="tarjeta-314"/>
+          <p:cNvSpPr/>
+          <p:nvPr/>
+        </p:nvSpPr>
+        <p:spPr>
+          <a:xfrm>
+            <a:off x="548640" y="3794760"/>
+            <a:ext cx="4206240" cy="2148840"/>
+          </a:xfrm>
+          <a:prstGeom prst="roundRect">
+            <a:avLst>
+              <a:gd name="adj" fmla="val 5455"/>
+            </a:avLst>
+          </a:prstGeom>
+          <a:solidFill>
+            <a:schemeClr val="bg2"/>
+          </a:solidFill>
+          <a:ln w="12700">
+            <a:solidFill>
+              <a:schemeClr val="bg2"/>
+            </a:solidFill>
+            <a:prstDash val="solid"/>
+          </a:ln>
+        </p:spPr>
+      </p:sp>
+      <p:sp>
+        <p:nvSpPr>
+          <p:cNvPr id="6" name="texto-315"/>
+          <p:cNvSpPr txBox="1"/>
+          <p:nvPr/>
+        </p:nvSpPr>
+        <p:spPr>
+          <a:xfrm>
+            <a:off x="822960" y="3977639"/>
+            <a:ext cx="3657600" cy="457200"/>
+          </a:xfrm>
+          <a:prstGeom prst="rect">
+            <a:avLst/>
+          </a:prstGeom>
+          <a:noFill/>
+          <a:ln/>
+        </p:spPr>
+        <p:txBody>
+          <a:bodyPr wrap="square" lIns="0" tIns="0" rIns="0" bIns="0" rtlCol="0" anchor="ctr"/>
+          <a:lstStyle/>
+          <a:p>
+            <a:pPr marL="0" indent="0">
+              <a:buNone/>
+            </a:pPr>
+            <a:r>
+              <a:rPr lang="en-US" sz="1800" b="1" dirty="0">
+                <a:solidFill>
+                  <a:schemeClr val="tx2"/>
+                </a:solidFill>
+              </a:rPr>
+              <a:t>Contexto que leyó</a:t>
+            </a:r>
+            <a:endParaRPr lang="en-US" sz="1800" dirty="0"/>
+          </a:p>
+        </p:txBody>
+      </p:sp>
+      <p:sp>
+        <p:nvSpPr>
+          <p:cNvPr id="7" name="texto-316"/>
+          <p:cNvSpPr txBox="1"/>
+          <p:nvPr/>
+        </p:nvSpPr>
+        <p:spPr>
+          <a:xfrm>
+            <a:off x="822960" y="4480560"/>
+            <a:ext cx="3749039" cy="1371600"/>
+          </a:xfrm>
+          <a:prstGeom prst="rect">
+            <a:avLst/>
+          </a:prstGeom>
+          <a:noFill/>
+          <a:ln/>
+        </p:spPr>
+        <p:txBody>
+          <a:bodyPr wrap="square" lIns="0" tIns="0" rIns="0" bIns="0" rtlCol="0" anchor="t"/>
+          <a:lstStyle/>
+          <a:p>
+            <a:pPr marL="0" indent="0">
+              <a:buNone/>
+            </a:pPr>
+            <a:r>
+              <a:rPr lang="en-US" sz="1400" dirty="0">
+                <a:solidFill>
+                  <a:schemeClr val="tx1"/>
+                </a:solidFill>
+              </a:rPr>
+              <a:t>modelo.md §4: correlativo con UPDLOCK</a:t>
+            </a:r>
+            <a:endParaRPr lang="en-US" sz="1400" dirty="0"/>
+          </a:p>
+          <a:p>
+            <a:pPr marL="0" indent="0">
+              <a:buNone/>
+            </a:pPr>
+            <a:r>
+              <a:rPr lang="en-US" sz="1400" dirty="0">
+                <a:solidFill>
+                  <a:schemeClr val="tx1"/>
+                </a:solidFill>
+              </a:rPr>
+              <a:t>ADR-001: EF Core y transacción</a:t>
+            </a:r>
+            <a:endParaRPr lang="en-US" sz="1400" dirty="0"/>
+          </a:p>
+          <a:p>
+            <a:pPr marL="0" indent="0">
+              <a:buNone/>
+            </a:pPr>
+            <a:r>
+              <a:rPr lang="en-US" sz="1400" dirty="0">
+                <a:solidFill>
+                  <a:schemeClr val="tx1"/>
+                </a:solidFill>
+              </a:rPr>
+              <a:t>RN-30 a RN-35 y RNF-02</a:t>
+            </a:r>
+            <a:endParaRPr lang="en-US" sz="1400" dirty="0"/>
+          </a:p>
+        </p:txBody>
+      </p:sp>
+      <p:sp>
+        <p:nvSpPr>
+          <p:cNvPr id="10" name="tarjeta-320"/>
+          <p:cNvSpPr/>
+          <p:nvPr/>
+        </p:nvSpPr>
+        <p:spPr>
+          <a:xfrm>
+            <a:off x="5029200" y="1463040"/>
+            <a:ext cx="6611112" cy="2148840"/>
+          </a:xfrm>
+          <a:prstGeom prst="roundRect">
+            <a:avLst>
+              <a:gd name="adj" fmla="val 5455"/>
+            </a:avLst>
+          </a:prstGeom>
+          <a:solidFill>
+            <a:srgbClr val="143740"/>
+          </a:solidFill>
+          <a:ln w="12700">
+            <a:solidFill>
+              <a:schemeClr val="bg2"/>
+            </a:solidFill>
+            <a:prstDash val="solid"/>
+          </a:ln>
+        </p:spPr>
+      </p:sp>
+      <p:sp>
+        <p:nvSpPr>
+          <p:cNvPr id="11" name="texto-321"/>
+          <p:cNvSpPr txBox="1"/>
+          <p:nvPr/>
+        </p:nvSpPr>
+        <p:spPr>
+          <a:xfrm>
+            <a:off x="5303520" y="1600200"/>
+            <a:ext cx="6035040" cy="411480"/>
+          </a:xfrm>
+          <a:prstGeom prst="rect">
+            <a:avLst/>
+          </a:prstGeom>
+          <a:noFill/>
+          <a:ln/>
+        </p:spPr>
+        <p:txBody>
+          <a:bodyPr wrap="square" lIns="0" tIns="0" rIns="0" bIns="0" rtlCol="0" anchor="ctr"/>
+          <a:lstStyle/>
+          <a:p>
+            <a:pPr marL="0" indent="0">
+              <a:buNone/>
+            </a:pPr>
+            <a:r>
+              <a:rPr lang="en-US" sz="1300" b="1" dirty="0">
+                <a:solidFill>
+                  <a:srgbClr val="F4A641"/>
+                </a:solidFill>
+              </a:rPr>
+              <a:t>Código propuesto · Transacciones.cs (commit 1445bfe: 10 archivos, +407 −2)</a:t>
+            </a:r>
+            <a:endParaRPr lang="en-US" sz="1800" dirty="0"/>
+          </a:p>
+        </p:txBody>
+      </p:sp>
+      <p:sp>
+        <p:nvSpPr>
+          <p:cNvPr id="12" name="texto-322"/>
+          <p:cNvSpPr txBox="1"/>
+          <p:nvPr/>
+        </p:nvSpPr>
+        <p:spPr>
+          <a:xfrm>
+            <a:off x="5303520" y="2057400"/>
+            <a:ext cx="6126480" cy="1463040"/>
+          </a:xfrm>
+          <a:prstGeom prst="rect">
+            <a:avLst/>
+          </a:prstGeom>
+          <a:noFill/>
+          <a:ln/>
+        </p:spPr>
+        <p:txBody>
+          <a:bodyPr wrap="square" lIns="0" tIns="0" rIns="0" bIns="0" rtlCol="0" anchor="t"/>
+          <a:lstStyle/>
+          <a:p>
+            <a:pPr marL="0" indent="0">
+              <a:buNone/>
+            </a:pPr>
+            <a:r>
+              <a:rPr lang="en-US" sz="1500" dirty="0">
+                <a:solidFill>
+                  <a:srgbClr val="FFFFFF"/>
+                </a:solidFill>
+                <a:latin typeface="Consolas"/>
+              </a:rPr>
+              <a:t>UPDATE [sisman].[Correlativo] WITH (UPDLOCK, ROWLOCK)</a:t>
+            </a:r>
+            <a:endParaRPr lang="en-US" sz="1400" dirty="0"/>
+          </a:p>
+          <a:p>
+            <a:pPr marL="0" indent="0">
+              <a:buNone/>
+            </a:pPr>
+            <a:r>
+              <a:rPr lang="en-US" sz="1500" dirty="0">
+                <a:solidFill>
+                  <a:srgbClr val="FFFFFF"/>
+                </a:solidFill>
+                <a:latin typeface="Consolas"/>
+              </a:rPr>
+              <a:t>   SET [UltimoValor] = [UltimoValor] + 1</a:t>
+            </a:r>
+            <a:endParaRPr lang="en-US" sz="1400" dirty="0"/>
+          </a:p>
+          <a:p>
+            <a:pPr marL="0" indent="0">
+              <a:buNone/>
+            </a:pPr>
+            <a:r>
+              <a:rPr lang="en-US" sz="1500" dirty="0">
+                <a:solidFill>
+                  <a:srgbClr val="FFFFFF"/>
+                </a:solidFill>
+                <a:latin typeface="Consolas"/>
+              </a:rPr>
+              <a:t>OUTPUT inserted.[UltimoValor]</a:t>
+            </a:r>
+            <a:endParaRPr lang="en-US" sz="1400" dirty="0"/>
+          </a:p>
+          <a:p>
+            <a:pPr marL="0" indent="0">
+              <a:buNone/>
+            </a:pPr>
+            <a:r>
+              <a:rPr lang="en-US" sz="1500" dirty="0">
+                <a:solidFill>
+                  <a:srgbClr val="FFFFFF"/>
+                </a:solidFill>
+                <a:latin typeface="Consolas"/>
+              </a:rPr>
+              <a:t> WHERE [Nombre] = {correlativo}</a:t>
+            </a:r>
+            <a:endParaRPr lang="en-US" sz="1400" dirty="0"/>
+          </a:p>
+        </p:txBody>
+      </p:sp>
+      <p:sp>
+        <p:nvSpPr>
+          <p:cNvPr id="13" name="tarjeta-323"/>
+          <p:cNvSpPr/>
+          <p:nvPr/>
+        </p:nvSpPr>
+        <p:spPr>
+          <a:xfrm>
+            <a:off x="5029200" y="3794760"/>
+            <a:ext cx="6611112" cy="2148840"/>
+          </a:xfrm>
+          <a:prstGeom prst="roundRect">
+            <a:avLst>
+              <a:gd name="adj" fmla="val 5455"/>
+            </a:avLst>
+          </a:prstGeom>
+          <a:solidFill>
+            <a:schemeClr val="bg2"/>
+          </a:solidFill>
+          <a:ln w="12700">
+            <a:solidFill>
+              <a:schemeClr val="bg2"/>
+            </a:solidFill>
+            <a:prstDash val="solid"/>
+          </a:ln>
+        </p:spPr>
+      </p:sp>
+      <p:sp>
+        <p:nvSpPr>
+          <p:cNvPr id="18" name="texto-324"/>
+          <p:cNvSpPr txBox="1"/>
+          <p:nvPr/>
+        </p:nvSpPr>
+        <p:spPr>
+          <a:xfrm>
+            <a:off x="5303520" y="3977639"/>
+            <a:ext cx="6035040" cy="457200"/>
+          </a:xfrm>
+          <a:prstGeom prst="rect">
+            <a:avLst/>
+          </a:prstGeom>
+          <a:noFill/>
+          <a:ln/>
+        </p:spPr>
+        <p:txBody>
+          <a:bodyPr wrap="square" lIns="0" tIns="0" rIns="0" bIns="0" rtlCol="0" anchor="ctr"/>
+          <a:lstStyle/>
+          <a:p>
+            <a:pPr marL="0" indent="0">
+              <a:buNone/>
+            </a:pPr>
+            <a:r>
+              <a:rPr lang="en-US" sz="1800" b="1" dirty="0">
+                <a:solidFill>
+                  <a:schemeClr val="tx2"/>
+                </a:solidFill>
+              </a:rPr>
+              <a:t>Revisión humana</a:t>
+            </a:r>
+            <a:endParaRPr lang="en-US" sz="1800" dirty="0"/>
+          </a:p>
+        </p:txBody>
+      </p:sp>
+      <p:sp>
+        <p:nvSpPr>
+          <p:cNvPr id="19" name="texto-325"/>
+          <p:cNvSpPr txBox="1"/>
+          <p:nvPr/>
+        </p:nvSpPr>
+        <p:spPr>
+          <a:xfrm>
+            <a:off x="5303520" y="4480560"/>
+            <a:ext cx="6126480" cy="1280160"/>
+          </a:xfrm>
+          <a:prstGeom prst="rect">
+            <a:avLst/>
+          </a:prstGeom>
+          <a:noFill/>
+          <a:ln/>
+        </p:spPr>
+        <p:txBody>
+          <a:bodyPr wrap="square" lIns="0" tIns="0" rIns="0" bIns="0" rtlCol="0" anchor="t"/>
+          <a:lstStyle/>
+          <a:p>
+            <a:pPr marL="0" indent="0">
+              <a:buNone/>
+            </a:pPr>
+            <a:r>
+              <a:rPr lang="en-US" sz="1400" dirty="0">
+                <a:solidFill>
+                  <a:schemeClr val="tx1"/>
+                </a:solidFill>
+              </a:rPr>
+              <a:t>Revisé el diff del commit 1445bfe. Prueba de mutación: con la forma del original (leer y luego actualizar), 19 de 20 solicitudes fallaron; restaurado, 20 de 20.</a:t>
+            </a:r>
+            <a:endParaRPr lang="en-US" sz="1400" dirty="0"/>
+          </a:p>
+        </p:txBody>
+      </p:sp>
+    </p:spTree>
+  </p:cSld>
+  <p:clrMapOvr>
+    <a:masterClrMapping/>
+  </p:clrMapOvr>
+</p:sld>
+</file>
+
+<file path=ppt/slides/slide11.xml><?xml version="1.0" encoding="utf-8"?>
 <p:sld xmlns:a="http://schemas.openxmlformats.org/drawingml/2006/main" xmlns:r="http://schemas.openxmlformats.org/officeDocument/2006/relationships" xmlns:p="http://schemas.openxmlformats.org/presentationml/2006/main">
   <p:cSld name="Slide 10">
     <p:spTree>
@@ -2796,9 +3351,11 @@
       <p:sp>
         <p:nvSpPr>
           <p:cNvPr id="2" name="Text 0"/>
-          <p:cNvSpPr/>
+          <p:cNvSpPr>
+            <a:spLocks noGrp="1"/>
+          </p:cNvSpPr>
           <p:nvPr>
-            <p:ph idx="100" type="title" hasCustomPrompt="1"/>
+            <p:ph type="title" idx="100" hasCustomPrompt="1"/>
           </p:nvPr>
         </p:nvSpPr>
         <p:spPr>
@@ -2816,7 +3373,7 @@
           <a:bodyPr wrap="square" lIns="0" tIns="0" rIns="0" bIns="0" rtlCol="0" anchor="ctr"/>
           <a:lstStyle/>
           <a:p>
-            <a:pPr indent="0" marL="0">
+            <a:pPr marL="0" indent="0">
               <a:buNone/>
             </a:pPr>
             <a:r>
@@ -2828,7 +3385,7 @@
                 <a:ea typeface="Cambria" pitchFamily="34" charset="-122"/>
                 <a:cs typeface="Cambria" pitchFamily="34" charset="-120"/>
               </a:rPr>
-              <a:t>Demo: el flujo completo en 4 minutos</a:t>
+              <a:t>Demo: el flujo completo en 5 minutos</a:t>
             </a:r>
             <a:endParaRPr lang="en-US" sz="3400" dirty="0"/>
           </a:p>
@@ -2880,7 +3437,7 @@
           <a:bodyPr wrap="square" lIns="0" tIns="0" rIns="0" bIns="0" rtlCol="0" anchor="ctr"/>
           <a:lstStyle/>
           <a:p>
-            <a:pPr algn="ctr" indent="0" marL="0">
+            <a:pPr marL="0" indent="0" algn="ctr">
               <a:buNone/>
             </a:pPr>
             <a:r>
@@ -2916,7 +3473,7 @@
           <a:bodyPr wrap="square" lIns="0" tIns="0" rIns="0" bIns="0" rtlCol="0" anchor="ctr"/>
           <a:lstStyle/>
           <a:p>
-            <a:pPr indent="0" marL="0">
+            <a:pPr marL="0" indent="0">
               <a:buNone/>
             </a:pPr>
             <a:r>
@@ -2925,7 +3482,7 @@
                   <a:schemeClr val="tx1"/>
                 </a:solidFill>
               </a:rPr>
-              <a:t>Iniciar sesión como planificador</a:t>
+              <a:t>Swagger: las 16 operaciones de la API, protegidas con JWT</a:t>
             </a:r>
             <a:endParaRPr lang="en-US" sz="1600" dirty="0"/>
           </a:p>
@@ -2977,7 +3534,7 @@
           <a:bodyPr wrap="square" lIns="0" tIns="0" rIns="0" bIns="0" rtlCol="0" anchor="ctr"/>
           <a:lstStyle/>
           <a:p>
-            <a:pPr algn="ctr" indent="0" marL="0">
+            <a:pPr marL="0" indent="0" algn="ctr">
               <a:buNone/>
             </a:pPr>
             <a:r>
@@ -3013,7 +3570,7 @@
           <a:bodyPr wrap="square" lIns="0" tIns="0" rIns="0" bIns="0" rtlCol="0" anchor="ctr"/>
           <a:lstStyle/>
           <a:p>
-            <a:pPr indent="0" marL="0">
+            <a:pPr marL="0" indent="0">
               <a:buNone/>
             </a:pPr>
             <a:r>
@@ -3022,7 +3579,7 @@
                   <a:schemeClr val="tx1"/>
                 </a:solidFill>
               </a:rPr>
-              <a:t>Registrar un MP mensual (mostrar el error si falta el mes)</a:t>
+              <a:t>Iniciar sesión como planificador; registrar un MP mensual (error si falta el mes)</a:t>
             </a:r>
             <a:endParaRPr lang="en-US" sz="1600" dirty="0"/>
           </a:p>
@@ -3074,7 +3631,7 @@
           <a:bodyPr wrap="square" lIns="0" tIns="0" rIns="0" bIns="0" rtlCol="0" anchor="ctr"/>
           <a:lstStyle/>
           <a:p>
-            <a:pPr algn="ctr" indent="0" marL="0">
+            <a:pPr marL="0" indent="0" algn="ctr">
               <a:buNone/>
             </a:pPr>
             <a:r>
@@ -3110,7 +3667,7 @@
           <a:bodyPr wrap="square" lIns="0" tIns="0" rIns="0" bIns="0" rtlCol="0" anchor="ctr"/>
           <a:lstStyle/>
           <a:p>
-            <a:pPr indent="0" marL="0">
+            <a:pPr marL="0" indent="0">
               <a:buNone/>
             </a:pPr>
             <a:r>
@@ -3119,7 +3676,7 @@
                   <a:schemeClr val="tx1"/>
                 </a:solidFill>
               </a:rPr>
-              <a:t>Aprobar el MP y programar una fecha (probar una fecha de hoy: la rechaza)</a:t>
+              <a:t>Editar el MP, aprobarlo y programar una fecha (una fecha de hoy se rechaza)</a:t>
             </a:r>
             <a:endParaRPr lang="en-US" sz="1600" dirty="0"/>
           </a:p>
@@ -3171,7 +3728,7 @@
           <a:bodyPr wrap="square" lIns="0" tIns="0" rIns="0" bIns="0" rtlCol="0" anchor="ctr"/>
           <a:lstStyle/>
           <a:p>
-            <a:pPr algn="ctr" indent="0" marL="0">
+            <a:pPr marL="0" indent="0" algn="ctr">
               <a:buNone/>
             </a:pPr>
             <a:r>
@@ -3207,7 +3764,7 @@
           <a:bodyPr wrap="square" lIns="0" tIns="0" rIns="0" bIns="0" rtlCol="0" anchor="ctr"/>
           <a:lstStyle/>
           <a:p>
-            <a:pPr indent="0" marL="0">
+            <a:pPr marL="0" indent="0">
               <a:buNone/>
             </a:pPr>
             <a:r>
@@ -3216,7 +3773,7 @@
                   <a:schemeClr val="tx1"/>
                 </a:solidFill>
               </a:rPr>
-              <a:t>Generar la OT y ver su número</a:t>
+              <a:t>Generar la OT y ver su número único</a:t>
             </a:r>
             <a:endParaRPr lang="en-US" sz="1600" dirty="0"/>
           </a:p>
@@ -3268,7 +3825,7 @@
           <a:bodyPr wrap="square" lIns="0" tIns="0" rIns="0" bIns="0" rtlCol="0" anchor="ctr"/>
           <a:lstStyle/>
           <a:p>
-            <a:pPr algn="ctr" indent="0" marL="0">
+            <a:pPr marL="0" indent="0" algn="ctr">
               <a:buNone/>
             </a:pPr>
             <a:r>
@@ -3304,7 +3861,7 @@
           <a:bodyPr wrap="square" lIns="0" tIns="0" rIns="0" bIns="0" rtlCol="0" anchor="ctr"/>
           <a:lstStyle/>
           <a:p>
-            <a:pPr indent="0" marL="0">
+            <a:pPr marL="0" indent="0">
               <a:buNone/>
             </a:pPr>
             <a:r>
@@ -3313,7 +3870,7 @@
                   <a:schemeClr val="tx1"/>
                 </a:solidFill>
               </a:rPr>
-              <a:t>Concluir la OT y ver el historial</a:t>
+              <a:t>Concluir la OT y ver el historial de estados</a:t>
             </a:r>
             <a:endParaRPr lang="en-US" sz="1600" dirty="0"/>
           </a:p>
@@ -3365,7 +3922,7 @@
           <a:bodyPr wrap="square" lIns="0" tIns="0" rIns="0" bIns="0" rtlCol="0" anchor="ctr"/>
           <a:lstStyle/>
           <a:p>
-            <a:pPr algn="ctr" indent="0" marL="0">
+            <a:pPr marL="0" indent="0" algn="ctr">
               <a:buNone/>
             </a:pPr>
             <a:r>
@@ -3401,7 +3958,7 @@
           <a:bodyPr wrap="square" lIns="0" tIns="0" rIns="0" bIns="0" rtlCol="0" anchor="ctr"/>
           <a:lstStyle/>
           <a:p>
-            <a:pPr indent="0" marL="0">
+            <a:pPr marL="0" indent="0">
               <a:buNone/>
             </a:pPr>
             <a:r>
@@ -3410,7 +3967,7 @@
                   <a:schemeClr val="tx1"/>
                 </a:solidFill>
               </a:rPr>
-              <a:t>Planning del mes y exportación a Excel</a:t>
+              <a:t>Planning del mes y exportación de OT a Excel</a:t>
             </a:r>
             <a:endParaRPr lang="en-US" sz="1600" dirty="0"/>
           </a:p>
@@ -3462,7 +4019,7 @@
           <a:bodyPr wrap="square" lIns="0" tIns="0" rIns="0" bIns="0" rtlCol="0" anchor="ctr"/>
           <a:lstStyle/>
           <a:p>
-            <a:pPr algn="ctr" indent="0" marL="0">
+            <a:pPr marL="0" indent="0" algn="ctr">
               <a:buNone/>
             </a:pPr>
             <a:r>
@@ -3498,7 +4055,7 @@
           <a:bodyPr wrap="square" lIns="0" tIns="0" rIns="0" bIns="0" rtlCol="0" anchor="ctr"/>
           <a:lstStyle/>
           <a:p>
-            <a:pPr indent="0" marL="0">
+            <a:pPr marL="0" indent="0">
               <a:buNone/>
             </a:pPr>
             <a:r>
@@ -3507,7 +4064,7 @@
                   <a:schemeClr val="tx1"/>
                 </a:solidFill>
               </a:rPr>
-              <a:t>Entrar como especialista: consulta, pero sin botones de escritura</a:t>
+              <a:t>Entrar como especialista: solo consulta, sin botones de escritura ni planning</a:t>
             </a:r>
             <a:endParaRPr lang="en-US" sz="1600" dirty="0"/>
           </a:p>
@@ -3561,7 +4118,7 @@
           <a:bodyPr wrap="square" lIns="0" tIns="0" rIns="0" bIns="0" rtlCol="0" anchor="t"/>
           <a:lstStyle/>
           <a:p>
-            <a:pPr indent="0" marL="0">
+            <a:pPr marL="0" indent="0">
               <a:buNone/>
             </a:pPr>
             <a:r>
@@ -3597,7 +4154,7 @@
           <a:bodyPr wrap="square" lIns="0" tIns="0" rIns="0" bIns="0" rtlCol="0" anchor="t"/>
           <a:lstStyle/>
           <a:p>
-            <a:pPr indent="0" marL="0">
+            <a:pPr marL="0" indent="0">
               <a:buNone/>
             </a:pPr>
             <a:r>
@@ -3606,7 +4163,7 @@
                   <a:schemeClr val="tx1"/>
                 </a:solidFill>
               </a:rPr>
-              <a:t>Si la web falla: el mismo flujo en Swagger (http://localhost:5300/swagger) o con docs/api/sisman.http</a:t>
+              <a:t>Si la web falla: el mismo flujo en Swagger (http://localhost:5300/swagger) o con docs/api/sisman.http. Último recurso: capturas 03 a 07.</a:t>
             </a:r>
             <a:endParaRPr lang="en-US" sz="1400" dirty="0"/>
           </a:p>
@@ -3614,7 +4171,7 @@
       </p:sp>
       <p:sp>
         <p:nvSpPr>
-          <p:cNvPr id="25" name="Slide Number Placeholder 0"/>
+          <p:cNvPr id="27" name="Slide Number Placeholder 0"/>
           <p:cNvSpPr>
             <a:spLocks noGrp="1"/>
           </p:cNvSpPr>
@@ -3632,7 +4189,7 @@
           </a:prstGeom>
           <a:extLst>
             <a:ext uri="{C572A759-6A51-4108-AA02-DFA0A04FC94B}">
-              <ma14:wrappingTextBoxFlag xmlns:ma14="http://schemas.microsoft.com/office/mac/drawingml/2011/main" val="0"/>
+              <ma14:wrappingTextBoxFlag xmlns:ma14="http://schemas.microsoft.com/office/mac/drawingml/2011/main" xmlns="" val="0"/>
             </a:ext>
           </a:extLst>
         </p:spPr>
@@ -3650,8 +4207,8 @@
           <a:p>
             <a:pPr algn="r"/>
             <a:fld id="{F7021451-1387-4CA6-816F-3879F97B5CBC}" type="slidenum">
-              <a:rPr b="0" lang="en-US"/>
-              <a:t>10</a:t>
+              <a:rPr lang="en-US" b="0"/>
+              <a:t>11</a:t>
             </a:fld>
             <a:endParaRPr lang="en-US"/>
           </a:p>
@@ -3665,7 +4222,7 @@
 </p:sld>
 </file>
 
-<file path=ppt/slides/slide11.xml><?xml version="1.0" encoding="utf-8"?>
+<file path=ppt/slides/slide12.xml><?xml version="1.0" encoding="utf-8"?>
 <p:sld xmlns:a="http://schemas.openxmlformats.org/drawingml/2006/main" xmlns:r="http://schemas.openxmlformats.org/officeDocument/2006/relationships" xmlns:p="http://schemas.openxmlformats.org/presentationml/2006/main">
   <p:cSld name="Slide 11">
     <p:spTree>
@@ -3685,9 +4242,11 @@
       <p:sp>
         <p:nvSpPr>
           <p:cNvPr id="2" name="Text 0"/>
-          <p:cNvSpPr/>
+          <p:cNvSpPr>
+            <a:spLocks noGrp="1"/>
+          </p:cNvSpPr>
           <p:nvPr>
-            <p:ph idx="100" type="title" hasCustomPrompt="1"/>
+            <p:ph type="title" idx="100" hasCustomPrompt="1"/>
           </p:nvPr>
         </p:nvSpPr>
         <p:spPr>
@@ -3705,7 +4264,7 @@
           <a:bodyPr wrap="square" lIns="0" tIns="0" rIns="0" bIns="0" rtlCol="0" anchor="ctr"/>
           <a:lstStyle/>
           <a:p>
-            <a:pPr indent="0" marL="0">
+            <a:pPr marL="0" indent="0">
               <a:buNone/>
             </a:pPr>
             <a:r>
@@ -3771,7 +4330,7 @@
           <a:bodyPr wrap="square" lIns="0" tIns="0" rIns="0" bIns="0" rtlCol="0" anchor="t"/>
           <a:lstStyle/>
           <a:p>
-            <a:pPr indent="0" marL="0">
+            <a:pPr marL="0" indent="0">
               <a:buNone/>
             </a:pPr>
             <a:r>
@@ -3875,6 +4434,24 @@
                 </a:solidFill>
               </a:rPr>
               <a:t>Con la spec como contexto, la IA acelera; sin ella, inventa</a:t>
+            </a:r>
+            <a:endParaRPr lang="en-US" sz="1500" dirty="0"/>
+          </a:p>
+          <a:p>
+            <a:pPr marL="342900" indent="-342900">
+              <a:spcAft>
+                <a:spcPts val="1000"/>
+              </a:spcAft>
+              <a:buSzPct val="100000"/>
+              <a:buChar char="•"/>
+            </a:pPr>
+            <a:r>
+              <a:rPr lang="en-US" sz="1500" dirty="0">
+                <a:solidFill>
+                  <a:schemeClr val="tx1"/>
+                </a:solidFill>
+              </a:rPr>
+              <a:t>El entorno se decide el primer día: Docker cambió tres veces</a:t>
             </a:r>
             <a:endParaRPr lang="en-US" sz="1500" dirty="0"/>
           </a:p>
@@ -3928,7 +4505,7 @@
           <a:bodyPr wrap="square" lIns="0" tIns="0" rIns="0" bIns="0" rtlCol="0" anchor="t"/>
           <a:lstStyle/>
           <a:p>
-            <a:pPr indent="0" marL="0">
+            <a:pPr marL="0" indent="0">
               <a:buNone/>
             </a:pPr>
             <a:r>
@@ -3977,7 +4554,7 @@
                   <a:schemeClr val="tx1"/>
                 </a:solidFill>
               </a:rPr>
-              <a:t>Validar con un usuario las reglas marcadas «a validar» (RN-15, RN-16, RN-23, RN-37)</a:t>
+              <a:t>Validar con usuarios de planta las reglas que decidí como responsable (RN-15, RN-16, RN-22, RN-23, RN-37)</a:t>
             </a:r>
             <a:endParaRPr lang="en-US" sz="1500" dirty="0"/>
           </a:p>
@@ -3995,7 +4572,7 @@
                   <a:schemeClr val="tx1"/>
                 </a:solidFill>
               </a:rPr>
-              <a:t>Presentación en vivo con LocalDB (sin Docker, ADR-007)</a:t>
+              <a:t>Docker para levantar base, API y web con un comando (hoy: LocalDB, ADR-007)</a:t>
             </a:r>
             <a:endParaRPr lang="en-US" sz="1500" dirty="0"/>
           </a:p>
@@ -4057,7 +4634,7 @@
           </a:prstGeom>
           <a:extLst>
             <a:ext uri="{C572A759-6A51-4108-AA02-DFA0A04FC94B}">
-              <ma14:wrappingTextBoxFlag xmlns:ma14="http://schemas.microsoft.com/office/mac/drawingml/2011/main" val="0"/>
+              <ma14:wrappingTextBoxFlag xmlns:ma14="http://schemas.microsoft.com/office/mac/drawingml/2011/main" xmlns="" val="0"/>
             </a:ext>
           </a:extLst>
         </p:spPr>
@@ -4075,8 +4652,8 @@
           <a:p>
             <a:pPr algn="r"/>
             <a:fld id="{F7021451-1387-4CA6-816F-3879F97B5CBC}" type="slidenum">
-              <a:rPr b="0" lang="en-US"/>
-              <a:t>11</a:t>
+              <a:rPr lang="en-US" b="0"/>
+              <a:t>12</a:t>
             </a:fld>
             <a:endParaRPr lang="en-US"/>
           </a:p>
@@ -4090,7 +4667,7 @@
 </p:sld>
 </file>
 
-<file path=ppt/slides/slide12.xml><?xml version="1.0" encoding="utf-8"?>
+<file path=ppt/slides/slide13.xml><?xml version="1.0" encoding="utf-8"?>
 <p:sld xmlns:a="http://schemas.openxmlformats.org/drawingml/2006/main" xmlns:r="http://schemas.openxmlformats.org/officeDocument/2006/relationships" xmlns:p="http://schemas.openxmlformats.org/presentationml/2006/main">
   <p:cSld name="Slide 12">
     <p:spTree>
@@ -4110,9 +4687,11 @@
       <p:sp>
         <p:nvSpPr>
           <p:cNvPr id="2" name="Text 0"/>
-          <p:cNvSpPr/>
+          <p:cNvSpPr>
+            <a:spLocks noGrp="1"/>
+          </p:cNvSpPr>
           <p:nvPr>
-            <p:ph idx="100" type="title" hasCustomPrompt="1"/>
+            <p:ph type="title" idx="100" hasCustomPrompt="1"/>
           </p:nvPr>
         </p:nvSpPr>
         <p:spPr>
@@ -4130,7 +4709,7 @@
           <a:bodyPr wrap="square" lIns="0" tIns="0" rIns="0" bIns="0" rtlCol="0" anchor="b"/>
           <a:lstStyle/>
           <a:p>
-            <a:pPr algn="l" indent="0" marL="0">
+            <a:pPr marL="0" indent="0" algn="l">
               <a:buNone/>
             </a:pPr>
             <a:r>
@@ -4151,9 +4730,11 @@
       <p:sp>
         <p:nvSpPr>
           <p:cNvPr id="3" name="Text 0"/>
-          <p:cNvSpPr/>
+          <p:cNvSpPr>
+            <a:spLocks noGrp="1"/>
+          </p:cNvSpPr>
           <p:nvPr>
-            <p:ph idx="101" type="body" hasCustomPrompt="1"/>
+            <p:ph type="body" idx="101" hasCustomPrompt="1"/>
           </p:nvPr>
         </p:nvSpPr>
         <p:spPr>
@@ -4171,7 +4752,7 @@
           <a:bodyPr wrap="square" lIns="0" tIns="0" rIns="0" bIns="0" rtlCol="0" anchor="t"/>
           <a:lstStyle/>
           <a:p>
-            <a:pPr indent="0" marL="0">
+            <a:pPr marL="0" indent="0">
               <a:buNone/>
             </a:pPr>
             <a:r>
@@ -4185,7 +4766,7 @@
             <a:endParaRPr lang="en-US" sz="2000" dirty="0"/>
           </a:p>
           <a:p>
-            <a:pPr indent="0" marL="0">
+            <a:pPr marL="0" indent="0">
               <a:buNone/>
             </a:pPr>
             <a:r>
@@ -4194,7 +4775,7 @@
                   <a:schemeClr val="accent1"/>
                 </a:solidFill>
               </a:rPr>
-              <a:t>Repositorio sisman-mantenimiento · README, specs/, docs/ (ADR, trazabilidad, calidad, evidencias de IA)</a:t>
+              <a:t>github.com/AngelHermozaSalasEDP/sisman-mantenimiento · README, specs/, docs/ (ADR, trazabilidad, calidad, evidencias de IA)</a:t>
             </a:r>
             <a:endParaRPr lang="en-US" sz="2000" dirty="0"/>
           </a:p>
@@ -4228,9 +4809,11 @@
       <p:sp>
         <p:nvSpPr>
           <p:cNvPr id="2" name="Text 0"/>
-          <p:cNvSpPr/>
+          <p:cNvSpPr>
+            <a:spLocks noGrp="1"/>
+          </p:cNvSpPr>
           <p:nvPr>
-            <p:ph idx="100" type="title" hasCustomPrompt="1"/>
+            <p:ph type="title" idx="100" hasCustomPrompt="1"/>
           </p:nvPr>
         </p:nvSpPr>
         <p:spPr>
@@ -4248,7 +4831,7 @@
           <a:bodyPr wrap="square" lIns="0" tIns="0" rIns="0" bIns="0" rtlCol="0" anchor="ctr"/>
           <a:lstStyle/>
           <a:p>
-            <a:pPr indent="0" marL="0">
+            <a:pPr marL="0" indent="0">
               <a:buNone/>
             </a:pPr>
             <a:r>
@@ -4314,7 +4897,7 @@
           <a:bodyPr wrap="square" lIns="0" tIns="0" rIns="0" bIns="0" rtlCol="0" anchor="t"/>
           <a:lstStyle/>
           <a:p>
-            <a:pPr indent="0" marL="0">
+            <a:pPr marL="0" indent="0">
               <a:buNone/>
             </a:pPr>
             <a:r>
@@ -4353,7 +4936,7 @@
           <a:bodyPr wrap="square" lIns="0" tIns="0" rIns="0" bIns="0" rtlCol="0" anchor="t"/>
           <a:lstStyle/>
           <a:p>
-            <a:pPr indent="0" marL="0">
+            <a:pPr marL="0" indent="0">
               <a:buNone/>
             </a:pPr>
             <a:r>
@@ -4416,7 +4999,7 @@
           <a:bodyPr wrap="square" lIns="0" tIns="0" rIns="0" bIns="0" rtlCol="0" anchor="t"/>
           <a:lstStyle/>
           <a:p>
-            <a:pPr indent="0" marL="0">
+            <a:pPr marL="0" indent="0">
               <a:buNone/>
             </a:pPr>
             <a:r>
@@ -4455,7 +5038,7 @@
           <a:bodyPr wrap="square" lIns="0" tIns="0" rIns="0" bIns="0" rtlCol="0" anchor="t"/>
           <a:lstStyle/>
           <a:p>
-            <a:pPr indent="0" marL="0">
+            <a:pPr marL="0" indent="0">
               <a:buNone/>
             </a:pPr>
             <a:r>
@@ -4518,7 +5101,7 @@
           <a:bodyPr wrap="square" lIns="0" tIns="0" rIns="0" bIns="0" rtlCol="0" anchor="t"/>
           <a:lstStyle/>
           <a:p>
-            <a:pPr indent="0" marL="0">
+            <a:pPr marL="0" indent="0">
               <a:buNone/>
             </a:pPr>
             <a:r>
@@ -4557,7 +5140,7 @@
           <a:bodyPr wrap="square" lIns="0" tIns="0" rIns="0" bIns="0" rtlCol="0" anchor="t"/>
           <a:lstStyle/>
           <a:p>
-            <a:pPr indent="0" marL="0">
+            <a:pPr marL="0" indent="0">
               <a:buNone/>
             </a:pPr>
             <a:r>
@@ -4566,7 +5149,7 @@
                   <a:schemeClr val="tx1"/>
                 </a:solidFill>
               </a:rPr>
-              <a:t>pesaba la lista de OT, con 26 000 filas; la queja principal de los usuarios era la lentitud</a:t>
+              <a:t>pesaba la lista de OT (672 filas en pantalla); la queja principal de los usuarios era la lentitud</a:t>
             </a:r>
             <a:endParaRPr lang="en-US" sz="1500" dirty="0"/>
           </a:p>
@@ -4620,7 +5203,7 @@
           <a:bodyPr wrap="square" lIns="0" tIns="0" rIns="0" bIns="0" rtlCol="0" anchor="t"/>
           <a:lstStyle/>
           <a:p>
-            <a:pPr indent="0" marL="0">
+            <a:pPr marL="0" indent="0">
               <a:buNone/>
             </a:pPr>
             <a:r>
@@ -4632,7 +5215,7 @@
                 <a:ea typeface="Cambria" pitchFamily="34" charset="-122"/>
                 <a:cs typeface="Cambria" pitchFamily="34" charset="-120"/>
               </a:rPr>
-              <a:t>9 de 11</a:t>
+              <a:t>Sin sesión</a:t>
             </a:r>
             <a:endParaRPr lang="en-US" sz="3600" dirty="0"/>
           </a:p>
@@ -4659,7 +5242,7 @@
           <a:bodyPr wrap="square" lIns="0" tIns="0" rIns="0" bIns="0" rtlCol="0" anchor="t"/>
           <a:lstStyle/>
           <a:p>
-            <a:pPr indent="0" marL="0">
+            <a:pPr marL="0" indent="0">
               <a:buNone/>
             </a:pPr>
             <a:r>
@@ -4668,7 +5251,7 @@
                   <a:schemeClr val="tx1"/>
                 </a:solidFill>
               </a:rPr>
-              <a:t>pantallas se abrían sin iniciar sesión, y cualquier usuario veía todo</a:t>
+              <a:t>se abrían las pantallas de SISMAN (solo 2 de las probadas pedían login), y cualquier usuario veía todo</a:t>
             </a:r>
             <a:endParaRPr lang="en-US" sz="1500" dirty="0"/>
           </a:p>
@@ -4695,7 +5278,7 @@
           <a:bodyPr wrap="square" lIns="0" tIns="0" rIns="0" bIns="0" rtlCol="0" anchor="t"/>
           <a:lstStyle/>
           <a:p>
-            <a:pPr indent="0" marL="0">
+            <a:pPr marL="0" indent="0">
               <a:buNone/>
             </a:pPr>
             <a:r>
@@ -4730,7 +5313,7 @@
           </a:prstGeom>
           <a:extLst>
             <a:ext uri="{C572A759-6A51-4108-AA02-DFA0A04FC94B}">
-              <ma14:wrappingTextBoxFlag xmlns:ma14="http://schemas.microsoft.com/office/mac/drawingml/2011/main" val="0"/>
+              <ma14:wrappingTextBoxFlag xmlns:ma14="http://schemas.microsoft.com/office/mac/drawingml/2011/main" xmlns="" val="0"/>
             </a:ext>
           </a:extLst>
         </p:spPr>
@@ -4748,7 +5331,7 @@
           <a:p>
             <a:pPr algn="r"/>
             <a:fld id="{F7021451-1387-4CA6-816F-3879F97B5CBC}" type="slidenum">
-              <a:rPr b="0" lang="en-US"/>
+              <a:rPr lang="en-US" b="0"/>
               <a:t>2</a:t>
             </a:fld>
             <a:endParaRPr lang="en-US"/>
@@ -4783,9 +5366,11 @@
       <p:sp>
         <p:nvSpPr>
           <p:cNvPr id="2" name="Text 0"/>
-          <p:cNvSpPr/>
+          <p:cNvSpPr>
+            <a:spLocks noGrp="1"/>
+          </p:cNvSpPr>
           <p:nvPr>
-            <p:ph idx="100" type="title" hasCustomPrompt="1"/>
+            <p:ph type="title" idx="100" hasCustomPrompt="1"/>
           </p:nvPr>
         </p:nvSpPr>
         <p:spPr>
@@ -4803,7 +5388,7 @@
           <a:bodyPr wrap="square" lIns="0" tIns="0" rIns="0" bIns="0" rtlCol="0" anchor="ctr"/>
           <a:lstStyle/>
           <a:p>
-            <a:pPr indent="0" marL="0">
+            <a:pPr marL="0" indent="0">
               <a:buNone/>
             </a:pPr>
             <a:r>
@@ -4894,7 +5479,7 @@
           <a:bodyPr wrap="square" lIns="0" tIns="0" rIns="0" bIns="0" rtlCol="0" anchor="ctr"/>
           <a:lstStyle/>
           <a:p>
-            <a:pPr algn="ctr" indent="0" marL="0">
+            <a:pPr marL="0" indent="0" algn="ctr">
               <a:buNone/>
             </a:pPr>
             <a:r>
@@ -4930,7 +5515,7 @@
           <a:bodyPr wrap="square" lIns="0" tIns="0" rIns="0" bIns="0" rtlCol="0" anchor="t"/>
           <a:lstStyle/>
           <a:p>
-            <a:pPr indent="0" marL="0">
+            <a:pPr marL="0" indent="0">
               <a:buNone/>
             </a:pPr>
             <a:r>
@@ -4966,7 +5551,7 @@
           <a:bodyPr wrap="square" lIns="0" tIns="0" rIns="0" bIns="0" rtlCol="0" anchor="t"/>
           <a:lstStyle/>
           <a:p>
-            <a:pPr indent="0" marL="0">
+            <a:pPr marL="0" indent="0">
               <a:buNone/>
             </a:pPr>
             <a:r>
@@ -5078,7 +5663,7 @@
           <a:bodyPr wrap="square" lIns="0" tIns="0" rIns="0" bIns="0" rtlCol="0" anchor="ctr"/>
           <a:lstStyle/>
           <a:p>
-            <a:pPr algn="ctr" indent="0" marL="0">
+            <a:pPr marL="0" indent="0" algn="ctr">
               <a:buNone/>
             </a:pPr>
             <a:r>
@@ -5114,7 +5699,7 @@
           <a:bodyPr wrap="square" lIns="0" tIns="0" rIns="0" bIns="0" rtlCol="0" anchor="t"/>
           <a:lstStyle/>
           <a:p>
-            <a:pPr indent="0" marL="0">
+            <a:pPr marL="0" indent="0">
               <a:buNone/>
             </a:pPr>
             <a:r>
@@ -5150,7 +5735,7 @@
           <a:bodyPr wrap="square" lIns="0" tIns="0" rIns="0" bIns="0" rtlCol="0" anchor="t"/>
           <a:lstStyle/>
           <a:p>
-            <a:pPr indent="0" marL="0">
+            <a:pPr marL="0" indent="0">
               <a:buNone/>
             </a:pPr>
             <a:r>
@@ -5262,7 +5847,7 @@
           <a:bodyPr wrap="square" lIns="0" tIns="0" rIns="0" bIns="0" rtlCol="0" anchor="ctr"/>
           <a:lstStyle/>
           <a:p>
-            <a:pPr algn="ctr" indent="0" marL="0">
+            <a:pPr marL="0" indent="0" algn="ctr">
               <a:buNone/>
             </a:pPr>
             <a:r>
@@ -5298,7 +5883,7 @@
           <a:bodyPr wrap="square" lIns="0" tIns="0" rIns="0" bIns="0" rtlCol="0" anchor="t"/>
           <a:lstStyle/>
           <a:p>
-            <a:pPr indent="0" marL="0">
+            <a:pPr marL="0" indent="0">
               <a:buNone/>
             </a:pPr>
             <a:r>
@@ -5334,7 +5919,7 @@
           <a:bodyPr wrap="square" lIns="0" tIns="0" rIns="0" bIns="0" rtlCol="0" anchor="t"/>
           <a:lstStyle/>
           <a:p>
-            <a:pPr indent="0" marL="0">
+            <a:pPr marL="0" indent="0">
               <a:buNone/>
             </a:pPr>
             <a:r>
@@ -5370,7 +5955,7 @@
           <a:bodyPr wrap="square" lIns="0" tIns="0" rIns="0" bIns="0" rtlCol="0" anchor="t"/>
           <a:lstStyle/>
           <a:p>
-            <a:pPr indent="0" marL="0">
+            <a:pPr marL="0" indent="0">
               <a:buNone/>
             </a:pPr>
             <a:r>
@@ -5406,7 +5991,7 @@
           <a:bodyPr wrap="square" lIns="0" tIns="0" rIns="0" bIns="0" rtlCol="0" anchor="t"/>
           <a:lstStyle/>
           <a:p>
-            <a:pPr indent="0" marL="0">
+            <a:pPr marL="0" indent="0">
               <a:buNone/>
             </a:pPr>
             <a:r>
@@ -5442,7 +6027,7 @@
           <a:bodyPr wrap="square" lIns="0" tIns="0" rIns="0" bIns="0" rtlCol="0" anchor="t"/>
           <a:lstStyle/>
           <a:p>
-            <a:pPr indent="0" marL="0">
+            <a:pPr marL="0" indent="0">
               <a:buNone/>
             </a:pPr>
             <a:r>
@@ -5478,7 +6063,7 @@
           <a:bodyPr wrap="square" lIns="0" tIns="0" rIns="0" bIns="0" rtlCol="0" anchor="t"/>
           <a:lstStyle/>
           <a:p>
-            <a:pPr indent="0" marL="0">
+            <a:pPr marL="0" indent="0">
               <a:buNone/>
             </a:pPr>
             <a:r>
@@ -5514,7 +6099,7 @@
           <a:bodyPr wrap="square" lIns="0" tIns="0" rIns="0" bIns="0" rtlCol="0" anchor="t"/>
           <a:lstStyle/>
           <a:p>
-            <a:pPr indent="0" marL="0">
+            <a:pPr marL="0" indent="0">
               <a:buNone/>
             </a:pPr>
             <a:r>
@@ -5550,7 +6135,7 @@
           <a:bodyPr wrap="square" lIns="0" tIns="0" rIns="0" bIns="0" rtlCol="0" anchor="t"/>
           <a:lstStyle/>
           <a:p>
-            <a:pPr indent="0" marL="0">
+            <a:pPr marL="0" indent="0">
               <a:buNone/>
             </a:pPr>
             <a:r>
@@ -5567,7 +6152,7 @@
       </p:sp>
       <p:sp>
         <p:nvSpPr>
-          <p:cNvPr id="25" name="Slide Number Placeholder 0"/>
+          <p:cNvPr id="26" name="Slide Number Placeholder 0"/>
           <p:cNvSpPr>
             <a:spLocks noGrp="1"/>
           </p:cNvSpPr>
@@ -5585,7 +6170,7 @@
           </a:prstGeom>
           <a:extLst>
             <a:ext uri="{C572A759-6A51-4108-AA02-DFA0A04FC94B}">
-              <ma14:wrappingTextBoxFlag xmlns:ma14="http://schemas.microsoft.com/office/mac/drawingml/2011/main" val="0"/>
+              <ma14:wrappingTextBoxFlag xmlns:ma14="http://schemas.microsoft.com/office/mac/drawingml/2011/main" xmlns="" val="0"/>
             </a:ext>
           </a:extLst>
         </p:spPr>
@@ -5603,7 +6188,7 @@
           <a:p>
             <a:pPr algn="r"/>
             <a:fld id="{F7021451-1387-4CA6-816F-3879F97B5CBC}" type="slidenum">
-              <a:rPr b="0" lang="en-US"/>
+              <a:rPr lang="en-US" b="0"/>
               <a:t>3</a:t>
             </a:fld>
             <a:endParaRPr lang="en-US"/>
@@ -5638,9 +6223,11 @@
       <p:sp>
         <p:nvSpPr>
           <p:cNvPr id="2" name="Text 0"/>
-          <p:cNvSpPr/>
+          <p:cNvSpPr>
+            <a:spLocks noGrp="1"/>
+          </p:cNvSpPr>
           <p:nvPr>
-            <p:ph idx="100" type="title" hasCustomPrompt="1"/>
+            <p:ph type="title" idx="100" hasCustomPrompt="1"/>
           </p:nvPr>
         </p:nvSpPr>
         <p:spPr>
@@ -5658,7 +6245,7 @@
           <a:bodyPr wrap="square" lIns="0" tIns="0" rIns="0" bIns="0" rtlCol="0" anchor="ctr"/>
           <a:lstStyle/>
           <a:p>
-            <a:pPr indent="0" marL="0">
+            <a:pPr marL="0" indent="0">
               <a:buNone/>
             </a:pPr>
             <a:r>
@@ -5697,7 +6284,7 @@
           <a:bodyPr wrap="square" lIns="0" tIns="0" rIns="0" bIns="0" rtlCol="0" anchor="t"/>
           <a:lstStyle/>
           <a:p>
-            <a:pPr indent="0" marL="0">
+            <a:pPr marL="0" indent="0">
               <a:buNone/>
             </a:pPr>
             <a:r>
@@ -5736,7 +6323,7 @@
           <a:bodyPr wrap="square" lIns="0" tIns="0" rIns="0" bIns="0" rtlCol="0" anchor="t"/>
           <a:lstStyle/>
           <a:p>
-            <a:pPr indent="0" marL="0">
+            <a:pPr marL="0" indent="0">
               <a:buNone/>
             </a:pPr>
             <a:r>
@@ -5772,7 +6359,7 @@
           <a:bodyPr wrap="square" lIns="0" tIns="0" rIns="0" bIns="0" rtlCol="0" anchor="t"/>
           <a:lstStyle/>
           <a:p>
-            <a:pPr indent="0" marL="0">
+            <a:pPr marL="0" indent="0">
               <a:buNone/>
             </a:pPr>
             <a:r>
@@ -5811,7 +6398,7 @@
           <a:bodyPr wrap="square" lIns="0" tIns="0" rIns="0" bIns="0" rtlCol="0" anchor="t"/>
           <a:lstStyle/>
           <a:p>
-            <a:pPr indent="0" marL="0">
+            <a:pPr marL="0" indent="0">
               <a:buNone/>
             </a:pPr>
             <a:r>
@@ -5847,7 +6434,7 @@
           <a:bodyPr wrap="square" lIns="0" tIns="0" rIns="0" bIns="0" rtlCol="0" anchor="t"/>
           <a:lstStyle/>
           <a:p>
-            <a:pPr indent="0" marL="0">
+            <a:pPr marL="0" indent="0">
               <a:buNone/>
             </a:pPr>
             <a:r>
@@ -5886,7 +6473,7 @@
           <a:bodyPr wrap="square" lIns="0" tIns="0" rIns="0" bIns="0" rtlCol="0" anchor="t"/>
           <a:lstStyle/>
           <a:p>
-            <a:pPr indent="0" marL="0">
+            <a:pPr marL="0" indent="0">
               <a:buNone/>
             </a:pPr>
             <a:r>
@@ -5922,7 +6509,7 @@
           <a:bodyPr wrap="square" lIns="0" tIns="0" rIns="0" bIns="0" rtlCol="0" anchor="t"/>
           <a:lstStyle/>
           <a:p>
-            <a:pPr indent="0" marL="0">
+            <a:pPr marL="0" indent="0">
               <a:buNone/>
             </a:pPr>
             <a:r>
@@ -5961,7 +6548,7 @@
           <a:bodyPr wrap="square" lIns="0" tIns="0" rIns="0" bIns="0" rtlCol="0" anchor="t"/>
           <a:lstStyle/>
           <a:p>
-            <a:pPr indent="0" marL="0">
+            <a:pPr marL="0" indent="0">
               <a:buNone/>
             </a:pPr>
             <a:r>
@@ -5997,7 +6584,7 @@
           <a:bodyPr wrap="square" lIns="0" tIns="0" rIns="0" bIns="0" rtlCol="0" anchor="t"/>
           <a:lstStyle/>
           <a:p>
-            <a:pPr indent="0" marL="0">
+            <a:pPr marL="0" indent="0">
               <a:buNone/>
             </a:pPr>
             <a:r>
@@ -6009,7 +6596,7 @@
                 <a:ea typeface="Cambria" pitchFamily="34" charset="-122"/>
                 <a:cs typeface="Cambria" pitchFamily="34" charset="-120"/>
               </a:rPr>
-              <a:t>34</a:t>
+              <a:t>35</a:t>
             </a:r>
             <a:endParaRPr lang="en-US" sz="4800" dirty="0"/>
           </a:p>
@@ -6036,7 +6623,7 @@
           <a:bodyPr wrap="square" lIns="0" tIns="0" rIns="0" bIns="0" rtlCol="0" anchor="t"/>
           <a:lstStyle/>
           <a:p>
-            <a:pPr indent="0" marL="0">
+            <a:pPr marL="0" indent="0">
               <a:buNone/>
             </a:pPr>
             <a:r>
@@ -6072,7 +6659,7 @@
           <a:bodyPr wrap="square" lIns="0" tIns="0" rIns="0" bIns="0" rtlCol="0" anchor="t"/>
           <a:lstStyle/>
           <a:p>
-            <a:pPr indent="0" marL="0">
+            <a:pPr marL="0" indent="0">
               <a:buNone/>
             </a:pPr>
             <a:r>
@@ -6135,7 +6722,7 @@
           <a:bodyPr wrap="square" lIns="0" tIns="0" rIns="0" bIns="0" rtlCol="0" anchor="ctr"/>
           <a:lstStyle/>
           <a:p>
-            <a:pPr algn="ctr" indent="0" marL="0">
+            <a:pPr marL="0" indent="0" algn="ctr">
               <a:buNone/>
             </a:pPr>
             <a:r>
@@ -6222,7 +6809,7 @@
           <a:bodyPr wrap="square" lIns="0" tIns="0" rIns="0" bIns="0" rtlCol="0" anchor="ctr"/>
           <a:lstStyle/>
           <a:p>
-            <a:pPr algn="ctr" indent="0" marL="0">
+            <a:pPr marL="0" indent="0" algn="ctr">
               <a:buNone/>
             </a:pPr>
             <a:r>
@@ -6309,7 +6896,7 @@
           <a:bodyPr wrap="square" lIns="0" tIns="0" rIns="0" bIns="0" rtlCol="0" anchor="ctr"/>
           <a:lstStyle/>
           <a:p>
-            <a:pPr algn="ctr" indent="0" marL="0">
+            <a:pPr marL="0" indent="0" algn="ctr">
               <a:buNone/>
             </a:pPr>
             <a:r>
@@ -6396,7 +6983,7 @@
           <a:bodyPr wrap="square" lIns="0" tIns="0" rIns="0" bIns="0" rtlCol="0" anchor="ctr"/>
           <a:lstStyle/>
           <a:p>
-            <a:pPr algn="ctr" indent="0" marL="0">
+            <a:pPr marL="0" indent="0" algn="ctr">
               <a:buNone/>
             </a:pPr>
             <a:r>
@@ -6483,7 +7070,7 @@
           <a:bodyPr wrap="square" lIns="0" tIns="0" rIns="0" bIns="0" rtlCol="0" anchor="ctr"/>
           <a:lstStyle/>
           <a:p>
-            <a:pPr algn="ctr" indent="0" marL="0">
+            <a:pPr marL="0" indent="0" algn="ctr">
               <a:buNone/>
             </a:pPr>
             <a:r>
@@ -6570,7 +7157,7 @@
           <a:bodyPr wrap="square" lIns="0" tIns="0" rIns="0" bIns="0" rtlCol="0" anchor="ctr"/>
           <a:lstStyle/>
           <a:p>
-            <a:pPr algn="ctr" indent="0" marL="0">
+            <a:pPr marL="0" indent="0" algn="ctr">
               <a:buNone/>
             </a:pPr>
             <a:r>
@@ -6657,7 +7244,7 @@
           <a:bodyPr wrap="square" lIns="0" tIns="0" rIns="0" bIns="0" rtlCol="0" anchor="ctr"/>
           <a:lstStyle/>
           <a:p>
-            <a:pPr algn="ctr" indent="0" marL="0">
+            <a:pPr marL="0" indent="0" algn="ctr">
               <a:buNone/>
             </a:pPr>
             <a:r>
@@ -6693,7 +7280,7 @@
           <a:bodyPr wrap="square" lIns="0" tIns="0" rIns="0" bIns="0" rtlCol="0" anchor="t"/>
           <a:lstStyle/>
           <a:p>
-            <a:pPr indent="0" marL="0">
+            <a:pPr marL="0" indent="0">
               <a:buNone/>
             </a:pPr>
             <a:r>
@@ -6710,7 +7297,7 @@
       </p:sp>
       <p:sp>
         <p:nvSpPr>
-          <p:cNvPr id="25" name="Slide Number Placeholder 0"/>
+          <p:cNvPr id="35" name="Slide Number Placeholder 0"/>
           <p:cNvSpPr>
             <a:spLocks noGrp="1"/>
           </p:cNvSpPr>
@@ -6728,7 +7315,7 @@
           </a:prstGeom>
           <a:extLst>
             <a:ext uri="{C572A759-6A51-4108-AA02-DFA0A04FC94B}">
-              <ma14:wrappingTextBoxFlag xmlns:ma14="http://schemas.microsoft.com/office/mac/drawingml/2011/main" val="0"/>
+              <ma14:wrappingTextBoxFlag xmlns:ma14="http://schemas.microsoft.com/office/mac/drawingml/2011/main" xmlns="" val="0"/>
             </a:ext>
           </a:extLst>
         </p:spPr>
@@ -6746,7 +7333,7 @@
           <a:p>
             <a:pPr algn="r"/>
             <a:fld id="{F7021451-1387-4CA6-816F-3879F97B5CBC}" type="slidenum">
-              <a:rPr b="0" lang="en-US"/>
+              <a:rPr lang="en-US" b="0"/>
               <a:t>4</a:t>
             </a:fld>
             <a:endParaRPr lang="en-US"/>
@@ -6781,9 +7368,11 @@
       <p:sp>
         <p:nvSpPr>
           <p:cNvPr id="2" name="Text 0"/>
-          <p:cNvSpPr/>
+          <p:cNvSpPr>
+            <a:spLocks noGrp="1"/>
+          </p:cNvSpPr>
           <p:nvPr>
-            <p:ph idx="100" type="title" hasCustomPrompt="1"/>
+            <p:ph type="title" idx="100" hasCustomPrompt="1"/>
           </p:nvPr>
         </p:nvSpPr>
         <p:spPr>
@@ -6801,7 +7390,7 @@
           <a:bodyPr wrap="square" lIns="0" tIns="0" rIns="0" bIns="0" rtlCol="0" anchor="ctr"/>
           <a:lstStyle/>
           <a:p>
-            <a:pPr indent="0" marL="0">
+            <a:pPr marL="0" indent="0">
               <a:buNone/>
             </a:pPr>
             <a:r>
@@ -6888,7 +7477,7 @@
           <a:bodyPr wrap="square" lIns="0" tIns="0" rIns="0" bIns="0" rtlCol="0" anchor="ctr"/>
           <a:lstStyle/>
           <a:p>
-            <a:pPr algn="ctr" indent="0" marL="0">
+            <a:pPr marL="0" indent="0" algn="ctr">
               <a:buNone/>
             </a:pPr>
             <a:r>
@@ -6924,7 +7513,7 @@
           <a:bodyPr wrap="square" lIns="0" tIns="0" rIns="0" bIns="0" rtlCol="0" anchor="ctr"/>
           <a:lstStyle/>
           <a:p>
-            <a:pPr indent="0" marL="0">
+            <a:pPr marL="0" indent="0">
               <a:buNone/>
             </a:pPr>
             <a:r>
@@ -6960,7 +7549,7 @@
           <a:bodyPr wrap="square" lIns="0" tIns="0" rIns="0" bIns="0" rtlCol="0" anchor="ctr"/>
           <a:lstStyle/>
           <a:p>
-            <a:pPr indent="0" marL="0">
+            <a:pPr marL="0" indent="0">
               <a:buNone/>
             </a:pPr>
             <a:r>
@@ -7021,7 +7610,7 @@
           <a:bodyPr wrap="square" lIns="0" tIns="0" rIns="0" bIns="0" rtlCol="0" anchor="ctr"/>
           <a:lstStyle/>
           <a:p>
-            <a:pPr algn="ctr" indent="0" marL="0">
+            <a:pPr marL="0" indent="0" algn="ctr">
               <a:buNone/>
             </a:pPr>
             <a:r>
@@ -7057,7 +7646,7 @@
           <a:bodyPr wrap="square" lIns="0" tIns="0" rIns="0" bIns="0" rtlCol="0" anchor="ctr"/>
           <a:lstStyle/>
           <a:p>
-            <a:pPr indent="0" marL="0">
+            <a:pPr marL="0" indent="0">
               <a:buNone/>
             </a:pPr>
             <a:r>
@@ -7093,7 +7682,7 @@
           <a:bodyPr wrap="square" lIns="0" tIns="0" rIns="0" bIns="0" rtlCol="0" anchor="ctr"/>
           <a:lstStyle/>
           <a:p>
-            <a:pPr indent="0" marL="0">
+            <a:pPr marL="0" indent="0">
               <a:buNone/>
             </a:pPr>
             <a:r>
@@ -7154,7 +7743,7 @@
           <a:bodyPr wrap="square" lIns="0" tIns="0" rIns="0" bIns="0" rtlCol="0" anchor="ctr"/>
           <a:lstStyle/>
           <a:p>
-            <a:pPr algn="ctr" indent="0" marL="0">
+            <a:pPr marL="0" indent="0" algn="ctr">
               <a:buNone/>
             </a:pPr>
             <a:r>
@@ -7190,7 +7779,7 @@
           <a:bodyPr wrap="square" lIns="0" tIns="0" rIns="0" bIns="0" rtlCol="0" anchor="ctr"/>
           <a:lstStyle/>
           <a:p>
-            <a:pPr indent="0" marL="0">
+            <a:pPr marL="0" indent="0">
               <a:buNone/>
             </a:pPr>
             <a:r>
@@ -7226,7 +7815,7 @@
           <a:bodyPr wrap="square" lIns="0" tIns="0" rIns="0" bIns="0" rtlCol="0" anchor="ctr"/>
           <a:lstStyle/>
           <a:p>
-            <a:pPr indent="0" marL="0">
+            <a:pPr marL="0" indent="0">
               <a:buNone/>
             </a:pPr>
             <a:r>
@@ -7287,7 +7876,7 @@
           <a:bodyPr wrap="square" lIns="0" tIns="0" rIns="0" bIns="0" rtlCol="0" anchor="ctr"/>
           <a:lstStyle/>
           <a:p>
-            <a:pPr algn="ctr" indent="0" marL="0">
+            <a:pPr marL="0" indent="0" algn="ctr">
               <a:buNone/>
             </a:pPr>
             <a:r>
@@ -7323,7 +7912,7 @@
           <a:bodyPr wrap="square" lIns="0" tIns="0" rIns="0" bIns="0" rtlCol="0" anchor="ctr"/>
           <a:lstStyle/>
           <a:p>
-            <a:pPr indent="0" marL="0">
+            <a:pPr marL="0" indent="0">
               <a:buNone/>
             </a:pPr>
             <a:r>
@@ -7359,7 +7948,7 @@
           <a:bodyPr wrap="square" lIns="0" tIns="0" rIns="0" bIns="0" rtlCol="0" anchor="ctr"/>
           <a:lstStyle/>
           <a:p>
-            <a:pPr indent="0" marL="0">
+            <a:pPr marL="0" indent="0">
               <a:buNone/>
             </a:pPr>
             <a:r>
@@ -7420,7 +8009,7 @@
           <a:bodyPr wrap="square" lIns="0" tIns="0" rIns="0" bIns="0" rtlCol="0" anchor="ctr"/>
           <a:lstStyle/>
           <a:p>
-            <a:pPr algn="ctr" indent="0" marL="0">
+            <a:pPr marL="0" indent="0" algn="ctr">
               <a:buNone/>
             </a:pPr>
             <a:r>
@@ -7456,7 +8045,7 @@
           <a:bodyPr wrap="square" lIns="0" tIns="0" rIns="0" bIns="0" rtlCol="0" anchor="ctr"/>
           <a:lstStyle/>
           <a:p>
-            <a:pPr indent="0" marL="0">
+            <a:pPr marL="0" indent="0">
               <a:buNone/>
             </a:pPr>
             <a:r>
@@ -7492,7 +8081,7 @@
           <a:bodyPr wrap="square" lIns="0" tIns="0" rIns="0" bIns="0" rtlCol="0" anchor="ctr"/>
           <a:lstStyle/>
           <a:p>
-            <a:pPr indent="0" marL="0">
+            <a:pPr marL="0" indent="0">
               <a:buNone/>
             </a:pPr>
             <a:r>
@@ -7527,7 +8116,7 @@
           </a:prstGeom>
           <a:extLst>
             <a:ext uri="{C572A759-6A51-4108-AA02-DFA0A04FC94B}">
-              <ma14:wrappingTextBoxFlag xmlns:ma14="http://schemas.microsoft.com/office/mac/drawingml/2011/main" val="0"/>
+              <ma14:wrappingTextBoxFlag xmlns:ma14="http://schemas.microsoft.com/office/mac/drawingml/2011/main" xmlns="" val="0"/>
             </a:ext>
           </a:extLst>
         </p:spPr>
@@ -7545,7 +8134,7 @@
           <a:p>
             <a:pPr algn="r"/>
             <a:fld id="{F7021451-1387-4CA6-816F-3879F97B5CBC}" type="slidenum">
-              <a:rPr b="0" lang="en-US"/>
+              <a:rPr lang="en-US" b="0"/>
               <a:t>5</a:t>
             </a:fld>
             <a:endParaRPr lang="en-US"/>
@@ -7580,9 +8169,11 @@
       <p:sp>
         <p:nvSpPr>
           <p:cNvPr id="2" name="Text 0"/>
-          <p:cNvSpPr/>
+          <p:cNvSpPr>
+            <a:spLocks noGrp="1"/>
+          </p:cNvSpPr>
           <p:nvPr>
-            <p:ph idx="100" type="title" hasCustomPrompt="1"/>
+            <p:ph type="title" idx="100" hasCustomPrompt="1"/>
           </p:nvPr>
         </p:nvSpPr>
         <p:spPr>
@@ -7600,7 +8191,7 @@
           <a:bodyPr wrap="square" lIns="0" tIns="0" rIns="0" bIns="0" rtlCol="0" anchor="ctr"/>
           <a:lstStyle/>
           <a:p>
-            <a:pPr indent="0" marL="0">
+            <a:pPr marL="0" indent="0">
               <a:buNone/>
             </a:pPr>
             <a:r>
@@ -7666,7 +8257,7 @@
           <a:bodyPr wrap="square" lIns="0" tIns="0" rIns="0" bIns="0" rtlCol="0" anchor="ctr"/>
           <a:lstStyle/>
           <a:p>
-            <a:pPr indent="0" marL="0">
+            <a:pPr marL="0" indent="0">
               <a:buNone/>
             </a:pPr>
             <a:r>
@@ -7702,7 +8293,7 @@
           <a:bodyPr wrap="square" lIns="0" tIns="0" rIns="0" bIns="0" rtlCol="0" anchor="ctr"/>
           <a:lstStyle/>
           <a:p>
-            <a:pPr indent="0" marL="0">
+            <a:pPr marL="0" indent="0">
               <a:buNone/>
             </a:pPr>
             <a:r>
@@ -7765,7 +8356,7 @@
           <a:bodyPr wrap="square" lIns="0" tIns="0" rIns="0" bIns="0" rtlCol="0" anchor="ctr"/>
           <a:lstStyle/>
           <a:p>
-            <a:pPr indent="0" marL="0">
+            <a:pPr marL="0" indent="0">
               <a:buNone/>
             </a:pPr>
             <a:r>
@@ -7801,7 +8392,7 @@
           <a:bodyPr wrap="square" lIns="0" tIns="0" rIns="0" bIns="0" rtlCol="0" anchor="ctr"/>
           <a:lstStyle/>
           <a:p>
-            <a:pPr indent="0" marL="0">
+            <a:pPr marL="0" indent="0">
               <a:buNone/>
             </a:pPr>
             <a:r>
@@ -7864,7 +8455,7 @@
           <a:bodyPr wrap="square" lIns="0" tIns="0" rIns="0" bIns="0" rtlCol="0" anchor="ctr"/>
           <a:lstStyle/>
           <a:p>
-            <a:pPr indent="0" marL="0">
+            <a:pPr marL="0" indent="0">
               <a:buNone/>
             </a:pPr>
             <a:r>
@@ -7900,7 +8491,7 @@
           <a:bodyPr wrap="square" lIns="0" tIns="0" rIns="0" bIns="0" rtlCol="0" anchor="ctr"/>
           <a:lstStyle/>
           <a:p>
-            <a:pPr indent="0" marL="0">
+            <a:pPr marL="0" indent="0">
               <a:buNone/>
             </a:pPr>
             <a:r>
@@ -7963,7 +8554,7 @@
           <a:bodyPr wrap="square" lIns="0" tIns="0" rIns="0" bIns="0" rtlCol="0" anchor="ctr"/>
           <a:lstStyle/>
           <a:p>
-            <a:pPr indent="0" marL="0">
+            <a:pPr marL="0" indent="0">
               <a:buNone/>
             </a:pPr>
             <a:r>
@@ -7999,7 +8590,7 @@
           <a:bodyPr wrap="square" lIns="0" tIns="0" rIns="0" bIns="0" rtlCol="0" anchor="ctr"/>
           <a:lstStyle/>
           <a:p>
-            <a:pPr indent="0" marL="0">
+            <a:pPr marL="0" indent="0">
               <a:buNone/>
             </a:pPr>
             <a:r>
@@ -8062,7 +8653,7 @@
           <a:bodyPr wrap="square" lIns="0" tIns="0" rIns="0" bIns="0" rtlCol="0" anchor="t"/>
           <a:lstStyle/>
           <a:p>
-            <a:pPr indent="0" marL="0">
+            <a:pPr marL="0" indent="0">
               <a:buNone/>
             </a:pPr>
             <a:r>
@@ -8191,7 +8782,7 @@
           </a:prstGeom>
           <a:extLst>
             <a:ext uri="{C572A759-6A51-4108-AA02-DFA0A04FC94B}">
-              <ma14:wrappingTextBoxFlag xmlns:ma14="http://schemas.microsoft.com/office/mac/drawingml/2011/main" val="0"/>
+              <ma14:wrappingTextBoxFlag xmlns:ma14="http://schemas.microsoft.com/office/mac/drawingml/2011/main" xmlns="" val="0"/>
             </a:ext>
           </a:extLst>
         </p:spPr>
@@ -8209,7 +8800,7 @@
           <a:p>
             <a:pPr algn="r"/>
             <a:fld id="{F7021451-1387-4CA6-816F-3879F97B5CBC}" type="slidenum">
-              <a:rPr b="0" lang="en-US"/>
+              <a:rPr lang="en-US" b="0"/>
               <a:t>6</a:t>
             </a:fld>
             <a:endParaRPr lang="en-US"/>
@@ -8244,9 +8835,11 @@
       <p:sp>
         <p:nvSpPr>
           <p:cNvPr id="2" name="Text 0"/>
-          <p:cNvSpPr/>
+          <p:cNvSpPr>
+            <a:spLocks noGrp="1"/>
+          </p:cNvSpPr>
           <p:nvPr>
-            <p:ph idx="100" type="title" hasCustomPrompt="1"/>
+            <p:ph type="title" idx="100" hasCustomPrompt="1"/>
           </p:nvPr>
         </p:nvSpPr>
         <p:spPr>
@@ -8264,7 +8857,7 @@
           <a:bodyPr wrap="square" lIns="0" tIns="0" rIns="0" bIns="0" rtlCol="0" anchor="ctr"/>
           <a:lstStyle/>
           <a:p>
-            <a:pPr indent="0" marL="0">
+            <a:pPr marL="0" indent="0">
               <a:buNone/>
             </a:pPr>
             <a:r>
@@ -8276,7 +8869,7 @@
                 <a:ea typeface="Cambria" pitchFamily="34" charset="-122"/>
                 <a:cs typeface="Cambria" pitchFamily="34" charset="-120"/>
               </a:rPr>
-              <a:t>Seis decisiones registradas como ADR</a:t>
+              <a:t>Siete decisiones registradas como ADR</a:t>
             </a:r>
             <a:endParaRPr lang="en-US" sz="3400" dirty="0"/>
           </a:p>
@@ -8290,8 +8883,8 @@
         </p:nvSpPr>
         <p:spPr>
           <a:xfrm>
-            <a:off x="548640" y="1554480"/>
-            <a:ext cx="3474720" cy="1920240"/>
+            <a:off x="548640" y="1463040"/>
+            <a:ext cx="2560320" cy="2011680"/>
           </a:xfrm>
           <a:prstGeom prst="roundRect">
             <a:avLst>
@@ -8317,8 +8910,8 @@
         </p:nvSpPr>
         <p:spPr>
           <a:xfrm>
-            <a:off x="822960" y="1783080"/>
-            <a:ext cx="2926080" cy="365760"/>
+            <a:off x="777240" y="1645920"/>
+            <a:ext cx="2103120" cy="365760"/>
           </a:xfrm>
           <a:prstGeom prst="rect">
             <a:avLst/>
@@ -8330,7 +8923,7 @@
           <a:bodyPr wrap="square" lIns="0" tIns="0" rIns="0" bIns="0" rtlCol="0" anchor="t"/>
           <a:lstStyle/>
           <a:p>
-            <a:pPr indent="0" marL="0">
+            <a:pPr marL="0" indent="0">
               <a:buNone/>
             </a:pPr>
             <a:r>
@@ -8353,8 +8946,8 @@
         </p:nvSpPr>
         <p:spPr>
           <a:xfrm>
-            <a:off x="822960" y="2148840"/>
-            <a:ext cx="3017520" cy="502920"/>
+            <a:off x="777240" y="2011680"/>
+            <a:ext cx="2148839" cy="685800"/>
           </a:xfrm>
           <a:prstGeom prst="rect">
             <a:avLst/>
@@ -8366,7 +8959,7 @@
           <a:bodyPr wrap="square" lIns="0" tIns="0" rIns="0" bIns="0" rtlCol="0" anchor="t"/>
           <a:lstStyle/>
           <a:p>
-            <a:pPr indent="0" marL="0">
+            <a:pPr marL="0" indent="0">
               <a:buNone/>
             </a:pPr>
             <a:r>
@@ -8389,8 +8982,8 @@
         </p:nvSpPr>
         <p:spPr>
           <a:xfrm>
-            <a:off x="822960" y="2697480"/>
-            <a:ext cx="3017520" cy="640080"/>
+            <a:off x="777240" y="2697480"/>
+            <a:ext cx="2148839" cy="685800"/>
           </a:xfrm>
           <a:prstGeom prst="rect">
             <a:avLst/>
@@ -8402,7 +8995,7 @@
           <a:bodyPr wrap="square" lIns="0" tIns="0" rIns="0" bIns="0" rtlCol="0" anchor="t"/>
           <a:lstStyle/>
           <a:p>
-            <a:pPr indent="0" marL="0">
+            <a:pPr marL="0" indent="0">
               <a:buNone/>
             </a:pPr>
             <a:r>
@@ -8425,8 +9018,8 @@
         </p:nvSpPr>
         <p:spPr>
           <a:xfrm>
-            <a:off x="4297680" y="1554480"/>
-            <a:ext cx="3474720" cy="1920240"/>
+            <a:off x="3392424" y="1463040"/>
+            <a:ext cx="2560320" cy="2011680"/>
           </a:xfrm>
           <a:prstGeom prst="roundRect">
             <a:avLst>
@@ -8452,8 +9045,8 @@
         </p:nvSpPr>
         <p:spPr>
           <a:xfrm>
-            <a:off x="4572000" y="1783080"/>
-            <a:ext cx="2926080" cy="365760"/>
+            <a:off x="3621024" y="1645920"/>
+            <a:ext cx="2103120" cy="365760"/>
           </a:xfrm>
           <a:prstGeom prst="rect">
             <a:avLst/>
@@ -8465,7 +9058,7 @@
           <a:bodyPr wrap="square" lIns="0" tIns="0" rIns="0" bIns="0" rtlCol="0" anchor="t"/>
           <a:lstStyle/>
           <a:p>
-            <a:pPr indent="0" marL="0">
+            <a:pPr marL="0" indent="0">
               <a:buNone/>
             </a:pPr>
             <a:r>
@@ -8488,8 +9081,8 @@
         </p:nvSpPr>
         <p:spPr>
           <a:xfrm>
-            <a:off x="4572000" y="2148840"/>
-            <a:ext cx="3017520" cy="502920"/>
+            <a:off x="3621024" y="2011680"/>
+            <a:ext cx="2148839" cy="685800"/>
           </a:xfrm>
           <a:prstGeom prst="rect">
             <a:avLst/>
@@ -8501,7 +9094,7 @@
           <a:bodyPr wrap="square" lIns="0" tIns="0" rIns="0" bIns="0" rtlCol="0" anchor="t"/>
           <a:lstStyle/>
           <a:p>
-            <a:pPr indent="0" marL="0">
+            <a:pPr marL="0" indent="0">
               <a:buNone/>
             </a:pPr>
             <a:r>
@@ -8524,8 +9117,8 @@
         </p:nvSpPr>
         <p:spPr>
           <a:xfrm>
-            <a:off x="4572000" y="2697480"/>
-            <a:ext cx="3017520" cy="640080"/>
+            <a:off x="3621024" y="2697480"/>
+            <a:ext cx="2148839" cy="685800"/>
           </a:xfrm>
           <a:prstGeom prst="rect">
             <a:avLst/>
@@ -8537,7 +9130,7 @@
           <a:bodyPr wrap="square" lIns="0" tIns="0" rIns="0" bIns="0" rtlCol="0" anchor="t"/>
           <a:lstStyle/>
           <a:p>
-            <a:pPr indent="0" marL="0">
+            <a:pPr marL="0" indent="0">
               <a:buNone/>
             </a:pPr>
             <a:r>
@@ -8560,8 +9153,8 @@
         </p:nvSpPr>
         <p:spPr>
           <a:xfrm>
-            <a:off x="8046720" y="1554480"/>
-            <a:ext cx="3474720" cy="1920240"/>
+            <a:off x="6236207" y="1463040"/>
+            <a:ext cx="2560320" cy="2011680"/>
           </a:xfrm>
           <a:prstGeom prst="roundRect">
             <a:avLst>
@@ -8587,8 +9180,8 @@
         </p:nvSpPr>
         <p:spPr>
           <a:xfrm>
-            <a:off x="8321040" y="1783080"/>
-            <a:ext cx="2926080" cy="365760"/>
+            <a:off x="6464807" y="1645920"/>
+            <a:ext cx="2103120" cy="365760"/>
           </a:xfrm>
           <a:prstGeom prst="rect">
             <a:avLst/>
@@ -8600,7 +9193,7 @@
           <a:bodyPr wrap="square" lIns="0" tIns="0" rIns="0" bIns="0" rtlCol="0" anchor="t"/>
           <a:lstStyle/>
           <a:p>
-            <a:pPr indent="0" marL="0">
+            <a:pPr marL="0" indent="0">
               <a:buNone/>
             </a:pPr>
             <a:r>
@@ -8623,8 +9216,8 @@
         </p:nvSpPr>
         <p:spPr>
           <a:xfrm>
-            <a:off x="8321040" y="2148840"/>
-            <a:ext cx="3017520" cy="502920"/>
+            <a:off x="6464807" y="2011680"/>
+            <a:ext cx="2148839" cy="685800"/>
           </a:xfrm>
           <a:prstGeom prst="rect">
             <a:avLst/>
@@ -8636,7 +9229,7 @@
           <a:bodyPr wrap="square" lIns="0" tIns="0" rIns="0" bIns="0" rtlCol="0" anchor="t"/>
           <a:lstStyle/>
           <a:p>
-            <a:pPr indent="0" marL="0">
+            <a:pPr marL="0" indent="0">
               <a:buNone/>
             </a:pPr>
             <a:r>
@@ -8659,8 +9252,8 @@
         </p:nvSpPr>
         <p:spPr>
           <a:xfrm>
-            <a:off x="8321040" y="2697480"/>
-            <a:ext cx="3017520" cy="640080"/>
+            <a:off x="6464807" y="2697480"/>
+            <a:ext cx="2148839" cy="685800"/>
           </a:xfrm>
           <a:prstGeom prst="rect">
             <a:avLst/>
@@ -8672,7 +9265,7 @@
           <a:bodyPr wrap="square" lIns="0" tIns="0" rIns="0" bIns="0" rtlCol="0" anchor="t"/>
           <a:lstStyle/>
           <a:p>
-            <a:pPr indent="0" marL="0">
+            <a:pPr marL="0" indent="0">
               <a:buNone/>
             </a:pPr>
             <a:r>
@@ -8695,8 +9288,8 @@
         </p:nvSpPr>
         <p:spPr>
           <a:xfrm>
-            <a:off x="548640" y="3749040"/>
-            <a:ext cx="3474720" cy="1920240"/>
+            <a:off x="9079992" y="1463040"/>
+            <a:ext cx="2560320" cy="2011680"/>
           </a:xfrm>
           <a:prstGeom prst="roundRect">
             <a:avLst>
@@ -8722,8 +9315,8 @@
         </p:nvSpPr>
         <p:spPr>
           <a:xfrm>
-            <a:off x="822960" y="3977640"/>
-            <a:ext cx="2926080" cy="365760"/>
+            <a:off x="9308592" y="1645920"/>
+            <a:ext cx="2103120" cy="365760"/>
           </a:xfrm>
           <a:prstGeom prst="rect">
             <a:avLst/>
@@ -8735,7 +9328,7 @@
           <a:bodyPr wrap="square" lIns="0" tIns="0" rIns="0" bIns="0" rtlCol="0" anchor="t"/>
           <a:lstStyle/>
           <a:p>
-            <a:pPr indent="0" marL="0">
+            <a:pPr marL="0" indent="0">
               <a:buNone/>
             </a:pPr>
             <a:r>
@@ -8758,8 +9351,8 @@
         </p:nvSpPr>
         <p:spPr>
           <a:xfrm>
-            <a:off x="822960" y="4343400"/>
-            <a:ext cx="3017520" cy="502920"/>
+            <a:off x="9308592" y="2011680"/>
+            <a:ext cx="2148839" cy="685800"/>
           </a:xfrm>
           <a:prstGeom prst="rect">
             <a:avLst/>
@@ -8771,7 +9364,7 @@
           <a:bodyPr wrap="square" lIns="0" tIns="0" rIns="0" bIns="0" rtlCol="0" anchor="t"/>
           <a:lstStyle/>
           <a:p>
-            <a:pPr indent="0" marL="0">
+            <a:pPr marL="0" indent="0">
               <a:buNone/>
             </a:pPr>
             <a:r>
@@ -8794,8 +9387,8 @@
         </p:nvSpPr>
         <p:spPr>
           <a:xfrm>
-            <a:off x="822960" y="4892040"/>
-            <a:ext cx="3017520" cy="640080"/>
+            <a:off x="9308592" y="2697480"/>
+            <a:ext cx="2148839" cy="685800"/>
           </a:xfrm>
           <a:prstGeom prst="rect">
             <a:avLst/>
@@ -8807,7 +9400,7 @@
           <a:bodyPr wrap="square" lIns="0" tIns="0" rIns="0" bIns="0" rtlCol="0" anchor="t"/>
           <a:lstStyle/>
           <a:p>
-            <a:pPr indent="0" marL="0">
+            <a:pPr marL="0" indent="0">
               <a:buNone/>
             </a:pPr>
             <a:r>
@@ -8830,8 +9423,8 @@
         </p:nvSpPr>
         <p:spPr>
           <a:xfrm>
-            <a:off x="4297680" y="3749040"/>
-            <a:ext cx="3474720" cy="1920240"/>
+            <a:off x="548640" y="3749039"/>
+            <a:ext cx="2560320" cy="2011680"/>
           </a:xfrm>
           <a:prstGeom prst="roundRect">
             <a:avLst>
@@ -8857,8 +9450,8 @@
         </p:nvSpPr>
         <p:spPr>
           <a:xfrm>
-            <a:off x="4572000" y="3977640"/>
-            <a:ext cx="2926080" cy="365760"/>
+            <a:off x="777240" y="3931920"/>
+            <a:ext cx="2103120" cy="365760"/>
           </a:xfrm>
           <a:prstGeom prst="rect">
             <a:avLst/>
@@ -8870,7 +9463,7 @@
           <a:bodyPr wrap="square" lIns="0" tIns="0" rIns="0" bIns="0" rtlCol="0" anchor="t"/>
           <a:lstStyle/>
           <a:p>
-            <a:pPr indent="0" marL="0">
+            <a:pPr marL="0" indent="0">
               <a:buNone/>
             </a:pPr>
             <a:r>
@@ -8893,8 +9486,8 @@
         </p:nvSpPr>
         <p:spPr>
           <a:xfrm>
-            <a:off x="4572000" y="4343400"/>
-            <a:ext cx="3017520" cy="502920"/>
+            <a:off x="777240" y="4297679"/>
+            <a:ext cx="2148839" cy="685800"/>
           </a:xfrm>
           <a:prstGeom prst="rect">
             <a:avLst/>
@@ -8906,7 +9499,7 @@
           <a:bodyPr wrap="square" lIns="0" tIns="0" rIns="0" bIns="0" rtlCol="0" anchor="t"/>
           <a:lstStyle/>
           <a:p>
-            <a:pPr indent="0" marL="0">
+            <a:pPr marL="0" indent="0">
               <a:buNone/>
             </a:pPr>
             <a:r>
@@ -8929,8 +9522,8 @@
         </p:nvSpPr>
         <p:spPr>
           <a:xfrm>
-            <a:off x="4572000" y="4892040"/>
-            <a:ext cx="3017520" cy="640080"/>
+            <a:off x="777240" y="4983479"/>
+            <a:ext cx="2148839" cy="685800"/>
           </a:xfrm>
           <a:prstGeom prst="rect">
             <a:avLst/>
@@ -8942,7 +9535,7 @@
           <a:bodyPr wrap="square" lIns="0" tIns="0" rIns="0" bIns="0" rtlCol="0" anchor="t"/>
           <a:lstStyle/>
           <a:p>
-            <a:pPr indent="0" marL="0">
+            <a:pPr marL="0" indent="0">
               <a:buNone/>
             </a:pPr>
             <a:r>
@@ -8965,8 +9558,8 @@
         </p:nvSpPr>
         <p:spPr>
           <a:xfrm>
-            <a:off x="8046720" y="3749040"/>
-            <a:ext cx="3474720" cy="1920240"/>
+            <a:off x="3392424" y="3749039"/>
+            <a:ext cx="2560320" cy="2011680"/>
           </a:xfrm>
           <a:prstGeom prst="roundRect">
             <a:avLst>
@@ -8992,8 +9585,8 @@
         </p:nvSpPr>
         <p:spPr>
           <a:xfrm>
-            <a:off x="8321040" y="3977640"/>
-            <a:ext cx="2926080" cy="365760"/>
+            <a:off x="3621024" y="3931920"/>
+            <a:ext cx="2103120" cy="365760"/>
           </a:xfrm>
           <a:prstGeom prst="rect">
             <a:avLst/>
@@ -9005,7 +9598,7 @@
           <a:bodyPr wrap="square" lIns="0" tIns="0" rIns="0" bIns="0" rtlCol="0" anchor="t"/>
           <a:lstStyle/>
           <a:p>
-            <a:pPr indent="0" marL="0">
+            <a:pPr marL="0" indent="0">
               <a:buNone/>
             </a:pPr>
             <a:r>
@@ -9028,8 +9621,8 @@
         </p:nvSpPr>
         <p:spPr>
           <a:xfrm>
-            <a:off x="8321040" y="4343400"/>
-            <a:ext cx="3017520" cy="502920"/>
+            <a:off x="3621024" y="4297679"/>
+            <a:ext cx="2148839" cy="685800"/>
           </a:xfrm>
           <a:prstGeom prst="rect">
             <a:avLst/>
@@ -9041,7 +9634,7 @@
           <a:bodyPr wrap="square" lIns="0" tIns="0" rIns="0" bIns="0" rtlCol="0" anchor="t"/>
           <a:lstStyle/>
           <a:p>
-            <a:pPr indent="0" marL="0">
+            <a:pPr marL="0" indent="0">
               <a:buNone/>
             </a:pPr>
             <a:r>
@@ -9064,8 +9657,8 @@
         </p:nvSpPr>
         <p:spPr>
           <a:xfrm>
-            <a:off x="8321040" y="4892040"/>
-            <a:ext cx="3017520" cy="640080"/>
+            <a:off x="3621024" y="4983479"/>
+            <a:ext cx="2148839" cy="685800"/>
           </a:xfrm>
           <a:prstGeom prst="rect">
             <a:avLst/>
@@ -9077,7 +9670,7 @@
           <a:bodyPr wrap="square" lIns="0" tIns="0" rIns="0" bIns="0" rtlCol="0" anchor="t"/>
           <a:lstStyle/>
           <a:p>
-            <a:pPr indent="0" marL="0">
+            <a:pPr marL="0" indent="0">
               <a:buNone/>
             </a:pPr>
             <a:r>
@@ -9094,7 +9687,7 @@
       </p:sp>
       <p:sp>
         <p:nvSpPr>
-          <p:cNvPr id="25" name="Slide Number Placeholder 0"/>
+          <p:cNvPr id="27" name="Slide Number Placeholder 0"/>
           <p:cNvSpPr>
             <a:spLocks noGrp="1"/>
           </p:cNvSpPr>
@@ -9112,7 +9705,7 @@
           </a:prstGeom>
           <a:extLst>
             <a:ext uri="{C572A759-6A51-4108-AA02-DFA0A04FC94B}">
-              <ma14:wrappingTextBoxFlag xmlns:ma14="http://schemas.microsoft.com/office/mac/drawingml/2011/main" val="0"/>
+              <ma14:wrappingTextBoxFlag xmlns:ma14="http://schemas.microsoft.com/office/mac/drawingml/2011/main" xmlns="" val="0"/>
             </a:ext>
           </a:extLst>
         </p:spPr>
@@ -9130,10 +9723,181 @@
           <a:p>
             <a:pPr algn="r"/>
             <a:fld id="{F7021451-1387-4CA6-816F-3879F97B5CBC}" type="slidenum">
-              <a:rPr b="0" lang="en-US"/>
+              <a:rPr lang="en-US" b="0"/>
               <a:t>7</a:t>
             </a:fld>
             <a:endParaRPr lang="en-US"/>
+          </a:p>
+        </p:txBody>
+      </p:sp>
+      <p:sp>
+        <p:nvSpPr>
+          <p:cNvPr id="28" name="tarjeta-300"/>
+          <p:cNvSpPr/>
+          <p:nvPr/>
+        </p:nvSpPr>
+        <p:spPr>
+          <a:xfrm>
+            <a:off x="6236207" y="3749039"/>
+            <a:ext cx="2560320" cy="2011680"/>
+          </a:xfrm>
+          <a:prstGeom prst="roundRect">
+            <a:avLst>
+              <a:gd name="adj" fmla="val 5714"/>
+            </a:avLst>
+          </a:prstGeom>
+          <a:solidFill>
+            <a:schemeClr val="bg2"/>
+          </a:solidFill>
+          <a:ln w="12700">
+            <a:solidFill>
+              <a:schemeClr val="bg2"/>
+            </a:solidFill>
+            <a:prstDash val="solid"/>
+          </a:ln>
+        </p:spPr>
+      </p:sp>
+      <p:sp>
+        <p:nvSpPr>
+          <p:cNvPr id="29" name="texto-301"/>
+          <p:cNvSpPr txBox="1"/>
+          <p:nvPr/>
+        </p:nvSpPr>
+        <p:spPr>
+          <a:xfrm>
+            <a:off x="6464807" y="3931920"/>
+            <a:ext cx="2103120" cy="365760"/>
+          </a:xfrm>
+          <a:prstGeom prst="rect">
+            <a:avLst/>
+          </a:prstGeom>
+          <a:noFill/>
+          <a:ln/>
+        </p:spPr>
+        <p:txBody>
+          <a:bodyPr wrap="square" lIns="0" tIns="0" rIns="0" bIns="0" rtlCol="0" anchor="t"/>
+          <a:lstStyle/>
+          <a:p>
+            <a:pPr marL="0" indent="0">
+              <a:buNone/>
+            </a:pPr>
+            <a:r>
+              <a:rPr lang="en-US" sz="1300" b="1" dirty="0">
+                <a:solidFill>
+                  <a:schemeClr val="accent5"/>
+                </a:solidFill>
+              </a:rPr>
+              <a:t>ADR-007</a:t>
+            </a:r>
+            <a:endParaRPr lang="en-US" sz="1300" dirty="0"/>
+          </a:p>
+        </p:txBody>
+      </p:sp>
+      <p:sp>
+        <p:nvSpPr>
+          <p:cNvPr id="30" name="texto-302"/>
+          <p:cNvSpPr txBox="1"/>
+          <p:nvPr/>
+        </p:nvSpPr>
+        <p:spPr>
+          <a:xfrm>
+            <a:off x="6464807" y="4297679"/>
+            <a:ext cx="2148839" cy="685800"/>
+          </a:xfrm>
+          <a:prstGeom prst="rect">
+            <a:avLst/>
+          </a:prstGeom>
+          <a:noFill/>
+          <a:ln/>
+        </p:spPr>
+        <p:txBody>
+          <a:bodyPr wrap="square" lIns="0" tIns="0" rIns="0" bIns="0" rtlCol="0" anchor="t"/>
+          <a:lstStyle/>
+          <a:p>
+            <a:pPr marL="0" indent="0">
+              <a:buNone/>
+            </a:pPr>
+            <a:r>
+              <a:rPr lang="en-US" sz="1900" b="1" dirty="0">
+                <a:solidFill>
+                  <a:schemeClr val="tx2"/>
+                </a:solidFill>
+              </a:rPr>
+              <a:t>Sin Docker</a:t>
+            </a:r>
+            <a:endParaRPr lang="en-US" sz="1900" dirty="0"/>
+          </a:p>
+        </p:txBody>
+      </p:sp>
+      <p:sp>
+        <p:nvSpPr>
+          <p:cNvPr id="31" name="texto-303"/>
+          <p:cNvSpPr txBox="1"/>
+          <p:nvPr/>
+        </p:nvSpPr>
+        <p:spPr>
+          <a:xfrm>
+            <a:off x="6464807" y="4983479"/>
+            <a:ext cx="2148839" cy="685800"/>
+          </a:xfrm>
+          <a:prstGeom prst="rect">
+            <a:avLst/>
+          </a:prstGeom>
+          <a:noFill/>
+          <a:ln/>
+        </p:spPr>
+        <p:txBody>
+          <a:bodyPr wrap="square" lIns="0" tIns="0" rIns="0" bIns="0" rtlCol="0" anchor="t"/>
+          <a:lstStyle/>
+          <a:p>
+            <a:pPr marL="0" indent="0">
+              <a:buNone/>
+            </a:pPr>
+            <a:r>
+              <a:rPr lang="en-US" sz="1400" dirty="0">
+                <a:solidFill>
+                  <a:schemeClr val="accent4"/>
+                </a:solidFill>
+              </a:rPr>
+              <a:t>Solo se afirma lo que se probó: LocalDB</a:t>
+            </a:r>
+            <a:endParaRPr lang="en-US" sz="1400" dirty="0"/>
+          </a:p>
+        </p:txBody>
+      </p:sp>
+      <p:sp>
+        <p:nvSpPr>
+          <p:cNvPr id="32" name="texto-304"/>
+          <p:cNvSpPr txBox="1"/>
+          <p:nvPr/>
+        </p:nvSpPr>
+        <p:spPr>
+          <a:xfrm>
+            <a:off x="9308592" y="4297679"/>
+            <a:ext cx="2148839" cy="1188720"/>
+          </a:xfrm>
+          <a:prstGeom prst="rect">
+            <a:avLst/>
+          </a:prstGeom>
+          <a:noFill/>
+          <a:ln/>
+        </p:spPr>
+        <p:txBody>
+          <a:bodyPr wrap="square" lIns="0" tIns="0" rIns="0" bIns="0" rtlCol="0" anchor="t"/>
+          <a:lstStyle/>
+          <a:p>
+            <a:pPr marL="0" indent="0">
+              <a:buNone/>
+            </a:pPr>
+            <a:r>
+              <a:rPr lang="en-US" sz="1400" i="1" dirty="0">
+                <a:solidFill>
+                  <a:schemeClr val="accent4"/>
+                </a:solidFill>
+              </a:rPr>
+              <a:t>Cada ADR registra contexto, alternativas descartadas y consecuencias</a:t>
+            </a:r>
+            <a:endParaRPr lang="en-US" sz="1400" dirty="0"/>
           </a:p>
         </p:txBody>
       </p:sp>
@@ -9165,9 +9929,11 @@
       <p:sp>
         <p:nvSpPr>
           <p:cNvPr id="2" name="Text 0"/>
-          <p:cNvSpPr/>
+          <p:cNvSpPr>
+            <a:spLocks noGrp="1"/>
+          </p:cNvSpPr>
           <p:nvPr>
-            <p:ph idx="100" type="title" hasCustomPrompt="1"/>
+            <p:ph type="title" idx="100" hasCustomPrompt="1"/>
           </p:nvPr>
         </p:nvSpPr>
         <p:spPr>
@@ -9185,7 +9951,7 @@
           <a:bodyPr wrap="square" lIns="0" tIns="0" rIns="0" bIns="0" rtlCol="0" anchor="ctr"/>
           <a:lstStyle/>
           <a:p>
-            <a:pPr indent="0" marL="0">
+            <a:pPr marL="0" indent="0">
               <a:buNone/>
             </a:pPr>
             <a:r>
@@ -9197,7 +9963,7 @@
                 <a:ea typeface="Cambria" pitchFamily="34" charset="-122"/>
                 <a:cs typeface="Cambria" pitchFamily="34" charset="-120"/>
               </a:rPr>
-              <a:t>119 pruebas en verde y medidas que se pueden repetir</a:t>
+              <a:t>121 pruebas en verde y medidas que se pueden repetir</a:t>
             </a:r>
             <a:endParaRPr lang="en-US" sz="3400" dirty="0"/>
           </a:p>
@@ -9224,7 +9990,7 @@
           <a:bodyPr wrap="square" lIns="0" tIns="0" rIns="0" bIns="0" rtlCol="0" anchor="t"/>
           <a:lstStyle/>
           <a:p>
-            <a:pPr indent="0" marL="0">
+            <a:pPr marL="0" indent="0">
               <a:buNone/>
             </a:pPr>
             <a:r>
@@ -9236,7 +10002,7 @@
                 <a:ea typeface="Cambria" pitchFamily="34" charset="-122"/>
                 <a:cs typeface="Cambria" pitchFamily="34" charset="-120"/>
               </a:rPr>
-              <a:t>119</a:t>
+              <a:t>121</a:t>
             </a:r>
             <a:endParaRPr lang="en-US" sz="3600" dirty="0"/>
           </a:p>
@@ -9263,7 +10029,7 @@
           <a:bodyPr wrap="square" lIns="0" tIns="0" rIns="0" bIns="0" rtlCol="0" anchor="t"/>
           <a:lstStyle/>
           <a:p>
-            <a:pPr indent="0" marL="0">
+            <a:pPr marL="0" indent="0">
               <a:buNone/>
             </a:pPr>
             <a:r>
@@ -9299,7 +10065,7 @@
           <a:bodyPr wrap="square" lIns="0" tIns="0" rIns="0" bIns="0" rtlCol="0" anchor="t"/>
           <a:lstStyle/>
           <a:p>
-            <a:pPr indent="0" marL="0">
+            <a:pPr marL="0" indent="0">
               <a:buNone/>
             </a:pPr>
             <a:r>
@@ -9338,7 +10104,7 @@
           <a:bodyPr wrap="square" lIns="0" tIns="0" rIns="0" bIns="0" rtlCol="0" anchor="t"/>
           <a:lstStyle/>
           <a:p>
-            <a:pPr indent="0" marL="0">
+            <a:pPr marL="0" indent="0">
               <a:buNone/>
             </a:pPr>
             <a:r>
@@ -9374,7 +10140,7 @@
           <a:bodyPr wrap="square" lIns="0" tIns="0" rIns="0" bIns="0" rtlCol="0" anchor="t"/>
           <a:lstStyle/>
           <a:p>
-            <a:pPr indent="0" marL="0">
+            <a:pPr marL="0" indent="0">
               <a:buNone/>
             </a:pPr>
             <a:r>
@@ -9413,7 +10179,7 @@
           <a:bodyPr wrap="square" lIns="0" tIns="0" rIns="0" bIns="0" rtlCol="0" anchor="t"/>
           <a:lstStyle/>
           <a:p>
-            <a:pPr indent="0" marL="0">
+            <a:pPr marL="0" indent="0">
               <a:buNone/>
             </a:pPr>
             <a:r>
@@ -9449,7 +10215,7 @@
           <a:bodyPr wrap="square" lIns="0" tIns="0" rIns="0" bIns="0" rtlCol="0" anchor="t"/>
           <a:lstStyle/>
           <a:p>
-            <a:pPr indent="0" marL="0">
+            <a:pPr marL="0" indent="0">
               <a:buNone/>
             </a:pPr>
             <a:r>
@@ -9488,7 +10254,7 @@
           <a:bodyPr wrap="square" lIns="0" tIns="0" rIns="0" bIns="0" rtlCol="0" anchor="t"/>
           <a:lstStyle/>
           <a:p>
-            <a:pPr indent="0" marL="0">
+            <a:pPr marL="0" indent="0">
               <a:buNone/>
             </a:pPr>
             <a:r>
@@ -9524,7 +10290,7 @@
           <a:bodyPr wrap="square" lIns="0" tIns="0" rIns="0" bIns="0" rtlCol="0" anchor="t"/>
           <a:lstStyle/>
           <a:p>
-            <a:pPr indent="0" marL="0">
+            <a:pPr marL="0" indent="0">
               <a:buNone/>
             </a:pPr>
             <a:r>
@@ -9541,7 +10307,7 @@
       </p:sp>
       <p:graphicFrame>
         <p:nvGraphicFramePr>
-          <p:cNvPr id="12" name="grafico-146" descr=""/>
+          <p:cNvPr id="12" name="grafico-146"/>
           <p:cNvGraphicFramePr/>
           <p:nvPr/>
         </p:nvGraphicFramePr>
@@ -9549,9 +10315,9 @@
           <a:off x="548640" y="3337560"/>
           <a:ext cx="6766560" cy="2651760"/>
         </p:xfrm>
-        <a:graphic xmlns:a="http://schemas.openxmlformats.org/drawingml/2006/main">
+        <a:graphic>
           <a:graphicData uri="http://schemas.openxmlformats.org/drawingml/2006/chart">
-            <c:chart xmlns:c="http://schemas.openxmlformats.org/drawingml/2006/chart" r:id="rId1"/>
+            <c:chart xmlns:c="http://schemas.openxmlformats.org/drawingml/2006/chart" xmlns:r="http://schemas.openxmlformats.org/officeDocument/2006/relationships" r:id="rId3"/>
           </a:graphicData>
         </a:graphic>
       </p:graphicFrame>
@@ -9581,6 +10347,13 @@
             <a:prstDash val="solid"/>
           </a:ln>
         </p:spPr>
+        <p:txBody>
+          <a:bodyPr/>
+          <a:lstStyle/>
+          <a:p>
+            <a:endParaRPr/>
+          </a:p>
+        </p:txBody>
       </p:sp>
       <p:sp>
         <p:nvSpPr>
@@ -9603,7 +10376,7 @@
           <a:bodyPr wrap="square" lIns="0" tIns="0" rIns="0" bIns="0" rtlCol="0" anchor="t"/>
           <a:lstStyle/>
           <a:p>
-            <a:pPr indent="0" marL="0">
+            <a:pPr marL="0" indent="0">
               <a:buNone/>
             </a:pPr>
             <a:r>
@@ -9750,7 +10523,7 @@
           </a:prstGeom>
           <a:extLst>
             <a:ext uri="{C572A759-6A51-4108-AA02-DFA0A04FC94B}">
-              <ma14:wrappingTextBoxFlag xmlns:ma14="http://schemas.microsoft.com/office/mac/drawingml/2011/main" val="0"/>
+              <ma14:wrappingTextBoxFlag xmlns:ma14="http://schemas.microsoft.com/office/mac/drawingml/2011/main" xmlns="" val="0"/>
             </a:ext>
           </a:extLst>
         </p:spPr>
@@ -9768,7 +10541,7 @@
           <a:p>
             <a:pPr algn="r"/>
             <a:fld id="{F7021451-1387-4CA6-816F-3879F97B5CBC}" type="slidenum">
-              <a:rPr b="0" lang="en-US"/>
+              <a:rPr lang="en-US" b="0"/>
               <a:t>8</a:t>
             </a:fld>
             <a:endParaRPr lang="en-US"/>
@@ -9803,9 +10576,11 @@
       <p:sp>
         <p:nvSpPr>
           <p:cNvPr id="2" name="Text 0"/>
-          <p:cNvSpPr/>
+          <p:cNvSpPr>
+            <a:spLocks noGrp="1"/>
+          </p:cNvSpPr>
           <p:nvPr>
-            <p:ph idx="100" type="title" hasCustomPrompt="1"/>
+            <p:ph type="title" idx="100" hasCustomPrompt="1"/>
           </p:nvPr>
         </p:nvSpPr>
         <p:spPr>
@@ -9823,7 +10598,7 @@
           <a:bodyPr wrap="square" lIns="0" tIns="0" rIns="0" bIns="0" rtlCol="0" anchor="ctr"/>
           <a:lstStyle/>
           <a:p>
-            <a:pPr indent="0" marL="0">
+            <a:pPr marL="0" indent="0">
               <a:buNone/>
             </a:pPr>
             <a:r>
@@ -9862,7 +10637,7 @@
           <a:bodyPr wrap="square" lIns="0" tIns="0" rIns="0" bIns="0" rtlCol="0" anchor="t"/>
           <a:lstStyle/>
           <a:p>
-            <a:pPr indent="0" marL="0">
+            <a:pPr marL="0" indent="0">
               <a:buNone/>
             </a:pPr>
             <a:r>
@@ -9874,7 +10649,7 @@
                 <a:ea typeface="Cambria" pitchFamily="34" charset="-122"/>
                 <a:cs typeface="Cambria" pitchFamily="34" charset="-120"/>
               </a:rPr>
-              <a:t>14</a:t>
+              <a:t>16</a:t>
             </a:r>
             <a:endParaRPr lang="en-US" sz="6600" dirty="0"/>
           </a:p>
@@ -9901,7 +10676,7 @@
           <a:bodyPr wrap="square" lIns="0" tIns="0" rIns="0" bIns="0" rtlCol="0" anchor="t"/>
           <a:lstStyle/>
           <a:p>
-            <a:pPr indent="0" marL="0">
+            <a:pPr marL="0" indent="0">
               <a:buNone/>
             </a:pPr>
             <a:r>
@@ -9989,7 +10764,7 @@
           <a:bodyPr wrap="square" lIns="0" tIns="0" rIns="0" bIns="0" rtlCol="0" anchor="ctr"/>
           <a:lstStyle/>
           <a:p>
-            <a:pPr algn="ctr" indent="0" marL="0">
+            <a:pPr marL="0" indent="0" algn="ctr">
               <a:buNone/>
             </a:pPr>
             <a:endParaRPr lang="en-US" sz="1600" dirty="0"/>
@@ -10017,7 +10792,7 @@
           <a:bodyPr wrap="square" lIns="0" tIns="0" rIns="0" bIns="0" rtlCol="0" anchor="ctr"/>
           <a:lstStyle/>
           <a:p>
-            <a:pPr indent="0" marL="0">
+            <a:pPr marL="0" indent="0">
               <a:buNone/>
             </a:pPr>
             <a:r>
@@ -10053,7 +10828,7 @@
           <a:bodyPr wrap="square" lIns="0" tIns="0" rIns="0" bIns="0" rtlCol="0" anchor="t"/>
           <a:lstStyle/>
           <a:p>
-            <a:pPr indent="0" marL="0">
+            <a:pPr marL="0" indent="0">
               <a:buNone/>
             </a:pPr>
             <a:r>
@@ -10062,7 +10837,7 @@
                   <a:schemeClr val="tx1"/>
                 </a:solidFill>
               </a:rPr>
-              <a:t>La IA atribuyó 10 fallos a «parámetros que no sirven»; la causa real era otra. Se corrigió la conclusión.</a:t>
+              <a:t>La IA concluyó que los procedimientos ausentes eran código sin uso; al aprobar un MP, la pantalla decía éxito y la base no cambiaba (evidencia 002).</a:t>
             </a:r>
             <a:endParaRPr lang="en-US" sz="1400" dirty="0"/>
           </a:p>
@@ -10141,7 +10916,7 @@
           <a:bodyPr wrap="square" lIns="0" tIns="0" rIns="0" bIns="0" rtlCol="0" anchor="ctr"/>
           <a:lstStyle/>
           <a:p>
-            <a:pPr algn="ctr" indent="0" marL="0">
+            <a:pPr marL="0" indent="0" algn="ctr">
               <a:buNone/>
             </a:pPr>
             <a:endParaRPr lang="en-US" sz="1600" dirty="0"/>
@@ -10169,7 +10944,7 @@
           <a:bodyPr wrap="square" lIns="0" tIns="0" rIns="0" bIns="0" rtlCol="0" anchor="ctr"/>
           <a:lstStyle/>
           <a:p>
-            <a:pPr indent="0" marL="0">
+            <a:pPr marL="0" indent="0">
               <a:buNone/>
             </a:pPr>
             <a:r>
@@ -10205,7 +10980,7 @@
           <a:bodyPr wrap="square" lIns="0" tIns="0" rIns="0" bIns="0" rtlCol="0" anchor="t"/>
           <a:lstStyle/>
           <a:p>
-            <a:pPr indent="0" marL="0">
+            <a:pPr marL="0" indent="0">
               <a:buNone/>
             </a:pPr>
             <a:r>
@@ -10293,7 +11068,7 @@
           <a:bodyPr wrap="square" lIns="0" tIns="0" rIns="0" bIns="0" rtlCol="0" anchor="ctr"/>
           <a:lstStyle/>
           <a:p>
-            <a:pPr algn="ctr" indent="0" marL="0">
+            <a:pPr marL="0" indent="0" algn="ctr">
               <a:buNone/>
             </a:pPr>
             <a:endParaRPr lang="en-US" sz="1600" dirty="0"/>
@@ -10321,7 +11096,7 @@
           <a:bodyPr wrap="square" lIns="0" tIns="0" rIns="0" bIns="0" rtlCol="0" anchor="ctr"/>
           <a:lstStyle/>
           <a:p>
-            <a:pPr indent="0" marL="0">
+            <a:pPr marL="0" indent="0">
               <a:buNone/>
             </a:pPr>
             <a:r>
@@ -10357,7 +11132,7 @@
           <a:bodyPr wrap="square" lIns="0" tIns="0" rIns="0" bIns="0" rtlCol="0" anchor="t"/>
           <a:lstStyle/>
           <a:p>
-            <a:pPr indent="0" marL="0">
+            <a:pPr marL="0" indent="0">
               <a:buNone/>
             </a:pPr>
             <a:r>
@@ -10445,7 +11220,7 @@
           <a:bodyPr wrap="square" lIns="0" tIns="0" rIns="0" bIns="0" rtlCol="0" anchor="ctr"/>
           <a:lstStyle/>
           <a:p>
-            <a:pPr algn="ctr" indent="0" marL="0">
+            <a:pPr marL="0" indent="0" algn="ctr">
               <a:buNone/>
             </a:pPr>
             <a:endParaRPr lang="en-US" sz="1600" dirty="0"/>
@@ -10473,7 +11248,7 @@
           <a:bodyPr wrap="square" lIns="0" tIns="0" rIns="0" bIns="0" rtlCol="0" anchor="ctr"/>
           <a:lstStyle/>
           <a:p>
-            <a:pPr indent="0" marL="0">
+            <a:pPr marL="0" indent="0">
               <a:buNone/>
             </a:pPr>
             <a:r>
@@ -10509,7 +11284,7 @@
           <a:bodyPr wrap="square" lIns="0" tIns="0" rIns="0" bIns="0" rtlCol="0" anchor="t"/>
           <a:lstStyle/>
           <a:p>
-            <a:pPr indent="0" marL="0">
+            <a:pPr marL="0" indent="0">
               <a:buNone/>
             </a:pPr>
             <a:r>
@@ -10518,7 +11293,7 @@
                   <a:schemeClr val="tx1"/>
                 </a:solidFill>
               </a:rPr>
-              <a:t>Un git add por carpeta mezcló archivos ajenos; desde entonces se añaden por nombre.</a:t>
+              <a:t>La IA recomendó conservar docker/ sin ejecutarlo; elegí quitarlo: no se afirma lo que no se probó (evidencia 015).</a:t>
             </a:r>
             <a:endParaRPr lang="en-US" sz="1400" dirty="0"/>
           </a:p>
@@ -10544,7 +11319,7 @@
           </a:prstGeom>
           <a:extLst>
             <a:ext uri="{C572A759-6A51-4108-AA02-DFA0A04FC94B}">
-              <ma14:wrappingTextBoxFlag xmlns:ma14="http://schemas.microsoft.com/office/mac/drawingml/2011/main" val="0"/>
+              <ma14:wrappingTextBoxFlag xmlns:ma14="http://schemas.microsoft.com/office/mac/drawingml/2011/main" xmlns="" val="0"/>
             </a:ext>
           </a:extLst>
         </p:spPr>
@@ -10562,7 +11337,7 @@
           <a:p>
             <a:pPr algn="r"/>
             <a:fld id="{F7021451-1387-4CA6-816F-3879F97B5CBC}" type="slidenum">
-              <a:rPr b="0" lang="en-US"/>
+              <a:rPr lang="en-US" b="0"/>
               <a:t>9</a:t>
             </a:fld>
             <a:endParaRPr lang="en-US"/>
@@ -10870,4 +11645,265 @@
     </a:ext>
   </a:extLst>
 </a:theme>
+</file>
+
+<file path=ppt/theme/theme2.xml><?xml version="1.0" encoding="utf-8"?>
+<a:theme xmlns:a="http://schemas.openxmlformats.org/drawingml/2006/main" name="Tema de Office">
+  <a:themeElements>
+    <a:clrScheme name="Office">
+      <a:dk1>
+        <a:sysClr val="windowText" lastClr="000000"/>
+      </a:dk1>
+      <a:lt1>
+        <a:sysClr val="window" lastClr="FFFFFF"/>
+      </a:lt1>
+      <a:dk2>
+        <a:srgbClr val="44546A"/>
+      </a:dk2>
+      <a:lt2>
+        <a:srgbClr val="E7E6E6"/>
+      </a:lt2>
+      <a:accent1>
+        <a:srgbClr val="5B9BD5"/>
+      </a:accent1>
+      <a:accent2>
+        <a:srgbClr val="ED7D31"/>
+      </a:accent2>
+      <a:accent3>
+        <a:srgbClr val="A5A5A5"/>
+      </a:accent3>
+      <a:accent4>
+        <a:srgbClr val="FFC000"/>
+      </a:accent4>
+      <a:accent5>
+        <a:srgbClr val="4472C4"/>
+      </a:accent5>
+      <a:accent6>
+        <a:srgbClr val="70AD47"/>
+      </a:accent6>
+      <a:hlink>
+        <a:srgbClr val="0563C1"/>
+      </a:hlink>
+      <a:folHlink>
+        <a:srgbClr val="954F72"/>
+      </a:folHlink>
+    </a:clrScheme>
+    <a:fontScheme name="Office">
+      <a:majorFont>
+        <a:latin typeface="Calibri Light" panose="020F0302020204030204"/>
+        <a:ea typeface=""/>
+        <a:cs typeface=""/>
+        <a:font script="Jpan" typeface="游ゴシック Light"/>
+        <a:font script="Hang" typeface="맑은 고딕"/>
+        <a:font script="Hans" typeface="等线 Light"/>
+        <a:font script="Hant" typeface="新細明體"/>
+        <a:font script="Arab" typeface="Times New Roman"/>
+        <a:font script="Hebr" typeface="Times New Roman"/>
+        <a:font script="Thai" typeface="Angsana New"/>
+        <a:font script="Ethi" typeface="Nyala"/>
+        <a:font script="Beng" typeface="Vrinda"/>
+        <a:font script="Gujr" typeface="Shruti"/>
+        <a:font script="Khmr" typeface="MoolBoran"/>
+        <a:font script="Knda" typeface="Tunga"/>
+        <a:font script="Guru" typeface="Raavi"/>
+        <a:font script="Cans" typeface="Euphemia"/>
+        <a:font script="Cher" typeface="Plantagenet Cherokee"/>
+        <a:font script="Yiii" typeface="Microsoft Yi Baiti"/>
+        <a:font script="Tibt" typeface="Microsoft Himalaya"/>
+        <a:font script="Thaa" typeface="MV Boli"/>
+        <a:font script="Deva" typeface="Mangal"/>
+        <a:font script="Telu" typeface="Gautami"/>
+        <a:font script="Taml" typeface="Latha"/>
+        <a:font script="Syrc" typeface="Estrangelo Edessa"/>
+        <a:font script="Orya" typeface="Kalinga"/>
+        <a:font script="Mlym" typeface="Kartika"/>
+        <a:font script="Laoo" typeface="DokChampa"/>
+        <a:font script="Sinh" typeface="Iskoola Pota"/>
+        <a:font script="Mong" typeface="Mongolian Baiti"/>
+        <a:font script="Viet" typeface="Times New Roman"/>
+        <a:font script="Uigh" typeface="Microsoft Uighur"/>
+        <a:font script="Geor" typeface="Sylfaen"/>
+      </a:majorFont>
+      <a:minorFont>
+        <a:latin typeface="Calibri" panose="020F0502020204030204"/>
+        <a:ea typeface=""/>
+        <a:cs typeface=""/>
+        <a:font script="Jpan" typeface="游ゴシック"/>
+        <a:font script="Hang" typeface="맑은 고딕"/>
+        <a:font script="Hans" typeface="等线"/>
+        <a:font script="Hant" typeface="新細明體"/>
+        <a:font script="Arab" typeface="Arial"/>
+        <a:font script="Hebr" typeface="Arial"/>
+        <a:font script="Thai" typeface="Cordia New"/>
+        <a:font script="Ethi" typeface="Nyala"/>
+        <a:font script="Beng" typeface="Vrinda"/>
+        <a:font script="Gujr" typeface="Shruti"/>
+        <a:font script="Khmr" typeface="DaunPenh"/>
+        <a:font script="Knda" typeface="Tunga"/>
+        <a:font script="Guru" typeface="Raavi"/>
+        <a:font script="Cans" typeface="Euphemia"/>
+        <a:font script="Cher" typeface="Plantagenet Cherokee"/>
+        <a:font script="Yiii" typeface="Microsoft Yi Baiti"/>
+        <a:font script="Tibt" typeface="Microsoft Himalaya"/>
+        <a:font script="Thaa" typeface="MV Boli"/>
+        <a:font script="Deva" typeface="Mangal"/>
+        <a:font script="Telu" typeface="Gautami"/>
+        <a:font script="Taml" typeface="Latha"/>
+        <a:font script="Syrc" typeface="Estrangelo Edessa"/>
+        <a:font script="Orya" typeface="Kalinga"/>
+        <a:font script="Mlym" typeface="Kartika"/>
+        <a:font script="Laoo" typeface="DokChampa"/>
+        <a:font script="Sinh" typeface="Iskoola Pota"/>
+        <a:font script="Mong" typeface="Mongolian Baiti"/>
+        <a:font script="Viet" typeface="Arial"/>
+        <a:font script="Uigh" typeface="Microsoft Uighur"/>
+        <a:font script="Geor" typeface="Sylfaen"/>
+      </a:minorFont>
+    </a:fontScheme>
+    <a:fmtScheme name="Office">
+      <a:fillStyleLst>
+        <a:solidFill>
+          <a:schemeClr val="phClr"/>
+        </a:solidFill>
+        <a:gradFill rotWithShape="1">
+          <a:gsLst>
+            <a:gs pos="0">
+              <a:schemeClr val="phClr">
+                <a:lumMod val="110000"/>
+                <a:satMod val="105000"/>
+                <a:tint val="67000"/>
+              </a:schemeClr>
+            </a:gs>
+            <a:gs pos="50000">
+              <a:schemeClr val="phClr">
+                <a:lumMod val="105000"/>
+                <a:satMod val="103000"/>
+                <a:tint val="73000"/>
+              </a:schemeClr>
+            </a:gs>
+            <a:gs pos="100000">
+              <a:schemeClr val="phClr">
+                <a:lumMod val="105000"/>
+                <a:satMod val="109000"/>
+                <a:tint val="81000"/>
+              </a:schemeClr>
+            </a:gs>
+          </a:gsLst>
+          <a:lin ang="5400000" scaled="0"/>
+        </a:gradFill>
+        <a:gradFill rotWithShape="1">
+          <a:gsLst>
+            <a:gs pos="0">
+              <a:schemeClr val="phClr">
+                <a:satMod val="103000"/>
+                <a:lumMod val="102000"/>
+                <a:tint val="94000"/>
+              </a:schemeClr>
+            </a:gs>
+            <a:gs pos="50000">
+              <a:schemeClr val="phClr">
+                <a:satMod val="110000"/>
+                <a:lumMod val="100000"/>
+                <a:shade val="100000"/>
+              </a:schemeClr>
+            </a:gs>
+            <a:gs pos="100000">
+              <a:schemeClr val="phClr">
+                <a:lumMod val="99000"/>
+                <a:satMod val="120000"/>
+                <a:shade val="78000"/>
+              </a:schemeClr>
+            </a:gs>
+          </a:gsLst>
+          <a:lin ang="5400000" scaled="0"/>
+        </a:gradFill>
+      </a:fillStyleLst>
+      <a:lnStyleLst>
+        <a:ln w="6350" cap="flat" cmpd="sng" algn="ctr">
+          <a:solidFill>
+            <a:schemeClr val="phClr"/>
+          </a:solidFill>
+          <a:prstDash val="solid"/>
+          <a:miter lim="800000"/>
+        </a:ln>
+        <a:ln w="12700" cap="flat" cmpd="sng" algn="ctr">
+          <a:solidFill>
+            <a:schemeClr val="phClr"/>
+          </a:solidFill>
+          <a:prstDash val="solid"/>
+          <a:miter lim="800000"/>
+        </a:ln>
+        <a:ln w="19050" cap="flat" cmpd="sng" algn="ctr">
+          <a:solidFill>
+            <a:schemeClr val="phClr"/>
+          </a:solidFill>
+          <a:prstDash val="solid"/>
+          <a:miter lim="800000"/>
+        </a:ln>
+      </a:lnStyleLst>
+      <a:effectStyleLst>
+        <a:effectStyle>
+          <a:effectLst/>
+        </a:effectStyle>
+        <a:effectStyle>
+          <a:effectLst/>
+        </a:effectStyle>
+        <a:effectStyle>
+          <a:effectLst>
+            <a:outerShdw blurRad="57150" dist="19050" dir="5400000" algn="ctr" rotWithShape="0">
+              <a:srgbClr val="000000">
+                <a:alpha val="63000"/>
+              </a:srgbClr>
+            </a:outerShdw>
+          </a:effectLst>
+        </a:effectStyle>
+      </a:effectStyleLst>
+      <a:bgFillStyleLst>
+        <a:solidFill>
+          <a:schemeClr val="phClr"/>
+        </a:solidFill>
+        <a:solidFill>
+          <a:schemeClr val="phClr">
+            <a:tint val="95000"/>
+            <a:satMod val="170000"/>
+          </a:schemeClr>
+        </a:solidFill>
+        <a:gradFill rotWithShape="1">
+          <a:gsLst>
+            <a:gs pos="0">
+              <a:schemeClr val="phClr">
+                <a:tint val="93000"/>
+                <a:satMod val="150000"/>
+                <a:shade val="98000"/>
+                <a:lumMod val="102000"/>
+              </a:schemeClr>
+            </a:gs>
+            <a:gs pos="50000">
+              <a:schemeClr val="phClr">
+                <a:tint val="98000"/>
+                <a:satMod val="130000"/>
+                <a:shade val="90000"/>
+                <a:lumMod val="103000"/>
+              </a:schemeClr>
+            </a:gs>
+            <a:gs pos="100000">
+              <a:schemeClr val="phClr">
+                <a:shade val="63000"/>
+                <a:satMod val="120000"/>
+              </a:schemeClr>
+            </a:gs>
+          </a:gsLst>
+          <a:lin ang="5400000" scaled="0"/>
+        </a:gradFill>
+      </a:bgFillStyleLst>
+    </a:fmtScheme>
+  </a:themeElements>
+  <a:objectDefaults/>
+  <a:extraClrSchemeLst/>
+  <a:extLst>
+    <a:ext uri="{05A4C25C-085E-4340-85A3-A5531E510DB2}">
+      <thm15:themeFamily xmlns:thm15="http://schemas.microsoft.com/office/thememl/2012/main" name="Office Theme" id="{62F939B6-93AF-4DB8-9C6B-D6C7DFDC589F}" vid="{4A3C46E8-61CC-4603-A589-7422A47A8E4A}"/>
+    </a:ext>
+  </a:extLst>
+</a:theme>
 </file>
</xml_diff>

<commit_message>
docs(presentacion): version 1.3 con los cambios del responsable (portada y titulos de seccion)
Se parte de la v1.2 editada por el responsable el 30/10: subtitulo de la
portada y una etiqueta de seccion sobre el titulo de 7 diapositivas. Se
corrigen dos erratas (Architecture y un doble espacio). Sin cambios de codigo.

Co-Authored-By: Claude Opus 5.5 <noreply@anthropic.com>
</commit_message>
<xml_diff>
--- a/docs/presentacion.pptx
+++ b/docs/presentacion.pptx
@@ -241,6 +241,7 @@
             <c:showLeaderLines val="0"/>
             <c:extLst>
               <c:ext xmlns:c15="http://schemas.microsoft.com/office/drawing/2012/chart" uri="{CE6537A1-D6FC-4f65-9D91-7224C49458BB}">
+                <c15:layout/>
                 <c15:showLeaderLines val="0"/>
               </c:ext>
             </c:extLst>
@@ -1887,7 +1888,7 @@
           </a:prstGeom>
           <a:extLst>
             <a:ext uri="{C572A759-6A51-4108-AA02-DFA0A04FC94B}">
-              <ma14:wrappingTextBoxFlag xmlns:ma14="http://schemas.microsoft.com/office/mac/drawingml/2011/main" xmlns="" val="0"/>
+              <ma14:wrappingTextBoxFlag xmlns="" xmlns:ma14="http://schemas.microsoft.com/office/mac/drawingml/2011/main" val="0"/>
             </a:ext>
           </a:extLst>
         </p:spPr>
@@ -1962,7 +1963,7 @@
           </a:prstGeom>
           <a:extLst>
             <a:ext uri="{C572A759-6A51-4108-AA02-DFA0A04FC94B}">
-              <ma14:wrappingTextBoxFlag xmlns:ma14="http://schemas.microsoft.com/office/mac/drawingml/2011/main" xmlns="" val="0"/>
+              <ma14:wrappingTextBoxFlag xmlns="" xmlns:ma14="http://schemas.microsoft.com/office/mac/drawingml/2011/main" val="0"/>
             </a:ext>
           </a:extLst>
         </p:spPr>
@@ -2390,12 +2391,68 @@
               <a:buNone/>
             </a:pPr>
             <a:r>
+              <a:rPr lang="en-US" sz="2000" dirty="0" smtClean="0">
+                <a:solidFill>
+                  <a:schemeClr val="accent6"/>
+                </a:solidFill>
+              </a:rPr>
+              <a:t>De un </a:t>
+            </a:r>
+            <a:r>
+              <a:rPr lang="en-US" sz="2000" dirty="0" err="1">
+                <a:solidFill>
+                  <a:schemeClr val="accent6"/>
+                </a:solidFill>
+              </a:rPr>
+              <a:t>sistema</a:t>
+            </a:r>
+            <a:r>
               <a:rPr lang="en-US" sz="2000" dirty="0">
                 <a:solidFill>
                   <a:schemeClr val="accent6"/>
                 </a:solidFill>
               </a:rPr>
-              <a:t>Del sistema que decía «éxito» sin grabar, a un módulo especificado, probado y </a:t>
+              <a:t> </a:t>
+            </a:r>
+            <a:r>
+              <a:rPr lang="en-US" sz="2000" dirty="0" err="1" smtClean="0">
+                <a:solidFill>
+                  <a:schemeClr val="accent6"/>
+                </a:solidFill>
+              </a:rPr>
+              <a:t>legado</a:t>
+            </a:r>
+            <a:r>
+              <a:rPr lang="en-US" sz="2000" dirty="0" smtClean="0">
+                <a:solidFill>
+                  <a:schemeClr val="accent6"/>
+                </a:solidFill>
+              </a:rPr>
+              <a:t> </a:t>
+            </a:r>
+            <a:r>
+              <a:rPr lang="en-US" sz="2000" dirty="0" err="1" smtClean="0">
+                <a:solidFill>
+                  <a:schemeClr val="accent6"/>
+                </a:solidFill>
+              </a:rPr>
+              <a:t>obsoleto</a:t>
+            </a:r>
+            <a:r>
+              <a:rPr lang="en-US" sz="2000" dirty="0" smtClean="0">
+                <a:solidFill>
+                  <a:schemeClr val="accent6"/>
+                </a:solidFill>
+              </a:rPr>
+              <a:t> </a:t>
+            </a:r>
+            <a:r>
+              <a:rPr lang="en-US" sz="2000" dirty="0">
+                <a:solidFill>
+                  <a:schemeClr val="accent6"/>
+                </a:solidFill>
+              </a:rPr>
+              <a:t>a un módulo especificado, probado y </a:t>
             </a:r>
             <a:r>
               <a:rPr lang="en-US" sz="2000" dirty="0" err="1" smtClean="0">
@@ -2494,6 +2551,10 @@
             <a:prstDash val="solid"/>
           </a:ln>
         </p:spPr>
+        <p:txBody>
+          <a:bodyPr/>
+          <a:p/>
+        </p:txBody>
       </p:sp>
       <p:sp>
         <p:nvSpPr>
@@ -2554,6 +2615,10 @@
             <a:tailEnd type="triangle"/>
           </a:ln>
         </p:spPr>
+        <p:txBody>
+          <a:bodyPr/>
+          <a:p/>
+        </p:txBody>
       </p:sp>
       <p:sp>
         <p:nvSpPr>
@@ -2579,6 +2644,10 @@
             <a:prstDash val="solid"/>
           </a:ln>
         </p:spPr>
+        <p:txBody>
+          <a:bodyPr/>
+          <a:p/>
+        </p:txBody>
       </p:sp>
       <p:sp>
         <p:nvSpPr>
@@ -2639,6 +2708,10 @@
             <a:tailEnd type="triangle"/>
           </a:ln>
         </p:spPr>
+        <p:txBody>
+          <a:bodyPr/>
+          <a:p/>
+        </p:txBody>
       </p:sp>
       <p:sp>
         <p:nvSpPr>
@@ -2664,6 +2737,10 @@
             <a:prstDash val="solid"/>
           </a:ln>
         </p:spPr>
+        <p:txBody>
+          <a:bodyPr/>
+          <a:p/>
+        </p:txBody>
       </p:sp>
       <p:sp>
         <p:nvSpPr>
@@ -2706,6 +2783,13 @@
   <p:clrMapOvr>
     <a:masterClrMapping/>
   </p:clrMapOvr>
+  <p:timing>
+    <p:tnLst>
+      <p:par>
+        <p:cTn id="1" dur="indefinite" restart="never" nodeType="tmRoot"/>
+      </p:par>
+    </p:tnLst>
+  </p:timing>
 </p:sld>
 </file>
 
@@ -2755,7 +2839,7 @@
               <a:buNone/>
             </a:pPr>
             <a:r>
-              <a:rPr lang="en-US" sz="3400" b="1" dirty="0">
+              <a:rPr lang="en-US" sz="3400" b="1" dirty="0" smtClean="0">
                 <a:solidFill>
                   <a:schemeClr val="tx2"/>
                 </a:solidFill>
@@ -2763,7 +2847,39 @@
                 <a:ea typeface="Cambria" pitchFamily="34" charset="-122"/>
                 <a:cs typeface="Cambria" pitchFamily="34" charset="-120"/>
               </a:rPr>
-              <a:t>Un prompt corto funciona cuando la spec es el contexto</a:t>
+              <a:t>Prompt y Diff</a:t>
+            </a:r>
+            <a:br>
+              <a:rPr lang="en-US" sz="3400" b="1" dirty="0" smtClean="0">
+                <a:solidFill>
+                  <a:schemeClr val="tx2"/>
+                </a:solidFill>
+                <a:latin typeface="Cambria" pitchFamily="34" charset="0"/>
+                <a:ea typeface="Cambria" pitchFamily="34" charset="-122"/>
+                <a:cs typeface="Cambria" pitchFamily="34" charset="-120"/>
+              </a:rPr>
+            </a:br>
+            <a:r>
+              <a:rPr lang="en-US" sz="3400" b="1" dirty="0" smtClean="0">
+                <a:solidFill>
+                  <a:schemeClr val="tx2"/>
+                </a:solidFill>
+                <a:latin typeface="Cambria" pitchFamily="34" charset="0"/>
+                <a:ea typeface="Cambria" pitchFamily="34" charset="-122"/>
+                <a:cs typeface="Cambria" pitchFamily="34" charset="-120"/>
+              </a:rPr>
+              <a:t>Un </a:t>
+            </a:r>
+            <a:r>
+              <a:rPr lang="en-US" sz="3400" b="1" dirty="0">
+                <a:solidFill>
+                  <a:schemeClr val="tx2"/>
+                </a:solidFill>
+                <a:latin typeface="Cambria" pitchFamily="34" charset="0"/>
+                <a:ea typeface="Cambria" pitchFamily="34" charset="-122"/>
+                <a:cs typeface="Cambria" pitchFamily="34" charset="-120"/>
+              </a:rPr>
+              <a:t>prompt corto funciona cuando la spec es el contexto</a:t>
             </a:r>
             <a:endParaRPr lang="en-US" sz="3400" dirty="0"/>
           </a:p>
@@ -2789,7 +2905,7 @@
           </a:prstGeom>
           <a:extLst>
             <a:ext uri="{C572A759-6A51-4108-AA02-DFA0A04FC94B}">
-              <ma14:wrappingTextBoxFlag xmlns:ma14="http://schemas.microsoft.com/office/mac/drawingml/2011/main" xmlns="" val="0"/>
+              <ma14:wrappingTextBoxFlag xmlns="" xmlns:ma14="http://schemas.microsoft.com/office/mac/drawingml/2011/main" val="0"/>
             </a:ext>
           </a:extLst>
         </p:spPr>
@@ -2840,6 +2956,10 @@
             <a:prstDash val="solid"/>
           </a:ln>
         </p:spPr>
+        <p:txBody>
+          <a:bodyPr/>
+          <a:p/>
+        </p:txBody>
       </p:sp>
       <p:sp>
         <p:nvSpPr>
@@ -2978,6 +3098,10 @@
             <a:prstDash val="solid"/>
           </a:ln>
         </p:spPr>
+        <p:txBody>
+          <a:bodyPr/>
+          <a:p/>
+        </p:txBody>
       </p:sp>
       <p:sp>
         <p:nvSpPr>
@@ -3105,6 +3229,10 @@
             <a:prstDash val="solid"/>
           </a:ln>
         </p:spPr>
+        <p:txBody>
+          <a:bodyPr/>
+          <a:p/>
+        </p:txBody>
       </p:sp>
       <p:sp>
         <p:nvSpPr>
@@ -3250,6 +3378,10 @@
             <a:prstDash val="solid"/>
           </a:ln>
         </p:spPr>
+        <p:txBody>
+          <a:bodyPr/>
+          <a:p/>
+        </p:txBody>
       </p:sp>
       <p:sp>
         <p:nvSpPr>
@@ -3328,6 +3460,13 @@
   <p:clrMapOvr>
     <a:masterClrMapping/>
   </p:clrMapOvr>
+  <p:timing>
+    <p:tnLst>
+      <p:par>
+        <p:cTn id="1" dur="indefinite" restart="never" nodeType="tmRoot"/>
+      </p:par>
+    </p:tnLst>
+  </p:timing>
 </p:sld>
 </file>
 
@@ -3415,6 +3554,10 @@
             <a:prstDash val="solid"/>
           </a:ln>
         </p:spPr>
+        <p:txBody>
+          <a:bodyPr/>
+          <a:p/>
+        </p:txBody>
       </p:sp>
       <p:sp>
         <p:nvSpPr>
@@ -3512,6 +3655,10 @@
             <a:prstDash val="solid"/>
           </a:ln>
         </p:spPr>
+        <p:txBody>
+          <a:bodyPr/>
+          <a:p/>
+        </p:txBody>
       </p:sp>
       <p:sp>
         <p:nvSpPr>
@@ -3609,6 +3756,10 @@
             <a:prstDash val="solid"/>
           </a:ln>
         </p:spPr>
+        <p:txBody>
+          <a:bodyPr/>
+          <a:p/>
+        </p:txBody>
       </p:sp>
       <p:sp>
         <p:nvSpPr>
@@ -3706,6 +3857,10 @@
             <a:prstDash val="solid"/>
           </a:ln>
         </p:spPr>
+        <p:txBody>
+          <a:bodyPr/>
+          <a:p/>
+        </p:txBody>
       </p:sp>
       <p:sp>
         <p:nvSpPr>
@@ -3803,6 +3958,10 @@
             <a:prstDash val="solid"/>
           </a:ln>
         </p:spPr>
+        <p:txBody>
+          <a:bodyPr/>
+          <a:p/>
+        </p:txBody>
       </p:sp>
       <p:sp>
         <p:nvSpPr>
@@ -3900,6 +4059,10 @@
             <a:prstDash val="solid"/>
           </a:ln>
         </p:spPr>
+        <p:txBody>
+          <a:bodyPr/>
+          <a:p/>
+        </p:txBody>
       </p:sp>
       <p:sp>
         <p:nvSpPr>
@@ -3997,6 +4160,10 @@
             <a:prstDash val="solid"/>
           </a:ln>
         </p:spPr>
+        <p:txBody>
+          <a:bodyPr/>
+          <a:p/>
+        </p:txBody>
       </p:sp>
       <p:sp>
         <p:nvSpPr>
@@ -4096,6 +4263,10 @@
             <a:prstDash val="solid"/>
           </a:ln>
         </p:spPr>
+        <p:txBody>
+          <a:bodyPr/>
+          <a:p/>
+        </p:txBody>
       </p:sp>
       <p:sp>
         <p:nvSpPr>
@@ -4189,7 +4360,7 @@
           </a:prstGeom>
           <a:extLst>
             <a:ext uri="{C572A759-6A51-4108-AA02-DFA0A04FC94B}">
-              <ma14:wrappingTextBoxFlag xmlns:ma14="http://schemas.microsoft.com/office/mac/drawingml/2011/main" xmlns="" val="0"/>
+              <ma14:wrappingTextBoxFlag xmlns="" xmlns:ma14="http://schemas.microsoft.com/office/mac/drawingml/2011/main" val="0"/>
             </a:ext>
           </a:extLst>
         </p:spPr>
@@ -4219,6 +4390,13 @@
   <p:clrMapOvr>
     <a:masterClrMapping/>
   </p:clrMapOvr>
+  <p:timing>
+    <p:tnLst>
+      <p:par>
+        <p:cTn id="1" dur="indefinite" restart="never" nodeType="tmRoot"/>
+      </p:par>
+    </p:tnLst>
+  </p:timing>
 </p:sld>
 </file>
 
@@ -4308,6 +4486,10 @@
             <a:prstDash val="solid"/>
           </a:ln>
         </p:spPr>
+        <p:txBody>
+          <a:bodyPr/>
+          <a:p/>
+        </p:txBody>
       </p:sp>
       <p:sp>
         <p:nvSpPr>
@@ -4483,6 +4665,10 @@
             <a:prstDash val="solid"/>
           </a:ln>
         </p:spPr>
+        <p:txBody>
+          <a:bodyPr/>
+          <a:p/>
+        </p:txBody>
       </p:sp>
       <p:sp>
         <p:nvSpPr>
@@ -4634,7 +4820,7 @@
           </a:prstGeom>
           <a:extLst>
             <a:ext uri="{C572A759-6A51-4108-AA02-DFA0A04FC94B}">
-              <ma14:wrappingTextBoxFlag xmlns:ma14="http://schemas.microsoft.com/office/mac/drawingml/2011/main" xmlns="" val="0"/>
+              <ma14:wrappingTextBoxFlag xmlns="" xmlns:ma14="http://schemas.microsoft.com/office/mac/drawingml/2011/main" val="0"/>
             </a:ext>
           </a:extLst>
         </p:spPr>
@@ -4664,6 +4850,13 @@
   <p:clrMapOvr>
     <a:masterClrMapping/>
   </p:clrMapOvr>
+  <p:timing>
+    <p:tnLst>
+      <p:par>
+        <p:cTn id="1" dur="indefinite" restart="never" nodeType="tmRoot"/>
+      </p:par>
+    </p:tnLst>
+  </p:timing>
 </p:sld>
 </file>
 
@@ -4786,6 +4979,13 @@
   <p:clrMapOvr>
     <a:masterClrMapping/>
   </p:clrMapOvr>
+  <p:timing>
+    <p:tnLst>
+      <p:par>
+        <p:cTn id="1" dur="indefinite" restart="never" nodeType="tmRoot"/>
+      </p:par>
+    </p:tnLst>
+  </p:timing>
 </p:sld>
 </file>
 
@@ -4818,8 +5018,8 @@
         </p:nvSpPr>
         <p:spPr>
           <a:xfrm>
-            <a:off x="548640" y="365760"/>
-            <a:ext cx="11094415" cy="822960"/>
+            <a:off x="548640" y="365759"/>
+            <a:ext cx="11094415" cy="1080485"/>
           </a:xfrm>
           <a:prstGeom prst="rect">
             <a:avLst/>
@@ -4835,7 +5035,7 @@
               <a:buNone/>
             </a:pPr>
             <a:r>
-              <a:rPr lang="en-US" sz="3400" b="1" dirty="0">
+              <a:rPr lang="en-US" sz="3400" b="1" dirty="0" smtClean="0">
                 <a:solidFill>
                   <a:schemeClr val="tx2"/>
                 </a:solidFill>
@@ -4843,7 +5043,61 @@
                 <a:ea typeface="Cambria" pitchFamily="34" charset="-122"/>
                 <a:cs typeface="Cambria" pitchFamily="34" charset="-120"/>
               </a:rPr>
-              <a:t>El sistema original fallaba donde más duele</a:t>
+              <a:t>El </a:t>
+            </a:r>
+            <a:r>
+              <a:rPr lang="en-US" sz="3400" b="1" dirty="0" err="1" smtClean="0">
+                <a:solidFill>
+                  <a:schemeClr val="tx2"/>
+                </a:solidFill>
+                <a:latin typeface="Cambria" pitchFamily="34" charset="0"/>
+                <a:ea typeface="Cambria" pitchFamily="34" charset="-122"/>
+                <a:cs typeface="Cambria" pitchFamily="34" charset="-120"/>
+              </a:rPr>
+              <a:t>Problema</a:t>
+            </a:r>
+            <a:r>
+              <a:rPr lang="en-US" sz="3400" b="1" dirty="0" smtClean="0">
+                <a:solidFill>
+                  <a:schemeClr val="tx2"/>
+                </a:solidFill>
+                <a:latin typeface="Cambria" pitchFamily="34" charset="0"/>
+                <a:ea typeface="Cambria" pitchFamily="34" charset="-122"/>
+                <a:cs typeface="Cambria" pitchFamily="34" charset="-120"/>
+              </a:rPr>
+              <a:t/>
+            </a:r>
+            <a:br>
+              <a:rPr lang="en-US" sz="3400" b="1" dirty="0" smtClean="0">
+                <a:solidFill>
+                  <a:schemeClr val="tx2"/>
+                </a:solidFill>
+                <a:latin typeface="Cambria" pitchFamily="34" charset="0"/>
+                <a:ea typeface="Cambria" pitchFamily="34" charset="-122"/>
+                <a:cs typeface="Cambria" pitchFamily="34" charset="-120"/>
+              </a:rPr>
+            </a:br>
+            <a:r>
+              <a:rPr lang="en-US" sz="3400" b="1" dirty="0" smtClean="0">
+                <a:solidFill>
+                  <a:schemeClr val="tx2"/>
+                </a:solidFill>
+                <a:latin typeface="Cambria" pitchFamily="34" charset="0"/>
+                <a:ea typeface="Cambria" pitchFamily="34" charset="-122"/>
+                <a:cs typeface="Cambria" pitchFamily="34" charset="-120"/>
+              </a:rPr>
+              <a:t>El </a:t>
+            </a:r>
+            <a:r>
+              <a:rPr lang="en-US" sz="3400" b="1" dirty="0">
+                <a:solidFill>
+                  <a:schemeClr val="tx2"/>
+                </a:solidFill>
+                <a:latin typeface="Cambria" pitchFamily="34" charset="0"/>
+                <a:ea typeface="Cambria" pitchFamily="34" charset="-122"/>
+                <a:cs typeface="Cambria" pitchFamily="34" charset="-120"/>
+              </a:rPr>
+              <a:t>sistema original fallaba donde más duele</a:t>
             </a:r>
             <a:endParaRPr lang="en-US" sz="3400" dirty="0"/>
           </a:p>
@@ -4875,6 +5129,10 @@
             <a:prstDash val="solid"/>
           </a:ln>
         </p:spPr>
+        <p:txBody>
+          <a:bodyPr/>
+          <a:p/>
+        </p:txBody>
       </p:sp>
       <p:sp>
         <p:nvSpPr>
@@ -4977,6 +5235,10 @@
             <a:prstDash val="solid"/>
           </a:ln>
         </p:spPr>
+        <p:txBody>
+          <a:bodyPr/>
+          <a:p/>
+        </p:txBody>
       </p:sp>
       <p:sp>
         <p:nvSpPr>
@@ -5079,6 +5341,10 @@
             <a:prstDash val="solid"/>
           </a:ln>
         </p:spPr>
+        <p:txBody>
+          <a:bodyPr/>
+          <a:p/>
+        </p:txBody>
       </p:sp>
       <p:sp>
         <p:nvSpPr>
@@ -5181,6 +5447,10 @@
             <a:prstDash val="solid"/>
           </a:ln>
         </p:spPr>
+        <p:txBody>
+          <a:bodyPr/>
+          <a:p/>
+        </p:txBody>
       </p:sp>
       <p:sp>
         <p:nvSpPr>
@@ -5313,7 +5583,7 @@
           </a:prstGeom>
           <a:extLst>
             <a:ext uri="{C572A759-6A51-4108-AA02-DFA0A04FC94B}">
-              <ma14:wrappingTextBoxFlag xmlns:ma14="http://schemas.microsoft.com/office/mac/drawingml/2011/main" xmlns="" val="0"/>
+              <ma14:wrappingTextBoxFlag xmlns="" xmlns:ma14="http://schemas.microsoft.com/office/mac/drawingml/2011/main" val="0"/>
             </a:ext>
           </a:extLst>
         </p:spPr>
@@ -5343,6 +5613,13 @@
   <p:clrMapOvr>
     <a:masterClrMapping/>
   </p:clrMapOvr>
+  <p:timing>
+    <p:tnLst>
+      <p:par>
+        <p:cTn id="1" dur="indefinite" restart="never" nodeType="tmRoot"/>
+      </p:par>
+    </p:tnLst>
+  </p:timing>
 </p:sld>
 </file>
 
@@ -5376,7 +5653,7 @@
         <p:spPr>
           <a:xfrm>
             <a:off x="548640" y="365760"/>
-            <a:ext cx="11094415" cy="822960"/>
+            <a:ext cx="11094415" cy="1051560"/>
           </a:xfrm>
           <a:prstGeom prst="rect">
             <a:avLst/>
@@ -5392,7 +5669,7 @@
               <a:buNone/>
             </a:pPr>
             <a:r>
-              <a:rPr lang="en-US" sz="3400" b="1" dirty="0">
+              <a:rPr lang="en-US" sz="3400" b="1" dirty="0" smtClean="0">
                 <a:solidFill>
                   <a:schemeClr val="tx2"/>
                 </a:solidFill>
@@ -5400,7 +5677,61 @@
                 <a:ea typeface="Cambria" pitchFamily="34" charset="-122"/>
                 <a:cs typeface="Cambria" pitchFamily="34" charset="-120"/>
               </a:rPr>
-              <a:t>Un módulo acotado, de punta a punta</a:t>
+              <a:t>La </a:t>
+            </a:r>
+            <a:r>
+              <a:rPr lang="en-US" sz="3400" b="1" dirty="0" err="1" smtClean="0">
+                <a:solidFill>
+                  <a:schemeClr val="tx2"/>
+                </a:solidFill>
+                <a:latin typeface="Cambria" pitchFamily="34" charset="0"/>
+                <a:ea typeface="Cambria" pitchFamily="34" charset="-122"/>
+                <a:cs typeface="Cambria" pitchFamily="34" charset="-120"/>
+              </a:rPr>
+              <a:t>Solución</a:t>
+            </a:r>
+            <a:r>
+              <a:rPr lang="en-US" sz="3400" b="1" dirty="0" smtClean="0">
+                <a:solidFill>
+                  <a:schemeClr val="tx2"/>
+                </a:solidFill>
+                <a:latin typeface="Cambria" pitchFamily="34" charset="0"/>
+                <a:ea typeface="Cambria" pitchFamily="34" charset="-122"/>
+                <a:cs typeface="Cambria" pitchFamily="34" charset="-120"/>
+              </a:rPr>
+              <a:t/>
+            </a:r>
+            <a:br>
+              <a:rPr lang="en-US" sz="3400" b="1" dirty="0" smtClean="0">
+                <a:solidFill>
+                  <a:schemeClr val="tx2"/>
+                </a:solidFill>
+                <a:latin typeface="Cambria" pitchFamily="34" charset="0"/>
+                <a:ea typeface="Cambria" pitchFamily="34" charset="-122"/>
+                <a:cs typeface="Cambria" pitchFamily="34" charset="-120"/>
+              </a:rPr>
+            </a:br>
+            <a:r>
+              <a:rPr lang="en-US" sz="3400" b="1" dirty="0" smtClean="0">
+                <a:solidFill>
+                  <a:schemeClr val="tx2"/>
+                </a:solidFill>
+                <a:latin typeface="Cambria" pitchFamily="34" charset="0"/>
+                <a:ea typeface="Cambria" pitchFamily="34" charset="-122"/>
+                <a:cs typeface="Cambria" pitchFamily="34" charset="-120"/>
+              </a:rPr>
+              <a:t>Un </a:t>
+            </a:r>
+            <a:r>
+              <a:rPr lang="en-US" sz="3400" b="1" dirty="0">
+                <a:solidFill>
+                  <a:schemeClr val="tx2"/>
+                </a:solidFill>
+                <a:latin typeface="Cambria" pitchFamily="34" charset="0"/>
+                <a:ea typeface="Cambria" pitchFamily="34" charset="-122"/>
+                <a:cs typeface="Cambria" pitchFamily="34" charset="-120"/>
+              </a:rPr>
+              <a:t>módulo acotado, de punta a punta</a:t>
             </a:r>
             <a:endParaRPr lang="en-US" sz="3400" dirty="0"/>
           </a:p>
@@ -5432,6 +5763,10 @@
             <a:prstDash val="solid"/>
           </a:ln>
         </p:spPr>
+        <p:txBody>
+          <a:bodyPr/>
+          <a:p/>
+        </p:txBody>
       </p:sp>
       <p:sp>
         <p:nvSpPr>
@@ -5457,6 +5792,10 @@
             <a:prstDash val="solid"/>
           </a:ln>
         </p:spPr>
+        <p:txBody>
+          <a:bodyPr/>
+          <a:p/>
+        </p:txBody>
       </p:sp>
       <p:sp>
         <p:nvSpPr>
@@ -5589,6 +5928,10 @@
             <a:tailEnd type="triangle"/>
           </a:ln>
         </p:spPr>
+        <p:txBody>
+          <a:bodyPr/>
+          <a:p/>
+        </p:txBody>
       </p:sp>
       <p:sp>
         <p:nvSpPr>
@@ -5616,6 +5959,10 @@
             <a:prstDash val="solid"/>
           </a:ln>
         </p:spPr>
+        <p:txBody>
+          <a:bodyPr/>
+          <a:p/>
+        </p:txBody>
       </p:sp>
       <p:sp>
         <p:nvSpPr>
@@ -5641,6 +5988,10 @@
             <a:prstDash val="solid"/>
           </a:ln>
         </p:spPr>
+        <p:txBody>
+          <a:bodyPr/>
+          <a:p/>
+        </p:txBody>
       </p:sp>
       <p:sp>
         <p:nvSpPr>
@@ -5773,6 +6124,10 @@
             <a:tailEnd type="triangle"/>
           </a:ln>
         </p:spPr>
+        <p:txBody>
+          <a:bodyPr/>
+          <a:p/>
+        </p:txBody>
       </p:sp>
       <p:sp>
         <p:nvSpPr>
@@ -5800,6 +6155,10 @@
             <a:prstDash val="solid"/>
           </a:ln>
         </p:spPr>
+        <p:txBody>
+          <a:bodyPr/>
+          <a:p/>
+        </p:txBody>
       </p:sp>
       <p:sp>
         <p:nvSpPr>
@@ -5825,6 +6184,10 @@
             <a:prstDash val="solid"/>
           </a:ln>
         </p:spPr>
+        <p:txBody>
+          <a:bodyPr/>
+          <a:p/>
+        </p:txBody>
       </p:sp>
       <p:sp>
         <p:nvSpPr>
@@ -6170,7 +6533,7 @@
           </a:prstGeom>
           <a:extLst>
             <a:ext uri="{C572A759-6A51-4108-AA02-DFA0A04FC94B}">
-              <ma14:wrappingTextBoxFlag xmlns:ma14="http://schemas.microsoft.com/office/mac/drawingml/2011/main" xmlns="" val="0"/>
+              <ma14:wrappingTextBoxFlag xmlns="" xmlns:ma14="http://schemas.microsoft.com/office/mac/drawingml/2011/main" val="0"/>
             </a:ext>
           </a:extLst>
         </p:spPr>
@@ -6200,6 +6563,13 @@
   <p:clrMapOvr>
     <a:masterClrMapping/>
   </p:clrMapOvr>
+  <p:timing>
+    <p:tnLst>
+      <p:par>
+        <p:cTn id="1" dur="indefinite" restart="never" nodeType="tmRoot"/>
+      </p:par>
+    </p:tnLst>
+  </p:timing>
 </p:sld>
 </file>
 
@@ -6700,6 +7070,10 @@
             <a:prstDash val="solid"/>
           </a:ln>
         </p:spPr>
+        <p:txBody>
+          <a:bodyPr/>
+          <a:p/>
+        </p:txBody>
       </p:sp>
       <p:sp>
         <p:nvSpPr>
@@ -6760,6 +7134,10 @@
             <a:tailEnd type="triangle"/>
           </a:ln>
         </p:spPr>
+        <p:txBody>
+          <a:bodyPr/>
+          <a:p/>
+        </p:txBody>
       </p:sp>
       <p:sp>
         <p:nvSpPr>
@@ -6787,6 +7165,10 @@
             <a:prstDash val="solid"/>
           </a:ln>
         </p:spPr>
+        <p:txBody>
+          <a:bodyPr/>
+          <a:p/>
+        </p:txBody>
       </p:sp>
       <p:sp>
         <p:nvSpPr>
@@ -6847,6 +7229,10 @@
             <a:tailEnd type="triangle"/>
           </a:ln>
         </p:spPr>
+        <p:txBody>
+          <a:bodyPr/>
+          <a:p/>
+        </p:txBody>
       </p:sp>
       <p:sp>
         <p:nvSpPr>
@@ -6874,6 +7260,10 @@
             <a:prstDash val="solid"/>
           </a:ln>
         </p:spPr>
+        <p:txBody>
+          <a:bodyPr/>
+          <a:p/>
+        </p:txBody>
       </p:sp>
       <p:sp>
         <p:nvSpPr>
@@ -6934,6 +7324,10 @@
             <a:tailEnd type="triangle"/>
           </a:ln>
         </p:spPr>
+        <p:txBody>
+          <a:bodyPr/>
+          <a:p/>
+        </p:txBody>
       </p:sp>
       <p:sp>
         <p:nvSpPr>
@@ -6961,6 +7355,10 @@
             <a:prstDash val="solid"/>
           </a:ln>
         </p:spPr>
+        <p:txBody>
+          <a:bodyPr/>
+          <a:p/>
+        </p:txBody>
       </p:sp>
       <p:sp>
         <p:nvSpPr>
@@ -7021,6 +7419,10 @@
             <a:tailEnd type="triangle"/>
           </a:ln>
         </p:spPr>
+        <p:txBody>
+          <a:bodyPr/>
+          <a:p/>
+        </p:txBody>
       </p:sp>
       <p:sp>
         <p:nvSpPr>
@@ -7048,6 +7450,10 @@
             <a:prstDash val="solid"/>
           </a:ln>
         </p:spPr>
+        <p:txBody>
+          <a:bodyPr/>
+          <a:p/>
+        </p:txBody>
       </p:sp>
       <p:sp>
         <p:nvSpPr>
@@ -7108,6 +7514,10 @@
             <a:tailEnd type="triangle"/>
           </a:ln>
         </p:spPr>
+        <p:txBody>
+          <a:bodyPr/>
+          <a:p/>
+        </p:txBody>
       </p:sp>
       <p:sp>
         <p:nvSpPr>
@@ -7135,6 +7545,10 @@
             <a:prstDash val="solid"/>
           </a:ln>
         </p:spPr>
+        <p:txBody>
+          <a:bodyPr/>
+          <a:p/>
+        </p:txBody>
       </p:sp>
       <p:sp>
         <p:nvSpPr>
@@ -7195,6 +7609,10 @@
             <a:tailEnd type="triangle"/>
           </a:ln>
         </p:spPr>
+        <p:txBody>
+          <a:bodyPr/>
+          <a:p/>
+        </p:txBody>
       </p:sp>
       <p:sp>
         <p:nvSpPr>
@@ -7222,6 +7640,10 @@
             <a:prstDash val="solid"/>
           </a:ln>
         </p:spPr>
+        <p:txBody>
+          <a:bodyPr/>
+          <a:p/>
+        </p:txBody>
       </p:sp>
       <p:sp>
         <p:nvSpPr>
@@ -7315,7 +7737,7 @@
           </a:prstGeom>
           <a:extLst>
             <a:ext uri="{C572A759-6A51-4108-AA02-DFA0A04FC94B}">
-              <ma14:wrappingTextBoxFlag xmlns:ma14="http://schemas.microsoft.com/office/mac/drawingml/2011/main" xmlns="" val="0"/>
+              <ma14:wrappingTextBoxFlag xmlns="" xmlns:ma14="http://schemas.microsoft.com/office/mac/drawingml/2011/main" val="0"/>
             </a:ext>
           </a:extLst>
         </p:spPr>
@@ -7345,6 +7767,13 @@
   <p:clrMapOvr>
     <a:masterClrMapping/>
   </p:clrMapOvr>
+  <p:timing>
+    <p:tnLst>
+      <p:par>
+        <p:cTn id="1" dur="indefinite" restart="never" nodeType="tmRoot"/>
+      </p:par>
+    </p:tnLst>
+  </p:timing>
 </p:sld>
 </file>
 
@@ -7430,6 +7859,10 @@
             <a:prstDash val="solid"/>
           </a:ln>
         </p:spPr>
+        <p:txBody>
+          <a:bodyPr/>
+          <a:p/>
+        </p:txBody>
       </p:sp>
       <p:sp>
         <p:nvSpPr>
@@ -7455,6 +7888,10 @@
             <a:prstDash val="solid"/>
           </a:ln>
         </p:spPr>
+        <p:txBody>
+          <a:bodyPr/>
+          <a:p/>
+        </p:txBody>
       </p:sp>
       <p:sp>
         <p:nvSpPr>
@@ -7588,6 +8025,10 @@
             <a:prstDash val="solid"/>
           </a:ln>
         </p:spPr>
+        <p:txBody>
+          <a:bodyPr/>
+          <a:p/>
+        </p:txBody>
       </p:sp>
       <p:sp>
         <p:nvSpPr>
@@ -7721,6 +8162,10 @@
             <a:prstDash val="solid"/>
           </a:ln>
         </p:spPr>
+        <p:txBody>
+          <a:bodyPr/>
+          <a:p/>
+        </p:txBody>
       </p:sp>
       <p:sp>
         <p:nvSpPr>
@@ -7854,6 +8299,10 @@
             <a:prstDash val="solid"/>
           </a:ln>
         </p:spPr>
+        <p:txBody>
+          <a:bodyPr/>
+          <a:p/>
+        </p:txBody>
       </p:sp>
       <p:sp>
         <p:nvSpPr>
@@ -7987,6 +8436,10 @@
             <a:prstDash val="solid"/>
           </a:ln>
         </p:spPr>
+        <p:txBody>
+          <a:bodyPr/>
+          <a:p/>
+        </p:txBody>
       </p:sp>
       <p:sp>
         <p:nvSpPr>
@@ -8116,7 +8569,7 @@
           </a:prstGeom>
           <a:extLst>
             <a:ext uri="{C572A759-6A51-4108-AA02-DFA0A04FC94B}">
-              <ma14:wrappingTextBoxFlag xmlns:ma14="http://schemas.microsoft.com/office/mac/drawingml/2011/main" xmlns="" val="0"/>
+              <ma14:wrappingTextBoxFlag xmlns="" xmlns:ma14="http://schemas.microsoft.com/office/mac/drawingml/2011/main" val="0"/>
             </a:ext>
           </a:extLst>
         </p:spPr>
@@ -8146,6 +8599,13 @@
   <p:clrMapOvr>
     <a:masterClrMapping/>
   </p:clrMapOvr>
+  <p:timing>
+    <p:tnLst>
+      <p:par>
+        <p:cTn id="1" dur="indefinite" restart="never" nodeType="tmRoot"/>
+      </p:par>
+    </p:tnLst>
+  </p:timing>
 </p:sld>
 </file>
 
@@ -8179,7 +8639,7 @@
         <p:spPr>
           <a:xfrm>
             <a:off x="548640" y="365760"/>
-            <a:ext cx="11094415" cy="822960"/>
+            <a:ext cx="11094415" cy="978408"/>
           </a:xfrm>
           <a:prstGeom prst="rect">
             <a:avLst/>
@@ -8195,7 +8655,7 @@
               <a:buNone/>
             </a:pPr>
             <a:r>
-              <a:rPr lang="en-US" sz="3400" b="1" dirty="0">
+              <a:rPr lang="en-US" sz="3400" b="1" dirty="0" err="1" smtClean="0">
                 <a:solidFill>
                   <a:schemeClr val="tx2"/>
                 </a:solidFill>
@@ -8203,7 +8663,50 @@
                 <a:ea typeface="Cambria" pitchFamily="34" charset="-122"/>
                 <a:cs typeface="Cambria" pitchFamily="34" charset="-120"/>
               </a:rPr>
-              <a:t>Clean Architecture: las reglas no dependen de nada</a:t>
+              <a:t>Arquitectura</a:t>
+            </a:r>
+            <a:r>
+              <a:rPr lang="en-US" sz="3400" b="1" dirty="0" smtClean="0">
+                <a:solidFill>
+                  <a:schemeClr val="tx2"/>
+                </a:solidFill>
+                <a:latin typeface="Cambria" pitchFamily="34" charset="0"/>
+                <a:ea typeface="Cambria" pitchFamily="34" charset="-122"/>
+                <a:cs typeface="Cambria" pitchFamily="34" charset="-120"/>
+              </a:rPr>
+              <a:t/>
+            </a:r>
+            <a:br>
+              <a:rPr lang="en-US" sz="3400" b="1" dirty="0" smtClean="0">
+                <a:solidFill>
+                  <a:schemeClr val="tx2"/>
+                </a:solidFill>
+                <a:latin typeface="Cambria" pitchFamily="34" charset="0"/>
+                <a:ea typeface="Cambria" pitchFamily="34" charset="-122"/>
+                <a:cs typeface="Cambria" pitchFamily="34" charset="-120"/>
+              </a:rPr>
+            </a:br>
+            <a:r>
+              <a:rPr lang="en-US" sz="3400" b="1" dirty="0" smtClean="0">
+                <a:solidFill>
+                  <a:schemeClr val="tx2"/>
+                </a:solidFill>
+                <a:latin typeface="Cambria" pitchFamily="34" charset="0"/>
+                <a:ea typeface="Cambria" pitchFamily="34" charset="-122"/>
+                <a:cs typeface="Cambria" pitchFamily="34" charset="-120"/>
+              </a:rPr>
+              <a:t>Clean </a:t>
+            </a:r>
+            <a:r>
+              <a:rPr lang="en-US" sz="3400" b="1" dirty="0">
+                <a:solidFill>
+                  <a:schemeClr val="tx2"/>
+                </a:solidFill>
+                <a:latin typeface="Cambria" pitchFamily="34" charset="0"/>
+                <a:ea typeface="Cambria" pitchFamily="34" charset="-122"/>
+                <a:cs typeface="Cambria" pitchFamily="34" charset="-120"/>
+              </a:rPr>
+              <a:t>Architecture: las reglas no dependen de nada</a:t>
             </a:r>
             <a:endParaRPr lang="en-US" sz="3400" dirty="0"/>
           </a:p>
@@ -8235,6 +8738,10 @@
             <a:prstDash val="solid"/>
           </a:ln>
         </p:spPr>
+        <p:txBody>
+          <a:bodyPr/>
+          <a:p/>
+        </p:txBody>
       </p:sp>
       <p:sp>
         <p:nvSpPr>
@@ -8334,6 +8841,10 @@
             <a:prstDash val="solid"/>
           </a:ln>
         </p:spPr>
+        <p:txBody>
+          <a:bodyPr/>
+          <a:p/>
+        </p:txBody>
       </p:sp>
       <p:sp>
         <p:nvSpPr>
@@ -8433,6 +8944,10 @@
             <a:prstDash val="solid"/>
           </a:ln>
         </p:spPr>
+        <p:txBody>
+          <a:bodyPr/>
+          <a:p/>
+        </p:txBody>
       </p:sp>
       <p:sp>
         <p:nvSpPr>
@@ -8532,6 +9047,10 @@
             <a:prstDash val="solid"/>
           </a:ln>
         </p:spPr>
+        <p:txBody>
+          <a:bodyPr/>
+          <a:p/>
+        </p:txBody>
       </p:sp>
       <p:sp>
         <p:nvSpPr>
@@ -8631,6 +9150,10 @@
             <a:prstDash val="solid"/>
           </a:ln>
         </p:spPr>
+        <p:txBody>
+          <a:bodyPr/>
+          <a:p/>
+        </p:txBody>
       </p:sp>
       <p:sp>
         <p:nvSpPr>
@@ -8782,7 +9305,7 @@
           </a:prstGeom>
           <a:extLst>
             <a:ext uri="{C572A759-6A51-4108-AA02-DFA0A04FC94B}">
-              <ma14:wrappingTextBoxFlag xmlns:ma14="http://schemas.microsoft.com/office/mac/drawingml/2011/main" xmlns="" val="0"/>
+              <ma14:wrappingTextBoxFlag xmlns="" xmlns:ma14="http://schemas.microsoft.com/office/mac/drawingml/2011/main" val="0"/>
             </a:ext>
           </a:extLst>
         </p:spPr>
@@ -8812,6 +9335,13 @@
   <p:clrMapOvr>
     <a:masterClrMapping/>
   </p:clrMapOvr>
+  <p:timing>
+    <p:tnLst>
+      <p:par>
+        <p:cTn id="1" dur="indefinite" restart="never" nodeType="tmRoot"/>
+      </p:par>
+    </p:tnLst>
+  </p:timing>
 </p:sld>
 </file>
 
@@ -8861,7 +9391,7 @@
               <a:buNone/>
             </a:pPr>
             <a:r>
-              <a:rPr lang="en-US" sz="3400" b="1" dirty="0">
+              <a:rPr lang="en-US" sz="3400" b="1" dirty="0" err="1" smtClean="0">
                 <a:solidFill>
                   <a:schemeClr val="tx2"/>
                 </a:solidFill>
@@ -8869,7 +9399,83 @@
                 <a:ea typeface="Cambria" pitchFamily="34" charset="-122"/>
                 <a:cs typeface="Cambria" pitchFamily="34" charset="-120"/>
               </a:rPr>
-              <a:t>Siete decisiones registradas como ADR</a:t>
+              <a:t>Siete</a:t>
+            </a:r>
+            <a:r>
+              <a:rPr lang="en-US" sz="3400" b="1" dirty="0" smtClean="0">
+                <a:solidFill>
+                  <a:schemeClr val="tx2"/>
+                </a:solidFill>
+                <a:latin typeface="Cambria" pitchFamily="34" charset="0"/>
+                <a:ea typeface="Cambria" pitchFamily="34" charset="-122"/>
+                <a:cs typeface="Cambria" pitchFamily="34" charset="-120"/>
+              </a:rPr>
+              <a:t> ADR (</a:t>
+            </a:r>
+            <a:r>
+              <a:rPr lang="en-US" sz="3400" b="1" dirty="0" err="1" smtClean="0">
+                <a:solidFill>
+                  <a:schemeClr val="tx2"/>
+                </a:solidFill>
+                <a:latin typeface="Cambria" pitchFamily="34" charset="0"/>
+                <a:ea typeface="Cambria" pitchFamily="34" charset="-122"/>
+                <a:cs typeface="Cambria" pitchFamily="34" charset="-120"/>
+              </a:rPr>
+              <a:t>Architecture</a:t>
+            </a:r>
+            <a:r>
+              <a:rPr lang="en-US" sz="3400" b="1" dirty="0" smtClean="0">
+                <a:solidFill>
+                  <a:schemeClr val="tx2"/>
+                </a:solidFill>
+                <a:latin typeface="Cambria" pitchFamily="34" charset="0"/>
+                <a:ea typeface="Cambria" pitchFamily="34" charset="-122"/>
+                <a:cs typeface="Cambria" pitchFamily="34" charset="-120"/>
+              </a:rPr>
+              <a:t> Decision Record)</a:t>
+            </a:r>
+            <a:br>
+              <a:rPr lang="en-US" sz="3400" b="1" dirty="0" smtClean="0">
+                <a:solidFill>
+                  <a:schemeClr val="tx2"/>
+                </a:solidFill>
+                <a:latin typeface="Cambria" pitchFamily="34" charset="0"/>
+                <a:ea typeface="Cambria" pitchFamily="34" charset="-122"/>
+                <a:cs typeface="Cambria" pitchFamily="34" charset="-120"/>
+              </a:rPr>
+            </a:br>
+            <a:r>
+              <a:rPr lang="en-US" sz="3400" b="1" dirty="0" err="1" smtClean="0">
+                <a:solidFill>
+                  <a:schemeClr val="tx2"/>
+                </a:solidFill>
+                <a:latin typeface="Cambria" pitchFamily="34" charset="0"/>
+                <a:ea typeface="Cambria" pitchFamily="34" charset="-122"/>
+                <a:cs typeface="Cambria" pitchFamily="34" charset="-120"/>
+              </a:rPr>
+              <a:t>Siete</a:t>
+            </a:r>
+            <a:r>
+              <a:rPr lang="en-US" sz="3400" b="1" dirty="0" smtClean="0">
+                <a:solidFill>
+                  <a:schemeClr val="tx2"/>
+                </a:solidFill>
+                <a:latin typeface="Cambria" pitchFamily="34" charset="0"/>
+                <a:ea typeface="Cambria" pitchFamily="34" charset="-122"/>
+                <a:cs typeface="Cambria" pitchFamily="34" charset="-120"/>
+              </a:rPr>
+              <a:t> </a:t>
+            </a:r>
+            <a:r>
+              <a:rPr lang="en-US" sz="3400" b="1" dirty="0">
+                <a:solidFill>
+                  <a:schemeClr val="tx2"/>
+                </a:solidFill>
+                <a:latin typeface="Cambria" pitchFamily="34" charset="0"/>
+                <a:ea typeface="Cambria" pitchFamily="34" charset="-122"/>
+                <a:cs typeface="Cambria" pitchFamily="34" charset="-120"/>
+              </a:rPr>
+              <a:t>decisiones registradas como ADR</a:t>
             </a:r>
             <a:endParaRPr lang="en-US" sz="3400" dirty="0"/>
           </a:p>
@@ -8901,6 +9507,10 @@
             <a:prstDash val="solid"/>
           </a:ln>
         </p:spPr>
+        <p:txBody>
+          <a:bodyPr/>
+          <a:p/>
+        </p:txBody>
       </p:sp>
       <p:sp>
         <p:nvSpPr>
@@ -9036,6 +9646,10 @@
             <a:prstDash val="solid"/>
           </a:ln>
         </p:spPr>
+        <p:txBody>
+          <a:bodyPr/>
+          <a:p/>
+        </p:txBody>
       </p:sp>
       <p:sp>
         <p:nvSpPr>
@@ -9171,6 +9785,10 @@
             <a:prstDash val="solid"/>
           </a:ln>
         </p:spPr>
+        <p:txBody>
+          <a:bodyPr/>
+          <a:p/>
+        </p:txBody>
       </p:sp>
       <p:sp>
         <p:nvSpPr>
@@ -9306,6 +9924,10 @@
             <a:prstDash val="solid"/>
           </a:ln>
         </p:spPr>
+        <p:txBody>
+          <a:bodyPr/>
+          <a:p/>
+        </p:txBody>
       </p:sp>
       <p:sp>
         <p:nvSpPr>
@@ -9441,6 +10063,10 @@
             <a:prstDash val="solid"/>
           </a:ln>
         </p:spPr>
+        <p:txBody>
+          <a:bodyPr/>
+          <a:p/>
+        </p:txBody>
       </p:sp>
       <p:sp>
         <p:nvSpPr>
@@ -9576,6 +10202,10 @@
             <a:prstDash val="solid"/>
           </a:ln>
         </p:spPr>
+        <p:txBody>
+          <a:bodyPr/>
+          <a:p/>
+        </p:txBody>
       </p:sp>
       <p:sp>
         <p:nvSpPr>
@@ -9705,7 +10335,7 @@
           </a:prstGeom>
           <a:extLst>
             <a:ext uri="{C572A759-6A51-4108-AA02-DFA0A04FC94B}">
-              <ma14:wrappingTextBoxFlag xmlns:ma14="http://schemas.microsoft.com/office/mac/drawingml/2011/main" xmlns="" val="0"/>
+              <ma14:wrappingTextBoxFlag xmlns="" xmlns:ma14="http://schemas.microsoft.com/office/mac/drawingml/2011/main" val="0"/>
             </a:ext>
           </a:extLst>
         </p:spPr>
@@ -9756,6 +10386,10 @@
             <a:prstDash val="solid"/>
           </a:ln>
         </p:spPr>
+        <p:txBody>
+          <a:bodyPr/>
+          <a:p/>
+        </p:txBody>
       </p:sp>
       <p:sp>
         <p:nvSpPr>
@@ -9906,6 +10540,13 @@
   <p:clrMapOvr>
     <a:masterClrMapping/>
   </p:clrMapOvr>
+  <p:timing>
+    <p:tnLst>
+      <p:par>
+        <p:cTn id="1" dur="indefinite" restart="never" nodeType="tmRoot"/>
+      </p:par>
+    </p:tnLst>
+  </p:timing>
 </p:sld>
 </file>
 
@@ -9955,7 +10596,7 @@
               <a:buNone/>
             </a:pPr>
             <a:r>
-              <a:rPr lang="en-US" sz="3400" b="1" dirty="0">
+              <a:rPr lang="en-US" sz="3400" b="1" dirty="0" err="1" smtClean="0">
                 <a:solidFill>
                   <a:schemeClr val="tx2"/>
                 </a:solidFill>
@@ -9963,7 +10604,50 @@
                 <a:ea typeface="Cambria" pitchFamily="34" charset="-122"/>
                 <a:cs typeface="Cambria" pitchFamily="34" charset="-120"/>
               </a:rPr>
-              <a:t>121 pruebas en verde y medidas que se pueden repetir</a:t>
+              <a:t>Calidad</a:t>
+            </a:r>
+            <a:r>
+              <a:rPr lang="en-US" sz="3400" b="1" dirty="0" smtClean="0">
+                <a:solidFill>
+                  <a:schemeClr val="tx2"/>
+                </a:solidFill>
+                <a:latin typeface="Cambria" pitchFamily="34" charset="0"/>
+                <a:ea typeface="Cambria" pitchFamily="34" charset="-122"/>
+                <a:cs typeface="Cambria" pitchFamily="34" charset="-120"/>
+              </a:rPr>
+              <a:t/>
+            </a:r>
+            <a:br>
+              <a:rPr lang="en-US" sz="3400" b="1" dirty="0" smtClean="0">
+                <a:solidFill>
+                  <a:schemeClr val="tx2"/>
+                </a:solidFill>
+                <a:latin typeface="Cambria" pitchFamily="34" charset="0"/>
+                <a:ea typeface="Cambria" pitchFamily="34" charset="-122"/>
+                <a:cs typeface="Cambria" pitchFamily="34" charset="-120"/>
+              </a:rPr>
+            </a:br>
+            <a:r>
+              <a:rPr lang="en-US" sz="3400" b="1" dirty="0" smtClean="0">
+                <a:solidFill>
+                  <a:schemeClr val="tx2"/>
+                </a:solidFill>
+                <a:latin typeface="Cambria" pitchFamily="34" charset="0"/>
+                <a:ea typeface="Cambria" pitchFamily="34" charset="-122"/>
+                <a:cs typeface="Cambria" pitchFamily="34" charset="-120"/>
+              </a:rPr>
+              <a:t>121 </a:t>
+            </a:r>
+            <a:r>
+              <a:rPr lang="en-US" sz="3400" b="1" dirty="0">
+                <a:solidFill>
+                  <a:schemeClr val="tx2"/>
+                </a:solidFill>
+                <a:latin typeface="Cambria" pitchFamily="34" charset="0"/>
+                <a:ea typeface="Cambria" pitchFamily="34" charset="-122"/>
+                <a:cs typeface="Cambria" pitchFamily="34" charset="-120"/>
+              </a:rPr>
+              <a:t>pruebas en verde y medidas que se pueden repetir</a:t>
             </a:r>
             <a:endParaRPr lang="en-US" sz="3400" dirty="0"/>
           </a:p>
@@ -10523,7 +11207,7 @@
           </a:prstGeom>
           <a:extLst>
             <a:ext uri="{C572A759-6A51-4108-AA02-DFA0A04FC94B}">
-              <ma14:wrappingTextBoxFlag xmlns:ma14="http://schemas.microsoft.com/office/mac/drawingml/2011/main" xmlns="" val="0"/>
+              <ma14:wrappingTextBoxFlag xmlns="" xmlns:ma14="http://schemas.microsoft.com/office/mac/drawingml/2011/main" val="0"/>
             </a:ext>
           </a:extLst>
         </p:spPr>
@@ -10553,6 +11237,13 @@
   <p:clrMapOvr>
     <a:masterClrMapping/>
   </p:clrMapOvr>
+  <p:timing>
+    <p:tnLst>
+      <p:par>
+        <p:cTn id="1" dur="indefinite" restart="never" nodeType="tmRoot"/>
+      </p:par>
+    </p:tnLst>
+  </p:timing>
 </p:sld>
 </file>
 
@@ -10602,7 +11293,7 @@
               <a:buNone/>
             </a:pPr>
             <a:r>
-              <a:rPr lang="en-US" sz="3400" b="1" dirty="0">
+              <a:rPr lang="en-US" sz="3400" b="1" dirty="0" err="1" smtClean="0">
                 <a:solidFill>
                   <a:schemeClr val="tx2"/>
                 </a:solidFill>
@@ -10610,7 +11301,50 @@
                 <a:ea typeface="Cambria" pitchFamily="34" charset="-122"/>
                 <a:cs typeface="Cambria" pitchFamily="34" charset="-120"/>
               </a:rPr>
-              <a:t>La IA propone; la revisión decide</a:t>
+              <a:t>Uso</a:t>
+            </a:r>
+            <a:r>
+              <a:rPr lang="en-US" sz="3400" b="1" dirty="0" smtClean="0">
+                <a:solidFill>
+                  <a:schemeClr val="tx2"/>
+                </a:solidFill>
+                <a:latin typeface="Cambria" pitchFamily="34" charset="0"/>
+                <a:ea typeface="Cambria" pitchFamily="34" charset="-122"/>
+                <a:cs typeface="Cambria" pitchFamily="34" charset="-120"/>
+              </a:rPr>
+              <a:t> de la IA</a:t>
+            </a:r>
+            <a:br>
+              <a:rPr lang="en-US" sz="3400" b="1" dirty="0" smtClean="0">
+                <a:solidFill>
+                  <a:schemeClr val="tx2"/>
+                </a:solidFill>
+                <a:latin typeface="Cambria" pitchFamily="34" charset="0"/>
+                <a:ea typeface="Cambria" pitchFamily="34" charset="-122"/>
+                <a:cs typeface="Cambria" pitchFamily="34" charset="-120"/>
+              </a:rPr>
+            </a:br>
+            <a:r>
+              <a:rPr lang="en-US" sz="3400" b="1" dirty="0" smtClean="0">
+                <a:solidFill>
+                  <a:schemeClr val="tx2"/>
+                </a:solidFill>
+                <a:latin typeface="Cambria" pitchFamily="34" charset="0"/>
+                <a:ea typeface="Cambria" pitchFamily="34" charset="-122"/>
+                <a:cs typeface="Cambria" pitchFamily="34" charset="-120"/>
+              </a:rPr>
+              <a:t>La </a:t>
+            </a:r>
+            <a:r>
+              <a:rPr lang="en-US" sz="3400" b="1" dirty="0">
+                <a:solidFill>
+                  <a:schemeClr val="tx2"/>
+                </a:solidFill>
+                <a:latin typeface="Cambria" pitchFamily="34" charset="0"/>
+                <a:ea typeface="Cambria" pitchFamily="34" charset="-122"/>
+                <a:cs typeface="Cambria" pitchFamily="34" charset="-120"/>
+              </a:rPr>
+              <a:t>IA propone; la revisión decide</a:t>
             </a:r>
             <a:endParaRPr lang="en-US" sz="3400" dirty="0"/>
           </a:p>
@@ -10717,6 +11451,10 @@
             <a:prstDash val="solid"/>
           </a:ln>
         </p:spPr>
+        <p:txBody>
+          <a:bodyPr/>
+          <a:p/>
+        </p:txBody>
       </p:sp>
       <p:sp>
         <p:nvSpPr>
@@ -10742,6 +11480,10 @@
             <a:prstDash val="solid"/>
           </a:ln>
         </p:spPr>
+        <p:txBody>
+          <a:bodyPr/>
+          <a:p/>
+        </p:txBody>
       </p:sp>
       <p:sp>
         <p:nvSpPr>
@@ -10869,6 +11611,10 @@
             <a:prstDash val="solid"/>
           </a:ln>
         </p:spPr>
+        <p:txBody>
+          <a:bodyPr/>
+          <a:p/>
+        </p:txBody>
       </p:sp>
       <p:sp>
         <p:nvSpPr>
@@ -10894,6 +11640,10 @@
             <a:prstDash val="solid"/>
           </a:ln>
         </p:spPr>
+        <p:txBody>
+          <a:bodyPr/>
+          <a:p/>
+        </p:txBody>
       </p:sp>
       <p:sp>
         <p:nvSpPr>
@@ -11021,6 +11771,10 @@
             <a:prstDash val="solid"/>
           </a:ln>
         </p:spPr>
+        <p:txBody>
+          <a:bodyPr/>
+          <a:p/>
+        </p:txBody>
       </p:sp>
       <p:sp>
         <p:nvSpPr>
@@ -11046,6 +11800,10 @@
             <a:prstDash val="solid"/>
           </a:ln>
         </p:spPr>
+        <p:txBody>
+          <a:bodyPr/>
+          <a:p/>
+        </p:txBody>
       </p:sp>
       <p:sp>
         <p:nvSpPr>
@@ -11173,6 +11931,10 @@
             <a:prstDash val="solid"/>
           </a:ln>
         </p:spPr>
+        <p:txBody>
+          <a:bodyPr/>
+          <a:p/>
+        </p:txBody>
       </p:sp>
       <p:sp>
         <p:nvSpPr>
@@ -11198,6 +11960,10 @@
             <a:prstDash val="solid"/>
           </a:ln>
         </p:spPr>
+        <p:txBody>
+          <a:bodyPr/>
+          <a:p/>
+        </p:txBody>
       </p:sp>
       <p:sp>
         <p:nvSpPr>
@@ -11319,7 +12085,7 @@
           </a:prstGeom>
           <a:extLst>
             <a:ext uri="{C572A759-6A51-4108-AA02-DFA0A04FC94B}">
-              <ma14:wrappingTextBoxFlag xmlns:ma14="http://schemas.microsoft.com/office/mac/drawingml/2011/main" xmlns="" val="0"/>
+              <ma14:wrappingTextBoxFlag xmlns="" xmlns:ma14="http://schemas.microsoft.com/office/mac/drawingml/2011/main" val="0"/>
             </a:ext>
           </a:extLst>
         </p:spPr>
@@ -11349,6 +12115,13 @@
   <p:clrMapOvr>
     <a:masterClrMapping/>
   </p:clrMapOvr>
+  <p:timing>
+    <p:tnLst>
+      <p:par>
+        <p:cTn id="1" dur="indefinite" restart="never" nodeType="tmRoot"/>
+      </p:par>
+    </p:tnLst>
+  </p:timing>
 </p:sld>
 </file>
 

</xml_diff>